<commit_message>
Strategy slides: combine allocation and Monte Carlo into one page
Co-Authored-By: Claude Opus 5.5 <noreply@anthropic.com>
Claude-Session: https://claude.ai/code/session_01Rwoh8cFDQqLD8JWT3mee6y
</commit_message>
<xml_diff>
--- a/strategy/Strategy-Slides.pptx
+++ b/strategy/Strategy-Slides.pptx
@@ -7,10 +7,9 @@
   <p:sldIdLst>
     <p:sldId id="256" r:id="rId2"/>
     <p:sldId id="257" r:id="rId3"/>
-    <p:sldId id="258" r:id="rId4"/>
   </p:sldIdLst>
   <p:notesMasterIdLst>
-    <p:notesMasterId r:id="rId5"/>
+    <p:notesMasterId r:id="rId4"/>
   </p:notesMasterIdLst>
   <p:sldSz cx="12192000" cy="6858000"/>
   <p:notesSz cx="6858000" cy="12192000"/>
@@ -199,16 +198,16 @@
           <c:dLbls>
             <c:dLbl>
               <c:idx val="0"/>
-              <c:numFmt formatCode="0&quot;%&quot;" sourceLinked="0"/>
+              <c:numFmt formatCode="General" sourceLinked="0"/>
               <c:spPr/>
               <c:txPr>
                 <a:bodyPr/>
                 <a:lstStyle/>
                 <a:p>
                   <a:pPr>
-                    <a:defRPr sz="1100" b="1" i="0" u="none" strike="noStrike">
-                      <a:solidFill>
-                        <a:srgbClr val="FFFFFF"/>
+                    <a:defRPr sz="1200" b="0" i="0" u="none" strike="noStrike">
+                      <a:solidFill>
+                        <a:srgbClr val="000000"/>
                       </a:solidFill>
                       <a:latin typeface="Arial"/>
                     </a:defRPr>
@@ -216,7 +215,7 @@
                 </a:p>
               </c:txPr>
               <c:showLegendKey val="0"/>
-              <c:showVal val="1"/>
+              <c:showVal val="0"/>
               <c:showCatName val="0"/>
               <c:showSerName val="0"/>
               <c:showPercent val="0"/>
@@ -224,16 +223,16 @@
             </c:dLbl>
             <c:dLbl>
               <c:idx val="1"/>
-              <c:numFmt formatCode="0&quot;%&quot;" sourceLinked="0"/>
+              <c:numFmt formatCode="General" sourceLinked="0"/>
               <c:spPr/>
               <c:txPr>
                 <a:bodyPr/>
                 <a:lstStyle/>
                 <a:p>
                   <a:pPr>
-                    <a:defRPr sz="1100" b="1" i="0" u="none" strike="noStrike">
-                      <a:solidFill>
-                        <a:srgbClr val="FFFFFF"/>
+                    <a:defRPr sz="1200" b="0" i="0" u="none" strike="noStrike">
+                      <a:solidFill>
+                        <a:srgbClr val="000000"/>
                       </a:solidFill>
                       <a:latin typeface="Arial"/>
                     </a:defRPr>
@@ -241,7 +240,7 @@
                 </a:p>
               </c:txPr>
               <c:showLegendKey val="0"/>
-              <c:showVal val="1"/>
+              <c:showVal val="0"/>
               <c:showCatName val="0"/>
               <c:showSerName val="0"/>
               <c:showPercent val="0"/>
@@ -249,16 +248,16 @@
             </c:dLbl>
             <c:dLbl>
               <c:idx val="2"/>
-              <c:numFmt formatCode="0&quot;%&quot;" sourceLinked="0"/>
+              <c:numFmt formatCode="General" sourceLinked="0"/>
               <c:spPr/>
               <c:txPr>
                 <a:bodyPr/>
                 <a:lstStyle/>
                 <a:p>
                   <a:pPr>
-                    <a:defRPr sz="1100" b="1" i="0" u="none" strike="noStrike">
-                      <a:solidFill>
-                        <a:srgbClr val="FFFFFF"/>
+                    <a:defRPr sz="1200" b="0" i="0" u="none" strike="noStrike">
+                      <a:solidFill>
+                        <a:srgbClr val="000000"/>
                       </a:solidFill>
                       <a:latin typeface="Arial"/>
                     </a:defRPr>
@@ -266,7 +265,7 @@
                 </a:p>
               </c:txPr>
               <c:showLegendKey val="0"/>
-              <c:showVal val="1"/>
+              <c:showVal val="0"/>
               <c:showCatName val="0"/>
               <c:showSerName val="0"/>
               <c:showPercent val="0"/>
@@ -274,16 +273,16 @@
             </c:dLbl>
             <c:dLbl>
               <c:idx val="3"/>
-              <c:numFmt formatCode="0&quot;%&quot;" sourceLinked="0"/>
+              <c:numFmt formatCode="General" sourceLinked="0"/>
               <c:spPr/>
               <c:txPr>
                 <a:bodyPr/>
                 <a:lstStyle/>
                 <a:p>
                   <a:pPr>
-                    <a:defRPr sz="1100" b="1" i="0" u="none" strike="noStrike">
-                      <a:solidFill>
-                        <a:srgbClr val="FFFFFF"/>
+                    <a:defRPr sz="1200" b="0" i="0" u="none" strike="noStrike">
+                      <a:solidFill>
+                        <a:srgbClr val="000000"/>
                       </a:solidFill>
                       <a:latin typeface="Arial"/>
                     </a:defRPr>
@@ -291,7 +290,7 @@
                 </a:p>
               </c:txPr>
               <c:showLegendKey val="0"/>
-              <c:showVal val="1"/>
+              <c:showVal val="0"/>
               <c:showCatName val="0"/>
               <c:showSerName val="0"/>
               <c:showPercent val="0"/>
@@ -299,16 +298,16 @@
             </c:dLbl>
             <c:dLbl>
               <c:idx val="4"/>
-              <c:numFmt formatCode="0&quot;%&quot;" sourceLinked="0"/>
+              <c:numFmt formatCode="General" sourceLinked="0"/>
               <c:spPr/>
               <c:txPr>
                 <a:bodyPr/>
                 <a:lstStyle/>
                 <a:p>
                   <a:pPr>
-                    <a:defRPr sz="1100" b="1" i="0" u="none" strike="noStrike">
-                      <a:solidFill>
-                        <a:srgbClr val="FFFFFF"/>
+                    <a:defRPr sz="1200" b="0" i="0" u="none" strike="noStrike">
+                      <a:solidFill>
+                        <a:srgbClr val="000000"/>
                       </a:solidFill>
                       <a:latin typeface="Arial"/>
                     </a:defRPr>
@@ -316,19 +315,19 @@
                 </a:p>
               </c:txPr>
               <c:showLegendKey val="0"/>
-              <c:showVal val="1"/>
+              <c:showVal val="0"/>
               <c:showCatName val="0"/>
               <c:showSerName val="0"/>
               <c:showPercent val="0"/>
               <c:showBubbleSize val="0"/>
             </c:dLbl>
-            <c:numFmt formatCode="0&quot;%&quot;" sourceLinked="0"/>
+            <c:numFmt formatCode="General" sourceLinked="0"/>
             <c:txPr>
               <a:bodyPr/>
               <a:lstStyle/>
               <a:p>
                 <a:pPr>
-                  <a:defRPr sz="1800" b="1" i="0" u="none" strike="noStrike">
+                  <a:defRPr sz="1800" b="0" i="0" u="none" strike="noStrike">
                     <a:solidFill>
                       <a:srgbClr val="000000"/>
                     </a:solidFill>
@@ -393,7 +392,7 @@
           </c:val>
         </c:ser>
         <c:firstSliceAng val="0"/>
-        <c:holeSize val="55"/>
+        <c:holeSize val="52"/>
       </c:doughnutChart>
       <c:spPr>
         <a:noFill/>
@@ -403,23 +402,6 @@
         <a:effectLst/>
       </c:spPr>
     </c:plotArea>
-    <c:legend>
-      <c:legendPos val="b"/>
-      <c:overlay val="0"/>
-      <c:txPr>
-        <a:bodyPr/>
-        <a:lstStyle/>
-        <a:p>
-          <a:pPr>
-            <a:defRPr sz="950">
-              <a:latin typeface="Arial"/>
-              <a:cs typeface="Arial"/>
-            </a:defRPr>
-          </a:pPr>
-          <a:endParaRPr lang="en-US"/>
-        </a:p>
-      </c:txPr>
-    </c:legend>
     <c:plotVisOnly val="1"/>
     <c:dispBlanksAs val="span"/>
   </c:chart>
@@ -961,94 +943,6 @@
 </p:notes>
 </file>
 
-<file path=ppt/notesSlides/notesSlide3.xml><?xml version="1.0" encoding="utf-8"?>
-<p:notes xmlns:a="http://schemas.openxmlformats.org/drawingml/2006/main" xmlns:r="http://schemas.openxmlformats.org/officeDocument/2006/relationships" xmlns:p="http://schemas.openxmlformats.org/presentationml/2006/main">
-  <p:cSld>
-    <p:spTree>
-      <p:nvGrpSpPr>
-        <p:cNvPr id="1" name=""/>
-        <p:cNvGrpSpPr/>
-        <p:nvPr/>
-      </p:nvGrpSpPr>
-      <p:grpSpPr>
-        <a:xfrm>
-          <a:off x="0" y="0"/>
-          <a:ext cx="0" cy="0"/>
-          <a:chOff x="0" y="0"/>
-          <a:chExt cx="0" cy="0"/>
-        </a:xfrm>
-      </p:grpSpPr>
-      <p:sp>
-        <p:nvSpPr>
-          <p:cNvPr id="2" name="Slide Image Placeholder 1"/>
-          <p:cNvSpPr>
-            <a:spLocks noGrp="1" noRot="1" noChangeAspect="1"/>
-          </p:cNvSpPr>
-          <p:nvPr>
-            <p:ph type="sldImg"/>
-          </p:nvPr>
-        </p:nvSpPr>
-        <p:spPr/>
-      </p:sp>
-      <p:sp>
-        <p:nvSpPr>
-          <p:cNvPr id="3" name="Notes Placeholder 2"/>
-          <p:cNvSpPr>
-            <a:spLocks noGrp="1"/>
-          </p:cNvSpPr>
-          <p:nvPr>
-            <p:ph type="body" idx="1"/>
-          </p:nvPr>
-        </p:nvSpPr>
-        <p:spPr/>
-        <p:txBody>
-          <a:bodyPr/>
-          <a:lstStyle/>
-          <a:p>
-            <a:r>
-              <a:rPr lang="en-US" dirty="0"/>
-              <a:t/>
-            </a:r>
-            <a:endParaRPr lang="en-US" dirty="0"/>
-          </a:p>
-        </p:txBody>
-      </p:sp>
-      <p:sp>
-        <p:nvSpPr>
-          <p:cNvPr id="4" name="Slide Number Placeholder 3"/>
-          <p:cNvSpPr>
-            <a:spLocks noGrp="1"/>
-          </p:cNvSpPr>
-          <p:nvPr>
-            <p:ph type="sldNum" sz="quarter" idx="10"/>
-          </p:nvPr>
-        </p:nvSpPr>
-        <p:spPr/>
-        <p:txBody>
-          <a:bodyPr/>
-          <a:lstStyle/>
-          <a:p>
-            <a:fld id="{F7021451-1387-4CA6-816F-3879F97B5CBC}" type="slidenum">
-              <a:rPr lang="en-US"/>
-              <a:t>3</a:t>
-            </a:fld>
-            <a:endParaRPr lang="en-US"/>
-          </a:p>
-        </p:txBody>
-      </p:sp>
-    </p:spTree>
-    <p:extLst>
-      <p:ext uri="{BB962C8B-B14F-4D97-AF65-F5344CB8AC3E}">
-        <p14:creationId xmlns:p14="http://schemas.microsoft.com/office/powerpoint/2010/main" val="1024086991"/>
-      </p:ext>
-    </p:extLst>
-  </p:cSld>
-  <p:clrMapOvr>
-    <a:masterClrMapping/>
-  </p:clrMapOvr>
-</p:notes>
-</file>
-
 <file path=ppt/slideLayouts/slideLayout1.xml><?xml version="1.0" encoding="utf-8"?>
 <p:sldLayout xmlns:a="http://schemas.openxmlformats.org/drawingml/2006/main" xmlns:r="http://schemas.openxmlformats.org/officeDocument/2006/relationships" xmlns:p="http://schemas.openxmlformats.org/presentationml/2006/main" preserve="1">
   <p:cSld name="DEFAULT">
@@ -1413,7 +1307,7 @@
                 <a:ea typeface="Arial" pitchFamily="34" charset="-122"/>
                 <a:cs typeface="Arial" pitchFamily="34" charset="-120"/>
               </a:rPr>
-              <a:t>Strategy: a five-ETF portfolio across Asia's AI-hardware chain</a:t>
+              <a:t>Strategy: five Asian AI-hardware ETFs, simulated over five years</a:t>
             </a:r>
             <a:endParaRPr lang="en-US" sz="2200" dirty="0"/>
           </a:p>
@@ -1640,38 +1534,47 @@
                 <a:ea typeface="Arial" pitchFamily="34" charset="-122"/>
                 <a:cs typeface="Arial" pitchFamily="34" charset="-120"/>
               </a:rPr>
-              <a:t>USD 100mn split across five Bloomberg-listed ETFs; half of it in the semiconductor core (3119 HK + 2644 JP)</a:t>
+              <a:t>USD 100mn across five Bloomberg-listed ETFs; Monte Carlo per USD 100,000 invested (×1,000 for the mandate)</a:t>
             </a:r>
             <a:endParaRPr lang="en-US" sz="1100" dirty="0"/>
           </a:p>
         </p:txBody>
       </p:sp>
-      <p:graphicFrame>
-        <p:nvGraphicFramePr>
-          <p:cNvPr id="10" name="Chart 0" descr=""/>
-          <p:cNvGraphicFramePr/>
-          <p:nvPr/>
-        </p:nvGraphicFramePr>
-        <p:xfrm>
-          <a:off x="457200" y="1371600"/>
-          <a:ext cx="3566160" cy="3566160"/>
-        </p:xfrm>
-        <a:graphic xmlns:a="http://schemas.openxmlformats.org/drawingml/2006/main">
-          <a:graphicData uri="http://schemas.openxmlformats.org/drawingml/2006/chart">
-            <c:chart xmlns:c="http://schemas.openxmlformats.org/drawingml/2006/chart" r:id="rId1"/>
-          </a:graphicData>
-        </a:graphic>
-      </p:graphicFrame>
       <p:sp>
         <p:nvSpPr>
-          <p:cNvPr id="11" name="Text 8"/>
+          <p:cNvPr id="10" name="Shape 8"/>
+          <p:cNvSpPr/>
+          <p:nvPr/>
+        </p:nvSpPr>
+        <p:spPr>
+          <a:xfrm>
+            <a:off x="457200" y="1325880"/>
+            <a:ext cx="3429000" cy="329184"/>
+          </a:xfrm>
+          <a:prstGeom prst="rect">
+            <a:avLst/>
+          </a:prstGeom>
+          <a:solidFill>
+            <a:srgbClr val="2C5F82"/>
+          </a:solidFill>
+          <a:ln w="12700">
+            <a:solidFill>
+              <a:srgbClr val="2C5F82"/>
+            </a:solidFill>
+            <a:prstDash val="solid"/>
+          </a:ln>
+        </p:spPr>
+      </p:sp>
+      <p:sp>
+        <p:nvSpPr>
+          <p:cNvPr id="11" name="Text 9"/>
           <p:cNvSpPr txBox="1"/>
           <p:nvPr/>
         </p:nvSpPr>
         <p:spPr>
           <a:xfrm>
-            <a:off x="1508760" y="2514600"/>
-            <a:ext cx="1463040" cy="640080"/>
+            <a:off x="457200" y="1325880"/>
+            <a:ext cx="3429000" cy="329184"/>
           </a:xfrm>
           <a:prstGeom prst="rect">
             <a:avLst/>
@@ -1687,15 +1590,70 @@
               <a:buNone/>
             </a:pPr>
             <a:r>
-              <a:rPr lang="en-US" sz="1600" b="1" dirty="0">
+              <a:rPr lang="en-US" sz="1150" b="1" dirty="0">
                 <a:solidFill>
-                  <a:srgbClr val="2C5F82"/>
+                  <a:srgbClr val="FFFFFF"/>
                 </a:solidFill>
                 <a:latin typeface="Arial" pitchFamily="34" charset="0"/>
                 <a:ea typeface="Arial" pitchFamily="34" charset="-122"/>
                 <a:cs typeface="Arial" pitchFamily="34" charset="-120"/>
               </a:rPr>
-              <a:t>USD 100mn</a:t>
+              <a:t>Allocation</a:t>
+            </a:r>
+            <a:endParaRPr lang="en-US" sz="1150" dirty="0"/>
+          </a:p>
+        </p:txBody>
+      </p:sp>
+      <p:graphicFrame>
+        <p:nvGraphicFramePr>
+          <p:cNvPr id="12" name="Chart 0" descr=""/>
+          <p:cNvGraphicFramePr/>
+          <p:nvPr/>
+        </p:nvGraphicFramePr>
+        <p:xfrm>
+          <a:off x="777240" y="1691640"/>
+          <a:ext cx="1874520" cy="1874520"/>
+        </p:xfrm>
+        <a:graphic xmlns:a="http://schemas.openxmlformats.org/drawingml/2006/main">
+          <a:graphicData uri="http://schemas.openxmlformats.org/drawingml/2006/chart">
+            <c:chart xmlns:c="http://schemas.openxmlformats.org/drawingml/2006/chart" r:id="rId1"/>
+          </a:graphicData>
+        </a:graphic>
+      </p:graphicFrame>
+      <p:sp>
+        <p:nvSpPr>
+          <p:cNvPr id="13" name="Text 10"/>
+          <p:cNvSpPr txBox="1"/>
+          <p:nvPr/>
+        </p:nvSpPr>
+        <p:spPr>
+          <a:xfrm>
+            <a:off x="1252728" y="2377440"/>
+            <a:ext cx="914400" cy="502920"/>
+          </a:xfrm>
+          <a:prstGeom prst="rect">
+            <a:avLst/>
+          </a:prstGeom>
+          <a:noFill/>
+          <a:ln/>
+        </p:spPr>
+        <p:txBody>
+          <a:bodyPr wrap="square" lIns="0" tIns="0" rIns="0" bIns="0" rtlCol="0" anchor="ctr"/>
+          <a:lstStyle/>
+          <a:p>
+            <a:pPr algn="ctr" indent="0" marL="0">
+              <a:buNone/>
+            </a:pPr>
+            <a:r>
+              <a:rPr lang="en-US" sz="900" dirty="0">
+                <a:solidFill>
+                  <a:srgbClr val="595959"/>
+                </a:solidFill>
+                <a:latin typeface="Arial" pitchFamily="34" charset="0"/>
+                <a:ea typeface="Arial" pitchFamily="34" charset="-122"/>
+                <a:cs typeface="Arial" pitchFamily="34" charset="-120"/>
+              </a:rPr>
+              <a:t>USD</a:t>
             </a:r>
             <a:endParaRPr lang="en-US" sz="1200" dirty="0"/>
           </a:p>
@@ -1704,17 +1662,73 @@
               <a:buNone/>
             </a:pPr>
             <a:r>
-              <a:rPr lang="en-US" sz="1000" dirty="0">
+              <a:rPr lang="en-US" sz="1300" b="1" dirty="0">
                 <a:solidFill>
-                  <a:srgbClr val="595959"/>
+                  <a:srgbClr val="2C5F82"/>
                 </a:solidFill>
                 <a:latin typeface="Arial" pitchFamily="34" charset="0"/>
                 <a:ea typeface="Arial" pitchFamily="34" charset="-122"/>
                 <a:cs typeface="Arial" pitchFamily="34" charset="-120"/>
               </a:rPr>
-              <a:t>5 ETFs</a:t>
+              <a:t>100mn</a:t>
             </a:r>
             <a:endParaRPr lang="en-US" sz="1200" dirty="0"/>
+          </a:p>
+        </p:txBody>
+      </p:sp>
+      <p:sp>
+        <p:nvSpPr>
+          <p:cNvPr id="14" name="Text 11"/>
+          <p:cNvSpPr txBox="1"/>
+          <p:nvPr/>
+        </p:nvSpPr>
+        <p:spPr>
+          <a:xfrm>
+            <a:off x="2743200" y="1874520"/>
+            <a:ext cx="1143000" cy="1554480"/>
+          </a:xfrm>
+          <a:prstGeom prst="rect">
+            <a:avLst/>
+          </a:prstGeom>
+          <a:noFill/>
+          <a:ln/>
+        </p:spPr>
+        <p:txBody>
+          <a:bodyPr wrap="square" lIns="0" tIns="0" rIns="0" bIns="0" rtlCol="0" anchor="t"/>
+          <a:lstStyle/>
+          <a:p>
+            <a:pPr indent="0" marL="0">
+              <a:buNone/>
+            </a:pPr>
+            <a:r>
+              <a:rPr lang="en-US" sz="850" b="1" dirty="0">
+                <a:solidFill>
+                  <a:srgbClr val="2C5F82"/>
+                </a:solidFill>
+                <a:latin typeface="Arial" pitchFamily="34" charset="0"/>
+                <a:ea typeface="Arial" pitchFamily="34" charset="-122"/>
+                <a:cs typeface="Arial" pitchFamily="34" charset="-120"/>
+              </a:rPr>
+              <a:t>Half in the semiconductor core</a:t>
+            </a:r>
+            <a:endParaRPr lang="en-US" sz="850" dirty="0"/>
+          </a:p>
+          <a:p>
+            <a:pPr indent="0" marL="0">
+              <a:buNone/>
+            </a:pPr>
+            <a:r>
+              <a:rPr lang="en-US" sz="850" dirty="0">
+                <a:solidFill>
+                  <a:srgbClr val="262626"/>
+                </a:solidFill>
+                <a:latin typeface="Arial" pitchFamily="34" charset="0"/>
+                <a:ea typeface="Arial" pitchFamily="34" charset="-122"/>
+                <a:cs typeface="Arial" pitchFamily="34" charset="-120"/>
+              </a:rPr>
+              <a:t>3119 HK + 2644 JP = 50%; Korea adds memory, Taiwan the foundry, 00878 the ESG income.</a:t>
+            </a:r>
+            <a:endParaRPr lang="en-US" sz="850" dirty="0"/>
           </a:p>
         </p:txBody>
       </p:sp>
@@ -1733,50 +1747,50 @@
           </p:nvPr>
         </p:nvGraphicFramePr>
         <p:xfrm>
-          <a:off x="4297680" y="1371600"/>
-          <a:ext cx="7434072" cy="914400"/>
+          <a:off x="457200" y="3703320"/>
+          <a:ext cx="3429000" cy="914400"/>
         </p:xfrm>
         <a:graphic>
           <a:graphicData uri="http://schemas.openxmlformats.org/drawingml/2006/table">
             <a:tbl>
               <a:tblPr/>
               <a:tblGrid>
-                <a:gridCol w="2743200"/>
-                <a:gridCol w="731520"/>
-                <a:gridCol w="731520"/>
-                <a:gridCol w="3227832"/>
+                <a:gridCol w="274320"/>
+                <a:gridCol w="777240"/>
+                <a:gridCol w="1828800"/>
+                <a:gridCol w="548640"/>
               </a:tblGrid>
-              <a:tr h="310896">
+              <a:tr h="329184">
                 <a:tc>
                   <a:txBody>
                     <a:bodyPr/>
                     <a:lstStyle/>
                     <a:p>
-                      <a:pPr indent="0" marL="0">
+                      <a:pPr algn="ctr" indent="0" marL="0">
                         <a:buNone/>
                       </a:pPr>
                       <a:r>
-                        <a:rPr lang="en-US" sz="950" b="1" dirty="0">
+                        <a:rPr lang="en-US" sz="1200" dirty="0">
                           <a:solidFill>
-                            <a:srgbClr val="FFFFFF"/>
+                            <a:srgbClr val="2C5F82"/>
                           </a:solidFill>
                           <a:latin typeface="Arial" pitchFamily="34" charset="0"/>
                           <a:ea typeface="Arial" pitchFamily="34" charset="-122"/>
                           <a:cs typeface="Arial" pitchFamily="34" charset="-120"/>
                         </a:rPr>
-                        <a:t>ETF (Bloomberg)</a:t>
+                        <a:t>■</a:t>
                       </a:r>
-                      <a:endParaRPr lang="en-US" sz="950" dirty="0">
+                      <a:endParaRPr lang="en-US" sz="1200" dirty="0">
                         <a:latin typeface="Arial" charset="0"/>
                         <a:ea typeface="Arial" charset="0"/>
                         <a:cs typeface="Arial" charset="0"/>
                       </a:endParaRPr>
                     </a:p>
                   </a:txBody>
-                  <a:tcPr marL="76200" marR="76200" marT="25400" marB="25400" anchor="ctr">
+                  <a:tcPr marL="50800" marR="50800" marT="12700" marB="12700" anchor="ctr">
                     <a:lnL w="6350" cap="flat" cmpd="sng" algn="ctr">
                       <a:solidFill>
-                        <a:srgbClr val="BFBFBF"/>
+                        <a:srgbClr val="E3E3E3"/>
                       </a:solidFill>
                       <a:prstDash val="solid"/>
                       <a:round/>
@@ -1785,7 +1799,7 @@
                     </a:lnL>
                     <a:lnR w="6350" cap="flat" cmpd="sng" algn="ctr">
                       <a:solidFill>
-                        <a:srgbClr val="BFBFBF"/>
+                        <a:srgbClr val="E3E3E3"/>
                       </a:solidFill>
                       <a:prstDash val="solid"/>
                       <a:round/>
@@ -1794,7 +1808,7 @@
                     </a:lnR>
                     <a:lnT w="6350" cap="flat" cmpd="sng" algn="ctr">
                       <a:solidFill>
-                        <a:srgbClr val="BFBFBF"/>
+                        <a:srgbClr val="E3E3E3"/>
                       </a:solidFill>
                       <a:prstDash val="solid"/>
                       <a:round/>
@@ -1803,7 +1817,7 @@
                     </a:lnT>
                     <a:lnB w="6350" cap="flat" cmpd="sng" algn="ctr">
                       <a:solidFill>
-                        <a:srgbClr val="BFBFBF"/>
+                        <a:srgbClr val="E3E3E3"/>
                       </a:solidFill>
                       <a:prstDash val="solid"/>
                       <a:round/>
@@ -1811,216 +1825,10 @@
                       <a:tailEnd type="none" w="med" len="med"/>
                     </a:lnB>
                     <a:solidFill>
-                      <a:srgbClr val="2C5F82"/>
+                      <a:srgbClr val="FFFFFF"/>
                     </a:solidFill>
                   </a:tcPr>
                 </a:tc>
-                <a:tc>
-                  <a:txBody>
-                    <a:bodyPr/>
-                    <a:lstStyle/>
-                    <a:p>
-                      <a:pPr indent="0" marL="0">
-                        <a:buNone/>
-                      </a:pPr>
-                      <a:r>
-                        <a:rPr lang="en-US" sz="950" b="1" dirty="0">
-                          <a:solidFill>
-                            <a:srgbClr val="FFFFFF"/>
-                          </a:solidFill>
-                          <a:latin typeface="Arial" pitchFamily="34" charset="0"/>
-                          <a:ea typeface="Arial" pitchFamily="34" charset="-122"/>
-                          <a:cs typeface="Arial" pitchFamily="34" charset="-120"/>
-                        </a:rPr>
-                        <a:t>Weight</a:t>
-                      </a:r>
-                      <a:endParaRPr lang="en-US" sz="950" dirty="0">
-                        <a:latin typeface="Arial" charset="0"/>
-                        <a:ea typeface="Arial" charset="0"/>
-                        <a:cs typeface="Arial" charset="0"/>
-                      </a:endParaRPr>
-                    </a:p>
-                  </a:txBody>
-                  <a:tcPr marL="76200" marR="76200" marT="25400" marB="25400" anchor="ctr">
-                    <a:lnL w="6350" cap="flat" cmpd="sng" algn="ctr">
-                      <a:solidFill>
-                        <a:srgbClr val="BFBFBF"/>
-                      </a:solidFill>
-                      <a:prstDash val="solid"/>
-                      <a:round/>
-                      <a:headEnd type="none" w="med" len="med"/>
-                      <a:tailEnd type="none" w="med" len="med"/>
-                    </a:lnL>
-                    <a:lnR w="6350" cap="flat" cmpd="sng" algn="ctr">
-                      <a:solidFill>
-                        <a:srgbClr val="BFBFBF"/>
-                      </a:solidFill>
-                      <a:prstDash val="solid"/>
-                      <a:round/>
-                      <a:headEnd type="none" w="med" len="med"/>
-                      <a:tailEnd type="none" w="med" len="med"/>
-                    </a:lnR>
-                    <a:lnT w="6350" cap="flat" cmpd="sng" algn="ctr">
-                      <a:solidFill>
-                        <a:srgbClr val="BFBFBF"/>
-                      </a:solidFill>
-                      <a:prstDash val="solid"/>
-                      <a:round/>
-                      <a:headEnd type="none" w="med" len="med"/>
-                      <a:tailEnd type="none" w="med" len="med"/>
-                    </a:lnT>
-                    <a:lnB w="6350" cap="flat" cmpd="sng" algn="ctr">
-                      <a:solidFill>
-                        <a:srgbClr val="BFBFBF"/>
-                      </a:solidFill>
-                      <a:prstDash val="solid"/>
-                      <a:round/>
-                      <a:headEnd type="none" w="med" len="med"/>
-                      <a:tailEnd type="none" w="med" len="med"/>
-                    </a:lnB>
-                    <a:solidFill>
-                      <a:srgbClr val="2C5F82"/>
-                    </a:solidFill>
-                  </a:tcPr>
-                </a:tc>
-                <a:tc>
-                  <a:txBody>
-                    <a:bodyPr/>
-                    <a:lstStyle/>
-                    <a:p>
-                      <a:pPr indent="0" marL="0">
-                        <a:buNone/>
-                      </a:pPr>
-                      <a:r>
-                        <a:rPr lang="en-US" sz="950" b="1" dirty="0">
-                          <a:solidFill>
-                            <a:srgbClr val="FFFFFF"/>
-                          </a:solidFill>
-                          <a:latin typeface="Arial" pitchFamily="34" charset="0"/>
-                          <a:ea typeface="Arial" pitchFamily="34" charset="-122"/>
-                          <a:cs typeface="Arial" pitchFamily="34" charset="-120"/>
-                        </a:rPr>
-                        <a:t>USD mn</a:t>
-                      </a:r>
-                      <a:endParaRPr lang="en-US" sz="950" dirty="0">
-                        <a:latin typeface="Arial" charset="0"/>
-                        <a:ea typeface="Arial" charset="0"/>
-                        <a:cs typeface="Arial" charset="0"/>
-                      </a:endParaRPr>
-                    </a:p>
-                  </a:txBody>
-                  <a:tcPr marL="76200" marR="76200" marT="25400" marB="25400" anchor="ctr">
-                    <a:lnL w="6350" cap="flat" cmpd="sng" algn="ctr">
-                      <a:solidFill>
-                        <a:srgbClr val="BFBFBF"/>
-                      </a:solidFill>
-                      <a:prstDash val="solid"/>
-                      <a:round/>
-                      <a:headEnd type="none" w="med" len="med"/>
-                      <a:tailEnd type="none" w="med" len="med"/>
-                    </a:lnL>
-                    <a:lnR w="6350" cap="flat" cmpd="sng" algn="ctr">
-                      <a:solidFill>
-                        <a:srgbClr val="BFBFBF"/>
-                      </a:solidFill>
-                      <a:prstDash val="solid"/>
-                      <a:round/>
-                      <a:headEnd type="none" w="med" len="med"/>
-                      <a:tailEnd type="none" w="med" len="med"/>
-                    </a:lnR>
-                    <a:lnT w="6350" cap="flat" cmpd="sng" algn="ctr">
-                      <a:solidFill>
-                        <a:srgbClr val="BFBFBF"/>
-                      </a:solidFill>
-                      <a:prstDash val="solid"/>
-                      <a:round/>
-                      <a:headEnd type="none" w="med" len="med"/>
-                      <a:tailEnd type="none" w="med" len="med"/>
-                    </a:lnT>
-                    <a:lnB w="6350" cap="flat" cmpd="sng" algn="ctr">
-                      <a:solidFill>
-                        <a:srgbClr val="BFBFBF"/>
-                      </a:solidFill>
-                      <a:prstDash val="solid"/>
-                      <a:round/>
-                      <a:headEnd type="none" w="med" len="med"/>
-                      <a:tailEnd type="none" w="med" len="med"/>
-                    </a:lnB>
-                    <a:solidFill>
-                      <a:srgbClr val="2C5F82"/>
-                    </a:solidFill>
-                  </a:tcPr>
-                </a:tc>
-                <a:tc>
-                  <a:txBody>
-                    <a:bodyPr/>
-                    <a:lstStyle/>
-                    <a:p>
-                      <a:pPr indent="0" marL="0">
-                        <a:buNone/>
-                      </a:pPr>
-                      <a:r>
-                        <a:rPr lang="en-US" sz="950" b="1" dirty="0">
-                          <a:solidFill>
-                            <a:srgbClr val="FFFFFF"/>
-                          </a:solidFill>
-                          <a:latin typeface="Arial" pitchFamily="34" charset="0"/>
-                          <a:ea typeface="Arial" pitchFamily="34" charset="-122"/>
-                          <a:cs typeface="Arial" pitchFamily="34" charset="-120"/>
-                        </a:rPr>
-                        <a:t>Role in the portfolio</a:t>
-                      </a:r>
-                      <a:endParaRPr lang="en-US" sz="950" dirty="0">
-                        <a:latin typeface="Arial" charset="0"/>
-                        <a:ea typeface="Arial" charset="0"/>
-                        <a:cs typeface="Arial" charset="0"/>
-                      </a:endParaRPr>
-                    </a:p>
-                  </a:txBody>
-                  <a:tcPr marL="76200" marR="76200" marT="25400" marB="25400" anchor="ctr">
-                    <a:lnL w="6350" cap="flat" cmpd="sng" algn="ctr">
-                      <a:solidFill>
-                        <a:srgbClr val="BFBFBF"/>
-                      </a:solidFill>
-                      <a:prstDash val="solid"/>
-                      <a:round/>
-                      <a:headEnd type="none" w="med" len="med"/>
-                      <a:tailEnd type="none" w="med" len="med"/>
-                    </a:lnL>
-                    <a:lnR w="6350" cap="flat" cmpd="sng" algn="ctr">
-                      <a:solidFill>
-                        <a:srgbClr val="BFBFBF"/>
-                      </a:solidFill>
-                      <a:prstDash val="solid"/>
-                      <a:round/>
-                      <a:headEnd type="none" w="med" len="med"/>
-                      <a:tailEnd type="none" w="med" len="med"/>
-                    </a:lnR>
-                    <a:lnT w="6350" cap="flat" cmpd="sng" algn="ctr">
-                      <a:solidFill>
-                        <a:srgbClr val="BFBFBF"/>
-                      </a:solidFill>
-                      <a:prstDash val="solid"/>
-                      <a:round/>
-                      <a:headEnd type="none" w="med" len="med"/>
-                      <a:tailEnd type="none" w="med" len="med"/>
-                    </a:lnT>
-                    <a:lnB w="6350" cap="flat" cmpd="sng" algn="ctr">
-                      <a:solidFill>
-                        <a:srgbClr val="BFBFBF"/>
-                      </a:solidFill>
-                      <a:prstDash val="solid"/>
-                      <a:round/>
-                      <a:headEnd type="none" w="med" len="med"/>
-                      <a:tailEnd type="none" w="med" len="med"/>
-                    </a:lnB>
-                    <a:solidFill>
-                      <a:srgbClr val="2C5F82"/>
-                    </a:solidFill>
-                  </a:tcPr>
-                </a:tc>
-              </a:tr>
-              <a:tr h="566928">
                 <a:tc>
                   <a:txBody>
                     <a:bodyPr/>
@@ -2046,32 +1854,11 @@
                         <a:cs typeface="Arial" charset="0"/>
                       </a:endParaRPr>
                     </a:p>
-                    <a:p>
-                      <a:pPr indent="0" marL="0">
-                        <a:buNone/>
-                      </a:pPr>
-                      <a:r>
-                        <a:rPr lang="en-US" sz="800" dirty="0">
-                          <a:solidFill>
-                            <a:srgbClr val="595959"/>
-                          </a:solidFill>
-                          <a:latin typeface="Arial" pitchFamily="34" charset="0"/>
-                          <a:ea typeface="Arial" pitchFamily="34" charset="-122"/>
-                          <a:cs typeface="Arial" pitchFamily="34" charset="-120"/>
-                        </a:rPr>
-                        <a:t>Global X Asia Semiconductor ETF</a:t>
-                      </a:r>
-                      <a:endParaRPr lang="en-US" sz="950" dirty="0">
-                        <a:latin typeface="Arial" charset="0"/>
-                        <a:ea typeface="Arial" charset="0"/>
-                        <a:cs typeface="Arial" charset="0"/>
-                      </a:endParaRPr>
-                    </a:p>
                   </a:txBody>
-                  <a:tcPr marL="76200" marR="76200" marT="25400" marB="25400" anchor="ctr">
+                  <a:tcPr marL="50800" marR="50800" marT="12700" marB="12700" anchor="ctr">
                     <a:lnL w="6350" cap="flat" cmpd="sng" algn="ctr">
                       <a:solidFill>
-                        <a:srgbClr val="BFBFBF"/>
+                        <a:srgbClr val="E3E3E3"/>
                       </a:solidFill>
                       <a:prstDash val="solid"/>
                       <a:round/>
@@ -2080,7 +1867,7 @@
                     </a:lnL>
                     <a:lnR w="6350" cap="flat" cmpd="sng" algn="ctr">
                       <a:solidFill>
-                        <a:srgbClr val="BFBFBF"/>
+                        <a:srgbClr val="E3E3E3"/>
                       </a:solidFill>
                       <a:prstDash val="solid"/>
                       <a:round/>
@@ -2089,7 +1876,7 @@
                     </a:lnR>
                     <a:lnT w="6350" cap="flat" cmpd="sng" algn="ctr">
                       <a:solidFill>
-                        <a:srgbClr val="BFBFBF"/>
+                        <a:srgbClr val="E3E3E3"/>
                       </a:solidFill>
                       <a:prstDash val="solid"/>
                       <a:round/>
@@ -2098,143 +1885,7 @@
                     </a:lnT>
                     <a:lnB w="6350" cap="flat" cmpd="sng" algn="ctr">
                       <a:solidFill>
-                        <a:srgbClr val="BFBFBF"/>
-                      </a:solidFill>
-                      <a:prstDash val="solid"/>
-                      <a:round/>
-                      <a:headEnd type="none" w="med" len="med"/>
-                      <a:tailEnd type="none" w="med" len="med"/>
-                    </a:lnB>
-                    <a:solidFill>
-                      <a:srgbClr val="FFFFFF"/>
-                    </a:solidFill>
-                  </a:tcPr>
-                </a:tc>
-                <a:tc>
-                  <a:txBody>
-                    <a:bodyPr/>
-                    <a:lstStyle/>
-                    <a:p>
-                      <a:pPr algn="ctr" indent="0" marL="0">
-                        <a:buNone/>
-                      </a:pPr>
-                      <a:r>
-                        <a:rPr lang="en-US" sz="950" b="1" dirty="0">
-                          <a:solidFill>
-                            <a:srgbClr val="262626"/>
-                          </a:solidFill>
-                          <a:latin typeface="Arial" pitchFamily="34" charset="0"/>
-                          <a:ea typeface="Arial" pitchFamily="34" charset="-122"/>
-                          <a:cs typeface="Arial" pitchFamily="34" charset="-120"/>
-                        </a:rPr>
-                        <a:t>35%</a:t>
-                      </a:r>
-                      <a:endParaRPr lang="en-US" sz="950" dirty="0">
-                        <a:latin typeface="Arial" charset="0"/>
-                        <a:ea typeface="Arial" charset="0"/>
-                        <a:cs typeface="Arial" charset="0"/>
-                      </a:endParaRPr>
-                    </a:p>
-                  </a:txBody>
-                  <a:tcPr marL="76200" marR="76200" marT="25400" marB="25400" anchor="ctr">
-                    <a:lnL w="6350" cap="flat" cmpd="sng" algn="ctr">
-                      <a:solidFill>
-                        <a:srgbClr val="BFBFBF"/>
-                      </a:solidFill>
-                      <a:prstDash val="solid"/>
-                      <a:round/>
-                      <a:headEnd type="none" w="med" len="med"/>
-                      <a:tailEnd type="none" w="med" len="med"/>
-                    </a:lnL>
-                    <a:lnR w="6350" cap="flat" cmpd="sng" algn="ctr">
-                      <a:solidFill>
-                        <a:srgbClr val="BFBFBF"/>
-                      </a:solidFill>
-                      <a:prstDash val="solid"/>
-                      <a:round/>
-                      <a:headEnd type="none" w="med" len="med"/>
-                      <a:tailEnd type="none" w="med" len="med"/>
-                    </a:lnR>
-                    <a:lnT w="6350" cap="flat" cmpd="sng" algn="ctr">
-                      <a:solidFill>
-                        <a:srgbClr val="BFBFBF"/>
-                      </a:solidFill>
-                      <a:prstDash val="solid"/>
-                      <a:round/>
-                      <a:headEnd type="none" w="med" len="med"/>
-                      <a:tailEnd type="none" w="med" len="med"/>
-                    </a:lnT>
-                    <a:lnB w="6350" cap="flat" cmpd="sng" algn="ctr">
-                      <a:solidFill>
-                        <a:srgbClr val="BFBFBF"/>
-                      </a:solidFill>
-                      <a:prstDash val="solid"/>
-                      <a:round/>
-                      <a:headEnd type="none" w="med" len="med"/>
-                      <a:tailEnd type="none" w="med" len="med"/>
-                    </a:lnB>
-                    <a:solidFill>
-                      <a:srgbClr val="FFFFFF"/>
-                    </a:solidFill>
-                  </a:tcPr>
-                </a:tc>
-                <a:tc>
-                  <a:txBody>
-                    <a:bodyPr/>
-                    <a:lstStyle/>
-                    <a:p>
-                      <a:pPr algn="ctr" indent="0" marL="0">
-                        <a:buNone/>
-                      </a:pPr>
-                      <a:r>
-                        <a:rPr lang="en-US" sz="950" dirty="0">
-                          <a:solidFill>
-                            <a:srgbClr val="262626"/>
-                          </a:solidFill>
-                          <a:latin typeface="Arial" pitchFamily="34" charset="0"/>
-                          <a:ea typeface="Arial" pitchFamily="34" charset="-122"/>
-                          <a:cs typeface="Arial" pitchFamily="34" charset="-120"/>
-                        </a:rPr>
-                        <a:t>35</a:t>
-                      </a:r>
-                      <a:endParaRPr lang="en-US" sz="950" dirty="0">
-                        <a:latin typeface="Arial" charset="0"/>
-                        <a:ea typeface="Arial" charset="0"/>
-                        <a:cs typeface="Arial" charset="0"/>
-                      </a:endParaRPr>
-                    </a:p>
-                  </a:txBody>
-                  <a:tcPr marL="76200" marR="76200" marT="25400" marB="25400" anchor="ctr">
-                    <a:lnL w="6350" cap="flat" cmpd="sng" algn="ctr">
-                      <a:solidFill>
-                        <a:srgbClr val="BFBFBF"/>
-                      </a:solidFill>
-                      <a:prstDash val="solid"/>
-                      <a:round/>
-                      <a:headEnd type="none" w="med" len="med"/>
-                      <a:tailEnd type="none" w="med" len="med"/>
-                    </a:lnL>
-                    <a:lnR w="6350" cap="flat" cmpd="sng" algn="ctr">
-                      <a:solidFill>
-                        <a:srgbClr val="BFBFBF"/>
-                      </a:solidFill>
-                      <a:prstDash val="solid"/>
-                      <a:round/>
-                      <a:headEnd type="none" w="med" len="med"/>
-                      <a:tailEnd type="none" w="med" len="med"/>
-                    </a:lnR>
-                    <a:lnT w="6350" cap="flat" cmpd="sng" algn="ctr">
-                      <a:solidFill>
-                        <a:srgbClr val="BFBFBF"/>
-                      </a:solidFill>
-                      <a:prstDash val="solid"/>
-                      <a:round/>
-                      <a:headEnd type="none" w="med" len="med"/>
-                      <a:tailEnd type="none" w="med" len="med"/>
-                    </a:lnT>
-                    <a:lnB w="6350" cap="flat" cmpd="sng" algn="ctr">
-                      <a:solidFill>
-                        <a:srgbClr val="BFBFBF"/>
+                        <a:srgbClr val="E3E3E3"/>
                       </a:solidFill>
                       <a:prstDash val="solid"/>
                       <a:round/>
@@ -2263,7 +1914,7 @@
                           <a:ea typeface="Arial" pitchFamily="34" charset="-122"/>
                           <a:cs typeface="Arial" pitchFamily="34" charset="-120"/>
                         </a:rPr>
-                        <a:t>Core: pan-Asian chip leaders (TSMC, Samsung, SK hynix)</a:t>
+                        <a:t>Pan-Asian chip leaders</a:t>
                       </a:r>
                       <a:endParaRPr lang="en-US" sz="950" dirty="0">
                         <a:latin typeface="Arial" charset="0"/>
@@ -2272,10 +1923,10 @@
                       </a:endParaRPr>
                     </a:p>
                   </a:txBody>
-                  <a:tcPr marL="76200" marR="76200" marT="25400" marB="25400" anchor="ctr">
+                  <a:tcPr marL="50800" marR="50800" marT="12700" marB="12700" anchor="ctr">
                     <a:lnL w="6350" cap="flat" cmpd="sng" algn="ctr">
                       <a:solidFill>
-                        <a:srgbClr val="BFBFBF"/>
+                        <a:srgbClr val="E3E3E3"/>
                       </a:solidFill>
                       <a:prstDash val="solid"/>
                       <a:round/>
@@ -2284,7 +1935,7 @@
                     </a:lnL>
                     <a:lnR w="6350" cap="flat" cmpd="sng" algn="ctr">
                       <a:solidFill>
-                        <a:srgbClr val="BFBFBF"/>
+                        <a:srgbClr val="E3E3E3"/>
                       </a:solidFill>
                       <a:prstDash val="solid"/>
                       <a:round/>
@@ -2293,7 +1944,7 @@
                     </a:lnR>
                     <a:lnT w="6350" cap="flat" cmpd="sng" algn="ctr">
                       <a:solidFill>
-                        <a:srgbClr val="BFBFBF"/>
+                        <a:srgbClr val="E3E3E3"/>
                       </a:solidFill>
                       <a:prstDash val="solid"/>
                       <a:round/>
@@ -2302,7 +1953,75 @@
                     </a:lnT>
                     <a:lnB w="6350" cap="flat" cmpd="sng" algn="ctr">
                       <a:solidFill>
-                        <a:srgbClr val="BFBFBF"/>
+                        <a:srgbClr val="E3E3E3"/>
+                      </a:solidFill>
+                      <a:prstDash val="solid"/>
+                      <a:round/>
+                      <a:headEnd type="none" w="med" len="med"/>
+                      <a:tailEnd type="none" w="med" len="med"/>
+                    </a:lnB>
+                    <a:solidFill>
+                      <a:srgbClr val="FFFFFF"/>
+                    </a:solidFill>
+                  </a:tcPr>
+                </a:tc>
+                <a:tc>
+                  <a:txBody>
+                    <a:bodyPr/>
+                    <a:lstStyle/>
+                    <a:p>
+                      <a:pPr algn="r" indent="0" marL="0">
+                        <a:buNone/>
+                      </a:pPr>
+                      <a:r>
+                        <a:rPr lang="en-US" sz="950" b="1" dirty="0">
+                          <a:solidFill>
+                            <a:srgbClr val="262626"/>
+                          </a:solidFill>
+                          <a:latin typeface="Arial" pitchFamily="34" charset="0"/>
+                          <a:ea typeface="Arial" pitchFamily="34" charset="-122"/>
+                          <a:cs typeface="Arial" pitchFamily="34" charset="-120"/>
+                        </a:rPr>
+                        <a:t>35%</a:t>
+                      </a:r>
+                      <a:endParaRPr lang="en-US" sz="950" dirty="0">
+                        <a:latin typeface="Arial" charset="0"/>
+                        <a:ea typeface="Arial" charset="0"/>
+                        <a:cs typeface="Arial" charset="0"/>
+                      </a:endParaRPr>
+                    </a:p>
+                  </a:txBody>
+                  <a:tcPr marL="50800" marR="50800" marT="12700" marB="12700" anchor="ctr">
+                    <a:lnL w="6350" cap="flat" cmpd="sng" algn="ctr">
+                      <a:solidFill>
+                        <a:srgbClr val="E3E3E3"/>
+                      </a:solidFill>
+                      <a:prstDash val="solid"/>
+                      <a:round/>
+                      <a:headEnd type="none" w="med" len="med"/>
+                      <a:tailEnd type="none" w="med" len="med"/>
+                    </a:lnL>
+                    <a:lnR w="6350" cap="flat" cmpd="sng" algn="ctr">
+                      <a:solidFill>
+                        <a:srgbClr val="E3E3E3"/>
+                      </a:solidFill>
+                      <a:prstDash val="solid"/>
+                      <a:round/>
+                      <a:headEnd type="none" w="med" len="med"/>
+                      <a:tailEnd type="none" w="med" len="med"/>
+                    </a:lnR>
+                    <a:lnT w="6350" cap="flat" cmpd="sng" algn="ctr">
+                      <a:solidFill>
+                        <a:srgbClr val="E3E3E3"/>
+                      </a:solidFill>
+                      <a:prstDash val="solid"/>
+                      <a:round/>
+                      <a:headEnd type="none" w="med" len="med"/>
+                      <a:tailEnd type="none" w="med" len="med"/>
+                    </a:lnT>
+                    <a:lnB w="6350" cap="flat" cmpd="sng" algn="ctr">
+                      <a:solidFill>
+                        <a:srgbClr val="E3E3E3"/>
                       </a:solidFill>
                       <a:prstDash val="solid"/>
                       <a:round/>
@@ -2315,7 +2034,75 @@
                   </a:tcPr>
                 </a:tc>
               </a:tr>
-              <a:tr h="566928">
+              <a:tr h="329184">
+                <a:tc>
+                  <a:txBody>
+                    <a:bodyPr/>
+                    <a:lstStyle/>
+                    <a:p>
+                      <a:pPr algn="ctr" indent="0" marL="0">
+                        <a:buNone/>
+                      </a:pPr>
+                      <a:r>
+                        <a:rPr lang="en-US" sz="1200" dirty="0">
+                          <a:solidFill>
+                            <a:srgbClr val="4F86AE"/>
+                          </a:solidFill>
+                          <a:latin typeface="Arial" pitchFamily="34" charset="0"/>
+                          <a:ea typeface="Arial" pitchFamily="34" charset="-122"/>
+                          <a:cs typeface="Arial" pitchFamily="34" charset="-120"/>
+                        </a:rPr>
+                        <a:t>■</a:t>
+                      </a:r>
+                      <a:endParaRPr lang="en-US" sz="1200" dirty="0">
+                        <a:latin typeface="Arial" charset="0"/>
+                        <a:ea typeface="Arial" charset="0"/>
+                        <a:cs typeface="Arial" charset="0"/>
+                      </a:endParaRPr>
+                    </a:p>
+                  </a:txBody>
+                  <a:tcPr marL="50800" marR="50800" marT="12700" marB="12700" anchor="ctr">
+                    <a:lnL w="6350" cap="flat" cmpd="sng" algn="ctr">
+                      <a:solidFill>
+                        <a:srgbClr val="E3E3E3"/>
+                      </a:solidFill>
+                      <a:prstDash val="solid"/>
+                      <a:round/>
+                      <a:headEnd type="none" w="med" len="med"/>
+                      <a:tailEnd type="none" w="med" len="med"/>
+                    </a:lnL>
+                    <a:lnR w="6350" cap="flat" cmpd="sng" algn="ctr">
+                      <a:solidFill>
+                        <a:srgbClr val="E3E3E3"/>
+                      </a:solidFill>
+                      <a:prstDash val="solid"/>
+                      <a:round/>
+                      <a:headEnd type="none" w="med" len="med"/>
+                      <a:tailEnd type="none" w="med" len="med"/>
+                    </a:lnR>
+                    <a:lnT w="6350" cap="flat" cmpd="sng" algn="ctr">
+                      <a:solidFill>
+                        <a:srgbClr val="E3E3E3"/>
+                      </a:solidFill>
+                      <a:prstDash val="solid"/>
+                      <a:round/>
+                      <a:headEnd type="none" w="med" len="med"/>
+                      <a:tailEnd type="none" w="med" len="med"/>
+                    </a:lnT>
+                    <a:lnB w="6350" cap="flat" cmpd="sng" algn="ctr">
+                      <a:solidFill>
+                        <a:srgbClr val="E3E3E3"/>
+                      </a:solidFill>
+                      <a:prstDash val="solid"/>
+                      <a:round/>
+                      <a:headEnd type="none" w="med" len="med"/>
+                      <a:tailEnd type="none" w="med" len="med"/>
+                    </a:lnB>
+                    <a:solidFill>
+                      <a:srgbClr val="FFFFFF"/>
+                    </a:solidFill>
+                  </a:tcPr>
+                </a:tc>
                 <a:tc>
                   <a:txBody>
                     <a:bodyPr/>
@@ -2341,32 +2128,11 @@
                         <a:cs typeface="Arial" charset="0"/>
                       </a:endParaRPr>
                     </a:p>
-                    <a:p>
-                      <a:pPr indent="0" marL="0">
-                        <a:buNone/>
-                      </a:pPr>
-                      <a:r>
-                        <a:rPr lang="en-US" sz="800" dirty="0">
-                          <a:solidFill>
-                            <a:srgbClr val="595959"/>
-                          </a:solidFill>
-                          <a:latin typeface="Arial" pitchFamily="34" charset="0"/>
-                          <a:ea typeface="Arial" pitchFamily="34" charset="-122"/>
-                          <a:cs typeface="Arial" pitchFamily="34" charset="-120"/>
-                        </a:rPr>
-                        <a:t>iShares MSCI South Korea ETF</a:t>
-                      </a:r>
-                      <a:endParaRPr lang="en-US" sz="950" dirty="0">
-                        <a:latin typeface="Arial" charset="0"/>
-                        <a:ea typeface="Arial" charset="0"/>
-                        <a:cs typeface="Arial" charset="0"/>
-                      </a:endParaRPr>
-                    </a:p>
                   </a:txBody>
-                  <a:tcPr marL="76200" marR="76200" marT="25400" marB="25400" anchor="ctr">
+                  <a:tcPr marL="50800" marR="50800" marT="12700" marB="12700" anchor="ctr">
                     <a:lnL w="6350" cap="flat" cmpd="sng" algn="ctr">
                       <a:solidFill>
-                        <a:srgbClr val="BFBFBF"/>
+                        <a:srgbClr val="E3E3E3"/>
                       </a:solidFill>
                       <a:prstDash val="solid"/>
                       <a:round/>
@@ -2375,7 +2141,7 @@
                     </a:lnL>
                     <a:lnR w="6350" cap="flat" cmpd="sng" algn="ctr">
                       <a:solidFill>
-                        <a:srgbClr val="BFBFBF"/>
+                        <a:srgbClr val="E3E3E3"/>
                       </a:solidFill>
                       <a:prstDash val="solid"/>
                       <a:round/>
@@ -2384,7 +2150,7 @@
                     </a:lnR>
                     <a:lnT w="6350" cap="flat" cmpd="sng" algn="ctr">
                       <a:solidFill>
-                        <a:srgbClr val="BFBFBF"/>
+                        <a:srgbClr val="E3E3E3"/>
                       </a:solidFill>
                       <a:prstDash val="solid"/>
                       <a:round/>
@@ -2393,143 +2159,7 @@
                     </a:lnT>
                     <a:lnB w="6350" cap="flat" cmpd="sng" algn="ctr">
                       <a:solidFill>
-                        <a:srgbClr val="BFBFBF"/>
-                      </a:solidFill>
-                      <a:prstDash val="solid"/>
-                      <a:round/>
-                      <a:headEnd type="none" w="med" len="med"/>
-                      <a:tailEnd type="none" w="med" len="med"/>
-                    </a:lnB>
-                    <a:solidFill>
-                      <a:srgbClr val="FFFFFF"/>
-                    </a:solidFill>
-                  </a:tcPr>
-                </a:tc>
-                <a:tc>
-                  <a:txBody>
-                    <a:bodyPr/>
-                    <a:lstStyle/>
-                    <a:p>
-                      <a:pPr algn="ctr" indent="0" marL="0">
-                        <a:buNone/>
-                      </a:pPr>
-                      <a:r>
-                        <a:rPr lang="en-US" sz="950" b="1" dirty="0">
-                          <a:solidFill>
-                            <a:srgbClr val="262626"/>
-                          </a:solidFill>
-                          <a:latin typeface="Arial" pitchFamily="34" charset="0"/>
-                          <a:ea typeface="Arial" pitchFamily="34" charset="-122"/>
-                          <a:cs typeface="Arial" pitchFamily="34" charset="-120"/>
-                        </a:rPr>
-                        <a:t>20%</a:t>
-                      </a:r>
-                      <a:endParaRPr lang="en-US" sz="950" dirty="0">
-                        <a:latin typeface="Arial" charset="0"/>
-                        <a:ea typeface="Arial" charset="0"/>
-                        <a:cs typeface="Arial" charset="0"/>
-                      </a:endParaRPr>
-                    </a:p>
-                  </a:txBody>
-                  <a:tcPr marL="76200" marR="76200" marT="25400" marB="25400" anchor="ctr">
-                    <a:lnL w="6350" cap="flat" cmpd="sng" algn="ctr">
-                      <a:solidFill>
-                        <a:srgbClr val="BFBFBF"/>
-                      </a:solidFill>
-                      <a:prstDash val="solid"/>
-                      <a:round/>
-                      <a:headEnd type="none" w="med" len="med"/>
-                      <a:tailEnd type="none" w="med" len="med"/>
-                    </a:lnL>
-                    <a:lnR w="6350" cap="flat" cmpd="sng" algn="ctr">
-                      <a:solidFill>
-                        <a:srgbClr val="BFBFBF"/>
-                      </a:solidFill>
-                      <a:prstDash val="solid"/>
-                      <a:round/>
-                      <a:headEnd type="none" w="med" len="med"/>
-                      <a:tailEnd type="none" w="med" len="med"/>
-                    </a:lnR>
-                    <a:lnT w="6350" cap="flat" cmpd="sng" algn="ctr">
-                      <a:solidFill>
-                        <a:srgbClr val="BFBFBF"/>
-                      </a:solidFill>
-                      <a:prstDash val="solid"/>
-                      <a:round/>
-                      <a:headEnd type="none" w="med" len="med"/>
-                      <a:tailEnd type="none" w="med" len="med"/>
-                    </a:lnT>
-                    <a:lnB w="6350" cap="flat" cmpd="sng" algn="ctr">
-                      <a:solidFill>
-                        <a:srgbClr val="BFBFBF"/>
-                      </a:solidFill>
-                      <a:prstDash val="solid"/>
-                      <a:round/>
-                      <a:headEnd type="none" w="med" len="med"/>
-                      <a:tailEnd type="none" w="med" len="med"/>
-                    </a:lnB>
-                    <a:solidFill>
-                      <a:srgbClr val="FFFFFF"/>
-                    </a:solidFill>
-                  </a:tcPr>
-                </a:tc>
-                <a:tc>
-                  <a:txBody>
-                    <a:bodyPr/>
-                    <a:lstStyle/>
-                    <a:p>
-                      <a:pPr algn="ctr" indent="0" marL="0">
-                        <a:buNone/>
-                      </a:pPr>
-                      <a:r>
-                        <a:rPr lang="en-US" sz="950" dirty="0">
-                          <a:solidFill>
-                            <a:srgbClr val="262626"/>
-                          </a:solidFill>
-                          <a:latin typeface="Arial" pitchFamily="34" charset="0"/>
-                          <a:ea typeface="Arial" pitchFamily="34" charset="-122"/>
-                          <a:cs typeface="Arial" pitchFamily="34" charset="-120"/>
-                        </a:rPr>
-                        <a:t>20</a:t>
-                      </a:r>
-                      <a:endParaRPr lang="en-US" sz="950" dirty="0">
-                        <a:latin typeface="Arial" charset="0"/>
-                        <a:ea typeface="Arial" charset="0"/>
-                        <a:cs typeface="Arial" charset="0"/>
-                      </a:endParaRPr>
-                    </a:p>
-                  </a:txBody>
-                  <a:tcPr marL="76200" marR="76200" marT="25400" marB="25400" anchor="ctr">
-                    <a:lnL w="6350" cap="flat" cmpd="sng" algn="ctr">
-                      <a:solidFill>
-                        <a:srgbClr val="BFBFBF"/>
-                      </a:solidFill>
-                      <a:prstDash val="solid"/>
-                      <a:round/>
-                      <a:headEnd type="none" w="med" len="med"/>
-                      <a:tailEnd type="none" w="med" len="med"/>
-                    </a:lnL>
-                    <a:lnR w="6350" cap="flat" cmpd="sng" algn="ctr">
-                      <a:solidFill>
-                        <a:srgbClr val="BFBFBF"/>
-                      </a:solidFill>
-                      <a:prstDash val="solid"/>
-                      <a:round/>
-                      <a:headEnd type="none" w="med" len="med"/>
-                      <a:tailEnd type="none" w="med" len="med"/>
-                    </a:lnR>
-                    <a:lnT w="6350" cap="flat" cmpd="sng" algn="ctr">
-                      <a:solidFill>
-                        <a:srgbClr val="BFBFBF"/>
-                      </a:solidFill>
-                      <a:prstDash val="solid"/>
-                      <a:round/>
-                      <a:headEnd type="none" w="med" len="med"/>
-                      <a:tailEnd type="none" w="med" len="med"/>
-                    </a:lnT>
-                    <a:lnB w="6350" cap="flat" cmpd="sng" algn="ctr">
-                      <a:solidFill>
-                        <a:srgbClr val="BFBFBF"/>
+                        <a:srgbClr val="E3E3E3"/>
                       </a:solidFill>
                       <a:prstDash val="solid"/>
                       <a:round/>
@@ -2558,7 +2188,7 @@
                           <a:ea typeface="Arial" pitchFamily="34" charset="-122"/>
                           <a:cs typeface="Arial" pitchFamily="34" charset="-120"/>
                         </a:rPr>
-                        <a:t>Memory for AI: Samsung + SK hynix ≈ 44% of the fund</a:t>
+                        <a:t>Korea: memory for AI</a:t>
                       </a:r>
                       <a:endParaRPr lang="en-US" sz="950" dirty="0">
                         <a:latin typeface="Arial" charset="0"/>
@@ -2567,10 +2197,10 @@
                       </a:endParaRPr>
                     </a:p>
                   </a:txBody>
-                  <a:tcPr marL="76200" marR="76200" marT="25400" marB="25400" anchor="ctr">
+                  <a:tcPr marL="50800" marR="50800" marT="12700" marB="12700" anchor="ctr">
                     <a:lnL w="6350" cap="flat" cmpd="sng" algn="ctr">
                       <a:solidFill>
-                        <a:srgbClr val="BFBFBF"/>
+                        <a:srgbClr val="E3E3E3"/>
                       </a:solidFill>
                       <a:prstDash val="solid"/>
                       <a:round/>
@@ -2579,7 +2209,7 @@
                     </a:lnL>
                     <a:lnR w="6350" cap="flat" cmpd="sng" algn="ctr">
                       <a:solidFill>
-                        <a:srgbClr val="BFBFBF"/>
+                        <a:srgbClr val="E3E3E3"/>
                       </a:solidFill>
                       <a:prstDash val="solid"/>
                       <a:round/>
@@ -2588,7 +2218,7 @@
                     </a:lnR>
                     <a:lnT w="6350" cap="flat" cmpd="sng" algn="ctr">
                       <a:solidFill>
-                        <a:srgbClr val="BFBFBF"/>
+                        <a:srgbClr val="E3E3E3"/>
                       </a:solidFill>
                       <a:prstDash val="solid"/>
                       <a:round/>
@@ -2597,7 +2227,75 @@
                     </a:lnT>
                     <a:lnB w="6350" cap="flat" cmpd="sng" algn="ctr">
                       <a:solidFill>
-                        <a:srgbClr val="BFBFBF"/>
+                        <a:srgbClr val="E3E3E3"/>
+                      </a:solidFill>
+                      <a:prstDash val="solid"/>
+                      <a:round/>
+                      <a:headEnd type="none" w="med" len="med"/>
+                      <a:tailEnd type="none" w="med" len="med"/>
+                    </a:lnB>
+                    <a:solidFill>
+                      <a:srgbClr val="FFFFFF"/>
+                    </a:solidFill>
+                  </a:tcPr>
+                </a:tc>
+                <a:tc>
+                  <a:txBody>
+                    <a:bodyPr/>
+                    <a:lstStyle/>
+                    <a:p>
+                      <a:pPr algn="r" indent="0" marL="0">
+                        <a:buNone/>
+                      </a:pPr>
+                      <a:r>
+                        <a:rPr lang="en-US" sz="950" b="1" dirty="0">
+                          <a:solidFill>
+                            <a:srgbClr val="262626"/>
+                          </a:solidFill>
+                          <a:latin typeface="Arial" pitchFamily="34" charset="0"/>
+                          <a:ea typeface="Arial" pitchFamily="34" charset="-122"/>
+                          <a:cs typeface="Arial" pitchFamily="34" charset="-120"/>
+                        </a:rPr>
+                        <a:t>20%</a:t>
+                      </a:r>
+                      <a:endParaRPr lang="en-US" sz="950" dirty="0">
+                        <a:latin typeface="Arial" charset="0"/>
+                        <a:ea typeface="Arial" charset="0"/>
+                        <a:cs typeface="Arial" charset="0"/>
+                      </a:endParaRPr>
+                    </a:p>
+                  </a:txBody>
+                  <a:tcPr marL="50800" marR="50800" marT="12700" marB="12700" anchor="ctr">
+                    <a:lnL w="6350" cap="flat" cmpd="sng" algn="ctr">
+                      <a:solidFill>
+                        <a:srgbClr val="E3E3E3"/>
+                      </a:solidFill>
+                      <a:prstDash val="solid"/>
+                      <a:round/>
+                      <a:headEnd type="none" w="med" len="med"/>
+                      <a:tailEnd type="none" w="med" len="med"/>
+                    </a:lnL>
+                    <a:lnR w="6350" cap="flat" cmpd="sng" algn="ctr">
+                      <a:solidFill>
+                        <a:srgbClr val="E3E3E3"/>
+                      </a:solidFill>
+                      <a:prstDash val="solid"/>
+                      <a:round/>
+                      <a:headEnd type="none" w="med" len="med"/>
+                      <a:tailEnd type="none" w="med" len="med"/>
+                    </a:lnR>
+                    <a:lnT w="6350" cap="flat" cmpd="sng" algn="ctr">
+                      <a:solidFill>
+                        <a:srgbClr val="E3E3E3"/>
+                      </a:solidFill>
+                      <a:prstDash val="solid"/>
+                      <a:round/>
+                      <a:headEnd type="none" w="med" len="med"/>
+                      <a:tailEnd type="none" w="med" len="med"/>
+                    </a:lnT>
+                    <a:lnB w="6350" cap="flat" cmpd="sng" algn="ctr">
+                      <a:solidFill>
+                        <a:srgbClr val="E3E3E3"/>
                       </a:solidFill>
                       <a:prstDash val="solid"/>
                       <a:round/>
@@ -2610,7 +2308,75 @@
                   </a:tcPr>
                 </a:tc>
               </a:tr>
-              <a:tr h="566928">
+              <a:tr h="329184">
+                <a:tc>
+                  <a:txBody>
+                    <a:bodyPr/>
+                    <a:lstStyle/>
+                    <a:p>
+                      <a:pPr algn="ctr" indent="0" marL="0">
+                        <a:buNone/>
+                      </a:pPr>
+                      <a:r>
+                        <a:rPr lang="en-US" sz="1200" dirty="0">
+                          <a:solidFill>
+                            <a:srgbClr val="8DB3D1"/>
+                          </a:solidFill>
+                          <a:latin typeface="Arial" pitchFamily="34" charset="0"/>
+                          <a:ea typeface="Arial" pitchFamily="34" charset="-122"/>
+                          <a:cs typeface="Arial" pitchFamily="34" charset="-120"/>
+                        </a:rPr>
+                        <a:t>■</a:t>
+                      </a:r>
+                      <a:endParaRPr lang="en-US" sz="1200" dirty="0">
+                        <a:latin typeface="Arial" charset="0"/>
+                        <a:ea typeface="Arial" charset="0"/>
+                        <a:cs typeface="Arial" charset="0"/>
+                      </a:endParaRPr>
+                    </a:p>
+                  </a:txBody>
+                  <a:tcPr marL="50800" marR="50800" marT="12700" marB="12700" anchor="ctr">
+                    <a:lnL w="6350" cap="flat" cmpd="sng" algn="ctr">
+                      <a:solidFill>
+                        <a:srgbClr val="E3E3E3"/>
+                      </a:solidFill>
+                      <a:prstDash val="solid"/>
+                      <a:round/>
+                      <a:headEnd type="none" w="med" len="med"/>
+                      <a:tailEnd type="none" w="med" len="med"/>
+                    </a:lnL>
+                    <a:lnR w="6350" cap="flat" cmpd="sng" algn="ctr">
+                      <a:solidFill>
+                        <a:srgbClr val="E3E3E3"/>
+                      </a:solidFill>
+                      <a:prstDash val="solid"/>
+                      <a:round/>
+                      <a:headEnd type="none" w="med" len="med"/>
+                      <a:tailEnd type="none" w="med" len="med"/>
+                    </a:lnR>
+                    <a:lnT w="6350" cap="flat" cmpd="sng" algn="ctr">
+                      <a:solidFill>
+                        <a:srgbClr val="E3E3E3"/>
+                      </a:solidFill>
+                      <a:prstDash val="solid"/>
+                      <a:round/>
+                      <a:headEnd type="none" w="med" len="med"/>
+                      <a:tailEnd type="none" w="med" len="med"/>
+                    </a:lnT>
+                    <a:lnB w="6350" cap="flat" cmpd="sng" algn="ctr">
+                      <a:solidFill>
+                        <a:srgbClr val="E3E3E3"/>
+                      </a:solidFill>
+                      <a:prstDash val="solid"/>
+                      <a:round/>
+                      <a:headEnd type="none" w="med" len="med"/>
+                      <a:tailEnd type="none" w="med" len="med"/>
+                    </a:lnB>
+                    <a:solidFill>
+                      <a:srgbClr val="FFFFFF"/>
+                    </a:solidFill>
+                  </a:tcPr>
+                </a:tc>
                 <a:tc>
                   <a:txBody>
                     <a:bodyPr/>
@@ -2636,32 +2402,11 @@
                         <a:cs typeface="Arial" charset="0"/>
                       </a:endParaRPr>
                     </a:p>
-                    <a:p>
-                      <a:pPr indent="0" marL="0">
-                        <a:buNone/>
-                      </a:pPr>
-                      <a:r>
-                        <a:rPr lang="en-US" sz="800" dirty="0">
-                          <a:solidFill>
-                            <a:srgbClr val="595959"/>
-                          </a:solidFill>
-                          <a:latin typeface="Arial" pitchFamily="34" charset="0"/>
-                          <a:ea typeface="Arial" pitchFamily="34" charset="-122"/>
-                          <a:cs typeface="Arial" pitchFamily="34" charset="-120"/>
-                        </a:rPr>
-                        <a:t>iShares MSCI Taiwan ETF</a:t>
-                      </a:r>
-                      <a:endParaRPr lang="en-US" sz="950" dirty="0">
-                        <a:latin typeface="Arial" charset="0"/>
-                        <a:ea typeface="Arial" charset="0"/>
-                        <a:cs typeface="Arial" charset="0"/>
-                      </a:endParaRPr>
-                    </a:p>
                   </a:txBody>
-                  <a:tcPr marL="76200" marR="76200" marT="25400" marB="25400" anchor="ctr">
+                  <a:tcPr marL="50800" marR="50800" marT="12700" marB="12700" anchor="ctr">
                     <a:lnL w="6350" cap="flat" cmpd="sng" algn="ctr">
                       <a:solidFill>
-                        <a:srgbClr val="BFBFBF"/>
+                        <a:srgbClr val="E3E3E3"/>
                       </a:solidFill>
                       <a:prstDash val="solid"/>
                       <a:round/>
@@ -2670,7 +2415,7 @@
                     </a:lnL>
                     <a:lnR w="6350" cap="flat" cmpd="sng" algn="ctr">
                       <a:solidFill>
-                        <a:srgbClr val="BFBFBF"/>
+                        <a:srgbClr val="E3E3E3"/>
                       </a:solidFill>
                       <a:prstDash val="solid"/>
                       <a:round/>
@@ -2679,7 +2424,7 @@
                     </a:lnR>
                     <a:lnT w="6350" cap="flat" cmpd="sng" algn="ctr">
                       <a:solidFill>
-                        <a:srgbClr val="BFBFBF"/>
+                        <a:srgbClr val="E3E3E3"/>
                       </a:solidFill>
                       <a:prstDash val="solid"/>
                       <a:round/>
@@ -2688,143 +2433,7 @@
                     </a:lnT>
                     <a:lnB w="6350" cap="flat" cmpd="sng" algn="ctr">
                       <a:solidFill>
-                        <a:srgbClr val="BFBFBF"/>
-                      </a:solidFill>
-                      <a:prstDash val="solid"/>
-                      <a:round/>
-                      <a:headEnd type="none" w="med" len="med"/>
-                      <a:tailEnd type="none" w="med" len="med"/>
-                    </a:lnB>
-                    <a:solidFill>
-                      <a:srgbClr val="FFFFFF"/>
-                    </a:solidFill>
-                  </a:tcPr>
-                </a:tc>
-                <a:tc>
-                  <a:txBody>
-                    <a:bodyPr/>
-                    <a:lstStyle/>
-                    <a:p>
-                      <a:pPr algn="ctr" indent="0" marL="0">
-                        <a:buNone/>
-                      </a:pPr>
-                      <a:r>
-                        <a:rPr lang="en-US" sz="950" b="1" dirty="0">
-                          <a:solidFill>
-                            <a:srgbClr val="262626"/>
-                          </a:solidFill>
-                          <a:latin typeface="Arial" pitchFamily="34" charset="0"/>
-                          <a:ea typeface="Arial" pitchFamily="34" charset="-122"/>
-                          <a:cs typeface="Arial" pitchFamily="34" charset="-120"/>
-                        </a:rPr>
-                        <a:t>15%</a:t>
-                      </a:r>
-                      <a:endParaRPr lang="en-US" sz="950" dirty="0">
-                        <a:latin typeface="Arial" charset="0"/>
-                        <a:ea typeface="Arial" charset="0"/>
-                        <a:cs typeface="Arial" charset="0"/>
-                      </a:endParaRPr>
-                    </a:p>
-                  </a:txBody>
-                  <a:tcPr marL="76200" marR="76200" marT="25400" marB="25400" anchor="ctr">
-                    <a:lnL w="6350" cap="flat" cmpd="sng" algn="ctr">
-                      <a:solidFill>
-                        <a:srgbClr val="BFBFBF"/>
-                      </a:solidFill>
-                      <a:prstDash val="solid"/>
-                      <a:round/>
-                      <a:headEnd type="none" w="med" len="med"/>
-                      <a:tailEnd type="none" w="med" len="med"/>
-                    </a:lnL>
-                    <a:lnR w="6350" cap="flat" cmpd="sng" algn="ctr">
-                      <a:solidFill>
-                        <a:srgbClr val="BFBFBF"/>
-                      </a:solidFill>
-                      <a:prstDash val="solid"/>
-                      <a:round/>
-                      <a:headEnd type="none" w="med" len="med"/>
-                      <a:tailEnd type="none" w="med" len="med"/>
-                    </a:lnR>
-                    <a:lnT w="6350" cap="flat" cmpd="sng" algn="ctr">
-                      <a:solidFill>
-                        <a:srgbClr val="BFBFBF"/>
-                      </a:solidFill>
-                      <a:prstDash val="solid"/>
-                      <a:round/>
-                      <a:headEnd type="none" w="med" len="med"/>
-                      <a:tailEnd type="none" w="med" len="med"/>
-                    </a:lnT>
-                    <a:lnB w="6350" cap="flat" cmpd="sng" algn="ctr">
-                      <a:solidFill>
-                        <a:srgbClr val="BFBFBF"/>
-                      </a:solidFill>
-                      <a:prstDash val="solid"/>
-                      <a:round/>
-                      <a:headEnd type="none" w="med" len="med"/>
-                      <a:tailEnd type="none" w="med" len="med"/>
-                    </a:lnB>
-                    <a:solidFill>
-                      <a:srgbClr val="FFFFFF"/>
-                    </a:solidFill>
-                  </a:tcPr>
-                </a:tc>
-                <a:tc>
-                  <a:txBody>
-                    <a:bodyPr/>
-                    <a:lstStyle/>
-                    <a:p>
-                      <a:pPr algn="ctr" indent="0" marL="0">
-                        <a:buNone/>
-                      </a:pPr>
-                      <a:r>
-                        <a:rPr lang="en-US" sz="950" dirty="0">
-                          <a:solidFill>
-                            <a:srgbClr val="262626"/>
-                          </a:solidFill>
-                          <a:latin typeface="Arial" pitchFamily="34" charset="0"/>
-                          <a:ea typeface="Arial" pitchFamily="34" charset="-122"/>
-                          <a:cs typeface="Arial" pitchFamily="34" charset="-120"/>
-                        </a:rPr>
-                        <a:t>15</a:t>
-                      </a:r>
-                      <a:endParaRPr lang="en-US" sz="950" dirty="0">
-                        <a:latin typeface="Arial" charset="0"/>
-                        <a:ea typeface="Arial" charset="0"/>
-                        <a:cs typeface="Arial" charset="0"/>
-                      </a:endParaRPr>
-                    </a:p>
-                  </a:txBody>
-                  <a:tcPr marL="76200" marR="76200" marT="25400" marB="25400" anchor="ctr">
-                    <a:lnL w="6350" cap="flat" cmpd="sng" algn="ctr">
-                      <a:solidFill>
-                        <a:srgbClr val="BFBFBF"/>
-                      </a:solidFill>
-                      <a:prstDash val="solid"/>
-                      <a:round/>
-                      <a:headEnd type="none" w="med" len="med"/>
-                      <a:tailEnd type="none" w="med" len="med"/>
-                    </a:lnL>
-                    <a:lnR w="6350" cap="flat" cmpd="sng" algn="ctr">
-                      <a:solidFill>
-                        <a:srgbClr val="BFBFBF"/>
-                      </a:solidFill>
-                      <a:prstDash val="solid"/>
-                      <a:round/>
-                      <a:headEnd type="none" w="med" len="med"/>
-                      <a:tailEnd type="none" w="med" len="med"/>
-                    </a:lnR>
-                    <a:lnT w="6350" cap="flat" cmpd="sng" algn="ctr">
-                      <a:solidFill>
-                        <a:srgbClr val="BFBFBF"/>
-                      </a:solidFill>
-                      <a:prstDash val="solid"/>
-                      <a:round/>
-                      <a:headEnd type="none" w="med" len="med"/>
-                      <a:tailEnd type="none" w="med" len="med"/>
-                    </a:lnT>
-                    <a:lnB w="6350" cap="flat" cmpd="sng" algn="ctr">
-                      <a:solidFill>
-                        <a:srgbClr val="BFBFBF"/>
+                        <a:srgbClr val="E3E3E3"/>
                       </a:solidFill>
                       <a:prstDash val="solid"/>
                       <a:round/>
@@ -2853,7 +2462,7 @@
                           <a:ea typeface="Arial" pitchFamily="34" charset="-122"/>
                           <a:cs typeface="Arial" pitchFamily="34" charset="-120"/>
                         </a:rPr>
-                        <a:t>The AI foundry: TSMC, MediaTek, Delta</a:t>
+                        <a:t>Taiwan: the AI foundry</a:t>
                       </a:r>
                       <a:endParaRPr lang="en-US" sz="950" dirty="0">
                         <a:latin typeface="Arial" charset="0"/>
@@ -2862,10 +2471,10 @@
                       </a:endParaRPr>
                     </a:p>
                   </a:txBody>
-                  <a:tcPr marL="76200" marR="76200" marT="25400" marB="25400" anchor="ctr">
+                  <a:tcPr marL="50800" marR="50800" marT="12700" marB="12700" anchor="ctr">
                     <a:lnL w="6350" cap="flat" cmpd="sng" algn="ctr">
                       <a:solidFill>
-                        <a:srgbClr val="BFBFBF"/>
+                        <a:srgbClr val="E3E3E3"/>
                       </a:solidFill>
                       <a:prstDash val="solid"/>
                       <a:round/>
@@ -2874,7 +2483,7 @@
                     </a:lnL>
                     <a:lnR w="6350" cap="flat" cmpd="sng" algn="ctr">
                       <a:solidFill>
-                        <a:srgbClr val="BFBFBF"/>
+                        <a:srgbClr val="E3E3E3"/>
                       </a:solidFill>
                       <a:prstDash val="solid"/>
                       <a:round/>
@@ -2883,7 +2492,7 @@
                     </a:lnR>
                     <a:lnT w="6350" cap="flat" cmpd="sng" algn="ctr">
                       <a:solidFill>
-                        <a:srgbClr val="BFBFBF"/>
+                        <a:srgbClr val="E3E3E3"/>
                       </a:solidFill>
                       <a:prstDash val="solid"/>
                       <a:round/>
@@ -2892,7 +2501,75 @@
                     </a:lnT>
                     <a:lnB w="6350" cap="flat" cmpd="sng" algn="ctr">
                       <a:solidFill>
-                        <a:srgbClr val="BFBFBF"/>
+                        <a:srgbClr val="E3E3E3"/>
+                      </a:solidFill>
+                      <a:prstDash val="solid"/>
+                      <a:round/>
+                      <a:headEnd type="none" w="med" len="med"/>
+                      <a:tailEnd type="none" w="med" len="med"/>
+                    </a:lnB>
+                    <a:solidFill>
+                      <a:srgbClr val="FFFFFF"/>
+                    </a:solidFill>
+                  </a:tcPr>
+                </a:tc>
+                <a:tc>
+                  <a:txBody>
+                    <a:bodyPr/>
+                    <a:lstStyle/>
+                    <a:p>
+                      <a:pPr algn="r" indent="0" marL="0">
+                        <a:buNone/>
+                      </a:pPr>
+                      <a:r>
+                        <a:rPr lang="en-US" sz="950" b="1" dirty="0">
+                          <a:solidFill>
+                            <a:srgbClr val="262626"/>
+                          </a:solidFill>
+                          <a:latin typeface="Arial" pitchFamily="34" charset="0"/>
+                          <a:ea typeface="Arial" pitchFamily="34" charset="-122"/>
+                          <a:cs typeface="Arial" pitchFamily="34" charset="-120"/>
+                        </a:rPr>
+                        <a:t>15%</a:t>
+                      </a:r>
+                      <a:endParaRPr lang="en-US" sz="950" dirty="0">
+                        <a:latin typeface="Arial" charset="0"/>
+                        <a:ea typeface="Arial" charset="0"/>
+                        <a:cs typeface="Arial" charset="0"/>
+                      </a:endParaRPr>
+                    </a:p>
+                  </a:txBody>
+                  <a:tcPr marL="50800" marR="50800" marT="12700" marB="12700" anchor="ctr">
+                    <a:lnL w="6350" cap="flat" cmpd="sng" algn="ctr">
+                      <a:solidFill>
+                        <a:srgbClr val="E3E3E3"/>
+                      </a:solidFill>
+                      <a:prstDash val="solid"/>
+                      <a:round/>
+                      <a:headEnd type="none" w="med" len="med"/>
+                      <a:tailEnd type="none" w="med" len="med"/>
+                    </a:lnL>
+                    <a:lnR w="6350" cap="flat" cmpd="sng" algn="ctr">
+                      <a:solidFill>
+                        <a:srgbClr val="E3E3E3"/>
+                      </a:solidFill>
+                      <a:prstDash val="solid"/>
+                      <a:round/>
+                      <a:headEnd type="none" w="med" len="med"/>
+                      <a:tailEnd type="none" w="med" len="med"/>
+                    </a:lnR>
+                    <a:lnT w="6350" cap="flat" cmpd="sng" algn="ctr">
+                      <a:solidFill>
+                        <a:srgbClr val="E3E3E3"/>
+                      </a:solidFill>
+                      <a:prstDash val="solid"/>
+                      <a:round/>
+                      <a:headEnd type="none" w="med" len="med"/>
+                      <a:tailEnd type="none" w="med" len="med"/>
+                    </a:lnT>
+                    <a:lnB w="6350" cap="flat" cmpd="sng" algn="ctr">
+                      <a:solidFill>
+                        <a:srgbClr val="E3E3E3"/>
                       </a:solidFill>
                       <a:prstDash val="solid"/>
                       <a:round/>
@@ -2905,7 +2582,75 @@
                   </a:tcPr>
                 </a:tc>
               </a:tr>
-              <a:tr h="566928">
+              <a:tr h="329184">
+                <a:tc>
+                  <a:txBody>
+                    <a:bodyPr/>
+                    <a:lstStyle/>
+                    <a:p>
+                      <a:pPr algn="ctr" indent="0" marL="0">
+                        <a:buNone/>
+                      </a:pPr>
+                      <a:r>
+                        <a:rPr lang="en-US" sz="1200" dirty="0">
+                          <a:solidFill>
+                            <a:srgbClr val="A6A6A6"/>
+                          </a:solidFill>
+                          <a:latin typeface="Arial" pitchFamily="34" charset="0"/>
+                          <a:ea typeface="Arial" pitchFamily="34" charset="-122"/>
+                          <a:cs typeface="Arial" pitchFamily="34" charset="-120"/>
+                        </a:rPr>
+                        <a:t>■</a:t>
+                      </a:r>
+                      <a:endParaRPr lang="en-US" sz="1200" dirty="0">
+                        <a:latin typeface="Arial" charset="0"/>
+                        <a:ea typeface="Arial" charset="0"/>
+                        <a:cs typeface="Arial" charset="0"/>
+                      </a:endParaRPr>
+                    </a:p>
+                  </a:txBody>
+                  <a:tcPr marL="50800" marR="50800" marT="12700" marB="12700" anchor="ctr">
+                    <a:lnL w="6350" cap="flat" cmpd="sng" algn="ctr">
+                      <a:solidFill>
+                        <a:srgbClr val="E3E3E3"/>
+                      </a:solidFill>
+                      <a:prstDash val="solid"/>
+                      <a:round/>
+                      <a:headEnd type="none" w="med" len="med"/>
+                      <a:tailEnd type="none" w="med" len="med"/>
+                    </a:lnL>
+                    <a:lnR w="6350" cap="flat" cmpd="sng" algn="ctr">
+                      <a:solidFill>
+                        <a:srgbClr val="E3E3E3"/>
+                      </a:solidFill>
+                      <a:prstDash val="solid"/>
+                      <a:round/>
+                      <a:headEnd type="none" w="med" len="med"/>
+                      <a:tailEnd type="none" w="med" len="med"/>
+                    </a:lnR>
+                    <a:lnT w="6350" cap="flat" cmpd="sng" algn="ctr">
+                      <a:solidFill>
+                        <a:srgbClr val="E3E3E3"/>
+                      </a:solidFill>
+                      <a:prstDash val="solid"/>
+                      <a:round/>
+                      <a:headEnd type="none" w="med" len="med"/>
+                      <a:tailEnd type="none" w="med" len="med"/>
+                    </a:lnT>
+                    <a:lnB w="6350" cap="flat" cmpd="sng" algn="ctr">
+                      <a:solidFill>
+                        <a:srgbClr val="E3E3E3"/>
+                      </a:solidFill>
+                      <a:prstDash val="solid"/>
+                      <a:round/>
+                      <a:headEnd type="none" w="med" len="med"/>
+                      <a:tailEnd type="none" w="med" len="med"/>
+                    </a:lnB>
+                    <a:solidFill>
+                      <a:srgbClr val="FFFFFF"/>
+                    </a:solidFill>
+                  </a:tcPr>
+                </a:tc>
                 <a:tc>
                   <a:txBody>
                     <a:bodyPr/>
@@ -2931,32 +2676,11 @@
                         <a:cs typeface="Arial" charset="0"/>
                       </a:endParaRPr>
                     </a:p>
-                    <a:p>
-                      <a:pPr indent="0" marL="0">
-                        <a:buNone/>
-                      </a:pPr>
-                      <a:r>
-                        <a:rPr lang="en-US" sz="800" dirty="0">
-                          <a:solidFill>
-                            <a:srgbClr val="595959"/>
-                          </a:solidFill>
-                          <a:latin typeface="Arial" pitchFamily="34" charset="0"/>
-                          <a:ea typeface="Arial" pitchFamily="34" charset="-122"/>
-                          <a:cs typeface="Arial" pitchFamily="34" charset="-120"/>
-                        </a:rPr>
-                        <a:t>Global X Japan Semiconductor ETF</a:t>
-                      </a:r>
-                      <a:endParaRPr lang="en-US" sz="950" dirty="0">
-                        <a:latin typeface="Arial" charset="0"/>
-                        <a:ea typeface="Arial" charset="0"/>
-                        <a:cs typeface="Arial" charset="0"/>
-                      </a:endParaRPr>
-                    </a:p>
                   </a:txBody>
-                  <a:tcPr marL="76200" marR="76200" marT="25400" marB="25400" anchor="ctr">
+                  <a:tcPr marL="50800" marR="50800" marT="12700" marB="12700" anchor="ctr">
                     <a:lnL w="6350" cap="flat" cmpd="sng" algn="ctr">
                       <a:solidFill>
-                        <a:srgbClr val="BFBFBF"/>
+                        <a:srgbClr val="E3E3E3"/>
                       </a:solidFill>
                       <a:prstDash val="solid"/>
                       <a:round/>
@@ -2965,7 +2689,7 @@
                     </a:lnL>
                     <a:lnR w="6350" cap="flat" cmpd="sng" algn="ctr">
                       <a:solidFill>
-                        <a:srgbClr val="BFBFBF"/>
+                        <a:srgbClr val="E3E3E3"/>
                       </a:solidFill>
                       <a:prstDash val="solid"/>
                       <a:round/>
@@ -2974,7 +2698,7 @@
                     </a:lnR>
                     <a:lnT w="6350" cap="flat" cmpd="sng" algn="ctr">
                       <a:solidFill>
-                        <a:srgbClr val="BFBFBF"/>
+                        <a:srgbClr val="E3E3E3"/>
                       </a:solidFill>
                       <a:prstDash val="solid"/>
                       <a:round/>
@@ -2983,143 +2707,7 @@
                     </a:lnT>
                     <a:lnB w="6350" cap="flat" cmpd="sng" algn="ctr">
                       <a:solidFill>
-                        <a:srgbClr val="BFBFBF"/>
-                      </a:solidFill>
-                      <a:prstDash val="solid"/>
-                      <a:round/>
-                      <a:headEnd type="none" w="med" len="med"/>
-                      <a:tailEnd type="none" w="med" len="med"/>
-                    </a:lnB>
-                    <a:solidFill>
-                      <a:srgbClr val="FFFFFF"/>
-                    </a:solidFill>
-                  </a:tcPr>
-                </a:tc>
-                <a:tc>
-                  <a:txBody>
-                    <a:bodyPr/>
-                    <a:lstStyle/>
-                    <a:p>
-                      <a:pPr algn="ctr" indent="0" marL="0">
-                        <a:buNone/>
-                      </a:pPr>
-                      <a:r>
-                        <a:rPr lang="en-US" sz="950" b="1" dirty="0">
-                          <a:solidFill>
-                            <a:srgbClr val="262626"/>
-                          </a:solidFill>
-                          <a:latin typeface="Arial" pitchFamily="34" charset="0"/>
-                          <a:ea typeface="Arial" pitchFamily="34" charset="-122"/>
-                          <a:cs typeface="Arial" pitchFamily="34" charset="-120"/>
-                        </a:rPr>
-                        <a:t>15%</a:t>
-                      </a:r>
-                      <a:endParaRPr lang="en-US" sz="950" dirty="0">
-                        <a:latin typeface="Arial" charset="0"/>
-                        <a:ea typeface="Arial" charset="0"/>
-                        <a:cs typeface="Arial" charset="0"/>
-                      </a:endParaRPr>
-                    </a:p>
-                  </a:txBody>
-                  <a:tcPr marL="76200" marR="76200" marT="25400" marB="25400" anchor="ctr">
-                    <a:lnL w="6350" cap="flat" cmpd="sng" algn="ctr">
-                      <a:solidFill>
-                        <a:srgbClr val="BFBFBF"/>
-                      </a:solidFill>
-                      <a:prstDash val="solid"/>
-                      <a:round/>
-                      <a:headEnd type="none" w="med" len="med"/>
-                      <a:tailEnd type="none" w="med" len="med"/>
-                    </a:lnL>
-                    <a:lnR w="6350" cap="flat" cmpd="sng" algn="ctr">
-                      <a:solidFill>
-                        <a:srgbClr val="BFBFBF"/>
-                      </a:solidFill>
-                      <a:prstDash val="solid"/>
-                      <a:round/>
-                      <a:headEnd type="none" w="med" len="med"/>
-                      <a:tailEnd type="none" w="med" len="med"/>
-                    </a:lnR>
-                    <a:lnT w="6350" cap="flat" cmpd="sng" algn="ctr">
-                      <a:solidFill>
-                        <a:srgbClr val="BFBFBF"/>
-                      </a:solidFill>
-                      <a:prstDash val="solid"/>
-                      <a:round/>
-                      <a:headEnd type="none" w="med" len="med"/>
-                      <a:tailEnd type="none" w="med" len="med"/>
-                    </a:lnT>
-                    <a:lnB w="6350" cap="flat" cmpd="sng" algn="ctr">
-                      <a:solidFill>
-                        <a:srgbClr val="BFBFBF"/>
-                      </a:solidFill>
-                      <a:prstDash val="solid"/>
-                      <a:round/>
-                      <a:headEnd type="none" w="med" len="med"/>
-                      <a:tailEnd type="none" w="med" len="med"/>
-                    </a:lnB>
-                    <a:solidFill>
-                      <a:srgbClr val="FFFFFF"/>
-                    </a:solidFill>
-                  </a:tcPr>
-                </a:tc>
-                <a:tc>
-                  <a:txBody>
-                    <a:bodyPr/>
-                    <a:lstStyle/>
-                    <a:p>
-                      <a:pPr algn="ctr" indent="0" marL="0">
-                        <a:buNone/>
-                      </a:pPr>
-                      <a:r>
-                        <a:rPr lang="en-US" sz="950" dirty="0">
-                          <a:solidFill>
-                            <a:srgbClr val="262626"/>
-                          </a:solidFill>
-                          <a:latin typeface="Arial" pitchFamily="34" charset="0"/>
-                          <a:ea typeface="Arial" pitchFamily="34" charset="-122"/>
-                          <a:cs typeface="Arial" pitchFamily="34" charset="-120"/>
-                        </a:rPr>
-                        <a:t>15</a:t>
-                      </a:r>
-                      <a:endParaRPr lang="en-US" sz="950" dirty="0">
-                        <a:latin typeface="Arial" charset="0"/>
-                        <a:ea typeface="Arial" charset="0"/>
-                        <a:cs typeface="Arial" charset="0"/>
-                      </a:endParaRPr>
-                    </a:p>
-                  </a:txBody>
-                  <a:tcPr marL="76200" marR="76200" marT="25400" marB="25400" anchor="ctr">
-                    <a:lnL w="6350" cap="flat" cmpd="sng" algn="ctr">
-                      <a:solidFill>
-                        <a:srgbClr val="BFBFBF"/>
-                      </a:solidFill>
-                      <a:prstDash val="solid"/>
-                      <a:round/>
-                      <a:headEnd type="none" w="med" len="med"/>
-                      <a:tailEnd type="none" w="med" len="med"/>
-                    </a:lnL>
-                    <a:lnR w="6350" cap="flat" cmpd="sng" algn="ctr">
-                      <a:solidFill>
-                        <a:srgbClr val="BFBFBF"/>
-                      </a:solidFill>
-                      <a:prstDash val="solid"/>
-                      <a:round/>
-                      <a:headEnd type="none" w="med" len="med"/>
-                      <a:tailEnd type="none" w="med" len="med"/>
-                    </a:lnR>
-                    <a:lnT w="6350" cap="flat" cmpd="sng" algn="ctr">
-                      <a:solidFill>
-                        <a:srgbClr val="BFBFBF"/>
-                      </a:solidFill>
-                      <a:prstDash val="solid"/>
-                      <a:round/>
-                      <a:headEnd type="none" w="med" len="med"/>
-                      <a:tailEnd type="none" w="med" len="med"/>
-                    </a:lnT>
-                    <a:lnB w="6350" cap="flat" cmpd="sng" algn="ctr">
-                      <a:solidFill>
-                        <a:srgbClr val="BFBFBF"/>
+                        <a:srgbClr val="E3E3E3"/>
                       </a:solidFill>
                       <a:prstDash val="solid"/>
                       <a:round/>
@@ -3148,7 +2736,7 @@
                           <a:ea typeface="Arial" pitchFamily="34" charset="-122"/>
                           <a:cs typeface="Arial" pitchFamily="34" charset="-120"/>
                         </a:rPr>
-                        <a:t>Chip-making tools: Tokyo Electron, Advantest</a:t>
+                        <a:t>Japan: chip-making tools</a:t>
                       </a:r>
                       <a:endParaRPr lang="en-US" sz="950" dirty="0">
                         <a:latin typeface="Arial" charset="0"/>
@@ -3157,10 +2745,10 @@
                       </a:endParaRPr>
                     </a:p>
                   </a:txBody>
-                  <a:tcPr marL="76200" marR="76200" marT="25400" marB="25400" anchor="ctr">
+                  <a:tcPr marL="50800" marR="50800" marT="12700" marB="12700" anchor="ctr">
                     <a:lnL w="6350" cap="flat" cmpd="sng" algn="ctr">
                       <a:solidFill>
-                        <a:srgbClr val="BFBFBF"/>
+                        <a:srgbClr val="E3E3E3"/>
                       </a:solidFill>
                       <a:prstDash val="solid"/>
                       <a:round/>
@@ -3169,7 +2757,7 @@
                     </a:lnL>
                     <a:lnR w="6350" cap="flat" cmpd="sng" algn="ctr">
                       <a:solidFill>
-                        <a:srgbClr val="BFBFBF"/>
+                        <a:srgbClr val="E3E3E3"/>
                       </a:solidFill>
                       <a:prstDash val="solid"/>
                       <a:round/>
@@ -3178,7 +2766,7 @@
                     </a:lnR>
                     <a:lnT w="6350" cap="flat" cmpd="sng" algn="ctr">
                       <a:solidFill>
-                        <a:srgbClr val="BFBFBF"/>
+                        <a:srgbClr val="E3E3E3"/>
                       </a:solidFill>
                       <a:prstDash val="solid"/>
                       <a:round/>
@@ -3187,7 +2775,75 @@
                     </a:lnT>
                     <a:lnB w="6350" cap="flat" cmpd="sng" algn="ctr">
                       <a:solidFill>
-                        <a:srgbClr val="BFBFBF"/>
+                        <a:srgbClr val="E3E3E3"/>
+                      </a:solidFill>
+                      <a:prstDash val="solid"/>
+                      <a:round/>
+                      <a:headEnd type="none" w="med" len="med"/>
+                      <a:tailEnd type="none" w="med" len="med"/>
+                    </a:lnB>
+                    <a:solidFill>
+                      <a:srgbClr val="FFFFFF"/>
+                    </a:solidFill>
+                  </a:tcPr>
+                </a:tc>
+                <a:tc>
+                  <a:txBody>
+                    <a:bodyPr/>
+                    <a:lstStyle/>
+                    <a:p>
+                      <a:pPr algn="r" indent="0" marL="0">
+                        <a:buNone/>
+                      </a:pPr>
+                      <a:r>
+                        <a:rPr lang="en-US" sz="950" b="1" dirty="0">
+                          <a:solidFill>
+                            <a:srgbClr val="262626"/>
+                          </a:solidFill>
+                          <a:latin typeface="Arial" pitchFamily="34" charset="0"/>
+                          <a:ea typeface="Arial" pitchFamily="34" charset="-122"/>
+                          <a:cs typeface="Arial" pitchFamily="34" charset="-120"/>
+                        </a:rPr>
+                        <a:t>15%</a:t>
+                      </a:r>
+                      <a:endParaRPr lang="en-US" sz="950" dirty="0">
+                        <a:latin typeface="Arial" charset="0"/>
+                        <a:ea typeface="Arial" charset="0"/>
+                        <a:cs typeface="Arial" charset="0"/>
+                      </a:endParaRPr>
+                    </a:p>
+                  </a:txBody>
+                  <a:tcPr marL="50800" marR="50800" marT="12700" marB="12700" anchor="ctr">
+                    <a:lnL w="6350" cap="flat" cmpd="sng" algn="ctr">
+                      <a:solidFill>
+                        <a:srgbClr val="E3E3E3"/>
+                      </a:solidFill>
+                      <a:prstDash val="solid"/>
+                      <a:round/>
+                      <a:headEnd type="none" w="med" len="med"/>
+                      <a:tailEnd type="none" w="med" len="med"/>
+                    </a:lnL>
+                    <a:lnR w="6350" cap="flat" cmpd="sng" algn="ctr">
+                      <a:solidFill>
+                        <a:srgbClr val="E3E3E3"/>
+                      </a:solidFill>
+                      <a:prstDash val="solid"/>
+                      <a:round/>
+                      <a:headEnd type="none" w="med" len="med"/>
+                      <a:tailEnd type="none" w="med" len="med"/>
+                    </a:lnR>
+                    <a:lnT w="6350" cap="flat" cmpd="sng" algn="ctr">
+                      <a:solidFill>
+                        <a:srgbClr val="E3E3E3"/>
+                      </a:solidFill>
+                      <a:prstDash val="solid"/>
+                      <a:round/>
+                      <a:headEnd type="none" w="med" len="med"/>
+                      <a:tailEnd type="none" w="med" len="med"/>
+                    </a:lnT>
+                    <a:lnB w="6350" cap="flat" cmpd="sng" algn="ctr">
+                      <a:solidFill>
+                        <a:srgbClr val="E3E3E3"/>
                       </a:solidFill>
                       <a:prstDash val="solid"/>
                       <a:round/>
@@ -3200,7 +2856,75 @@
                   </a:tcPr>
                 </a:tc>
               </a:tr>
-              <a:tr h="566928">
+              <a:tr h="329184">
+                <a:tc>
+                  <a:txBody>
+                    <a:bodyPr/>
+                    <a:lstStyle/>
+                    <a:p>
+                      <a:pPr algn="ctr" indent="0" marL="0">
+                        <a:buNone/>
+                      </a:pPr>
+                      <a:r>
+                        <a:rPr lang="en-US" sz="1200" dirty="0">
+                          <a:solidFill>
+                            <a:srgbClr val="2E9E44"/>
+                          </a:solidFill>
+                          <a:latin typeface="Arial" pitchFamily="34" charset="0"/>
+                          <a:ea typeface="Arial" pitchFamily="34" charset="-122"/>
+                          <a:cs typeface="Arial" pitchFamily="34" charset="-120"/>
+                        </a:rPr>
+                        <a:t>■</a:t>
+                      </a:r>
+                      <a:endParaRPr lang="en-US" sz="1200" dirty="0">
+                        <a:latin typeface="Arial" charset="0"/>
+                        <a:ea typeface="Arial" charset="0"/>
+                        <a:cs typeface="Arial" charset="0"/>
+                      </a:endParaRPr>
+                    </a:p>
+                  </a:txBody>
+                  <a:tcPr marL="50800" marR="50800" marT="12700" marB="12700" anchor="ctr">
+                    <a:lnL w="6350" cap="flat" cmpd="sng" algn="ctr">
+                      <a:solidFill>
+                        <a:srgbClr val="E3E3E3"/>
+                      </a:solidFill>
+                      <a:prstDash val="solid"/>
+                      <a:round/>
+                      <a:headEnd type="none" w="med" len="med"/>
+                      <a:tailEnd type="none" w="med" len="med"/>
+                    </a:lnL>
+                    <a:lnR w="6350" cap="flat" cmpd="sng" algn="ctr">
+                      <a:solidFill>
+                        <a:srgbClr val="E3E3E3"/>
+                      </a:solidFill>
+                      <a:prstDash val="solid"/>
+                      <a:round/>
+                      <a:headEnd type="none" w="med" len="med"/>
+                      <a:tailEnd type="none" w="med" len="med"/>
+                    </a:lnR>
+                    <a:lnT w="6350" cap="flat" cmpd="sng" algn="ctr">
+                      <a:solidFill>
+                        <a:srgbClr val="E3E3E3"/>
+                      </a:solidFill>
+                      <a:prstDash val="solid"/>
+                      <a:round/>
+                      <a:headEnd type="none" w="med" len="med"/>
+                      <a:tailEnd type="none" w="med" len="med"/>
+                    </a:lnT>
+                    <a:lnB w="6350" cap="flat" cmpd="sng" algn="ctr">
+                      <a:solidFill>
+                        <a:srgbClr val="E3E3E3"/>
+                      </a:solidFill>
+                      <a:prstDash val="solid"/>
+                      <a:round/>
+                      <a:headEnd type="none" w="med" len="med"/>
+                      <a:tailEnd type="none" w="med" len="med"/>
+                    </a:lnB>
+                    <a:solidFill>
+                      <a:srgbClr val="FFFFFF"/>
+                    </a:solidFill>
+                  </a:tcPr>
+                </a:tc>
                 <a:tc>
                   <a:txBody>
                     <a:bodyPr/>
@@ -3226,32 +2950,11 @@
                         <a:cs typeface="Arial" charset="0"/>
                       </a:endParaRPr>
                     </a:p>
-                    <a:p>
-                      <a:pPr indent="0" marL="0">
-                        <a:buNone/>
-                      </a:pPr>
-                      <a:r>
-                        <a:rPr lang="en-US" sz="800" dirty="0">
-                          <a:solidFill>
-                            <a:srgbClr val="595959"/>
-                          </a:solidFill>
-                          <a:latin typeface="Arial" pitchFamily="34" charset="0"/>
-                          <a:ea typeface="Arial" pitchFamily="34" charset="-122"/>
-                          <a:cs typeface="Arial" pitchFamily="34" charset="-120"/>
-                        </a:rPr>
-                        <a:t>Cathay Taiwan ESG Sustainability High Dividend ETF</a:t>
-                      </a:r>
-                      <a:endParaRPr lang="en-US" sz="950" dirty="0">
-                        <a:latin typeface="Arial" charset="0"/>
-                        <a:ea typeface="Arial" charset="0"/>
-                        <a:cs typeface="Arial" charset="0"/>
-                      </a:endParaRPr>
-                    </a:p>
                   </a:txBody>
-                  <a:tcPr marL="76200" marR="76200" marT="25400" marB="25400" anchor="ctr">
+                  <a:tcPr marL="50800" marR="50800" marT="12700" marB="12700" anchor="ctr">
                     <a:lnL w="6350" cap="flat" cmpd="sng" algn="ctr">
                       <a:solidFill>
-                        <a:srgbClr val="BFBFBF"/>
+                        <a:srgbClr val="E3E3E3"/>
                       </a:solidFill>
                       <a:prstDash val="solid"/>
                       <a:round/>
@@ -3260,7 +2963,7 @@
                     </a:lnL>
                     <a:lnR w="6350" cap="flat" cmpd="sng" algn="ctr">
                       <a:solidFill>
-                        <a:srgbClr val="BFBFBF"/>
+                        <a:srgbClr val="E3E3E3"/>
                       </a:solidFill>
                       <a:prstDash val="solid"/>
                       <a:round/>
@@ -3269,7 +2972,7 @@
                     </a:lnR>
                     <a:lnT w="6350" cap="flat" cmpd="sng" algn="ctr">
                       <a:solidFill>
-                        <a:srgbClr val="BFBFBF"/>
+                        <a:srgbClr val="E3E3E3"/>
                       </a:solidFill>
                       <a:prstDash val="solid"/>
                       <a:round/>
@@ -3278,143 +2981,7 @@
                     </a:lnT>
                     <a:lnB w="6350" cap="flat" cmpd="sng" algn="ctr">
                       <a:solidFill>
-                        <a:srgbClr val="BFBFBF"/>
-                      </a:solidFill>
-                      <a:prstDash val="solid"/>
-                      <a:round/>
-                      <a:headEnd type="none" w="med" len="med"/>
-                      <a:tailEnd type="none" w="med" len="med"/>
-                    </a:lnB>
-                    <a:solidFill>
-                      <a:srgbClr val="FFFFFF"/>
-                    </a:solidFill>
-                  </a:tcPr>
-                </a:tc>
-                <a:tc>
-                  <a:txBody>
-                    <a:bodyPr/>
-                    <a:lstStyle/>
-                    <a:p>
-                      <a:pPr algn="ctr" indent="0" marL="0">
-                        <a:buNone/>
-                      </a:pPr>
-                      <a:r>
-                        <a:rPr lang="en-US" sz="950" b="1" dirty="0">
-                          <a:solidFill>
-                            <a:srgbClr val="262626"/>
-                          </a:solidFill>
-                          <a:latin typeface="Arial" pitchFamily="34" charset="0"/>
-                          <a:ea typeface="Arial" pitchFamily="34" charset="-122"/>
-                          <a:cs typeface="Arial" pitchFamily="34" charset="-120"/>
-                        </a:rPr>
-                        <a:t>15%</a:t>
-                      </a:r>
-                      <a:endParaRPr lang="en-US" sz="950" dirty="0">
-                        <a:latin typeface="Arial" charset="0"/>
-                        <a:ea typeface="Arial" charset="0"/>
-                        <a:cs typeface="Arial" charset="0"/>
-                      </a:endParaRPr>
-                    </a:p>
-                  </a:txBody>
-                  <a:tcPr marL="76200" marR="76200" marT="25400" marB="25400" anchor="ctr">
-                    <a:lnL w="6350" cap="flat" cmpd="sng" algn="ctr">
-                      <a:solidFill>
-                        <a:srgbClr val="BFBFBF"/>
-                      </a:solidFill>
-                      <a:prstDash val="solid"/>
-                      <a:round/>
-                      <a:headEnd type="none" w="med" len="med"/>
-                      <a:tailEnd type="none" w="med" len="med"/>
-                    </a:lnL>
-                    <a:lnR w="6350" cap="flat" cmpd="sng" algn="ctr">
-                      <a:solidFill>
-                        <a:srgbClr val="BFBFBF"/>
-                      </a:solidFill>
-                      <a:prstDash val="solid"/>
-                      <a:round/>
-                      <a:headEnd type="none" w="med" len="med"/>
-                      <a:tailEnd type="none" w="med" len="med"/>
-                    </a:lnR>
-                    <a:lnT w="6350" cap="flat" cmpd="sng" algn="ctr">
-                      <a:solidFill>
-                        <a:srgbClr val="BFBFBF"/>
-                      </a:solidFill>
-                      <a:prstDash val="solid"/>
-                      <a:round/>
-                      <a:headEnd type="none" w="med" len="med"/>
-                      <a:tailEnd type="none" w="med" len="med"/>
-                    </a:lnT>
-                    <a:lnB w="6350" cap="flat" cmpd="sng" algn="ctr">
-                      <a:solidFill>
-                        <a:srgbClr val="BFBFBF"/>
-                      </a:solidFill>
-                      <a:prstDash val="solid"/>
-                      <a:round/>
-                      <a:headEnd type="none" w="med" len="med"/>
-                      <a:tailEnd type="none" w="med" len="med"/>
-                    </a:lnB>
-                    <a:solidFill>
-                      <a:srgbClr val="FFFFFF"/>
-                    </a:solidFill>
-                  </a:tcPr>
-                </a:tc>
-                <a:tc>
-                  <a:txBody>
-                    <a:bodyPr/>
-                    <a:lstStyle/>
-                    <a:p>
-                      <a:pPr algn="ctr" indent="0" marL="0">
-                        <a:buNone/>
-                      </a:pPr>
-                      <a:r>
-                        <a:rPr lang="en-US" sz="950" dirty="0">
-                          <a:solidFill>
-                            <a:srgbClr val="262626"/>
-                          </a:solidFill>
-                          <a:latin typeface="Arial" pitchFamily="34" charset="0"/>
-                          <a:ea typeface="Arial" pitchFamily="34" charset="-122"/>
-                          <a:cs typeface="Arial" pitchFamily="34" charset="-120"/>
-                        </a:rPr>
-                        <a:t>15</a:t>
-                      </a:r>
-                      <a:endParaRPr lang="en-US" sz="950" dirty="0">
-                        <a:latin typeface="Arial" charset="0"/>
-                        <a:ea typeface="Arial" charset="0"/>
-                        <a:cs typeface="Arial" charset="0"/>
-                      </a:endParaRPr>
-                    </a:p>
-                  </a:txBody>
-                  <a:tcPr marL="76200" marR="76200" marT="25400" marB="25400" anchor="ctr">
-                    <a:lnL w="6350" cap="flat" cmpd="sng" algn="ctr">
-                      <a:solidFill>
-                        <a:srgbClr val="BFBFBF"/>
-                      </a:solidFill>
-                      <a:prstDash val="solid"/>
-                      <a:round/>
-                      <a:headEnd type="none" w="med" len="med"/>
-                      <a:tailEnd type="none" w="med" len="med"/>
-                    </a:lnL>
-                    <a:lnR w="6350" cap="flat" cmpd="sng" algn="ctr">
-                      <a:solidFill>
-                        <a:srgbClr val="BFBFBF"/>
-                      </a:solidFill>
-                      <a:prstDash val="solid"/>
-                      <a:round/>
-                      <a:headEnd type="none" w="med" len="med"/>
-                      <a:tailEnd type="none" w="med" len="med"/>
-                    </a:lnR>
-                    <a:lnT w="6350" cap="flat" cmpd="sng" algn="ctr">
-                      <a:solidFill>
-                        <a:srgbClr val="BFBFBF"/>
-                      </a:solidFill>
-                      <a:prstDash val="solid"/>
-                      <a:round/>
-                      <a:headEnd type="none" w="med" len="med"/>
-                      <a:tailEnd type="none" w="med" len="med"/>
-                    </a:lnT>
-                    <a:lnB w="6350" cap="flat" cmpd="sng" algn="ctr">
-                      <a:solidFill>
-                        <a:srgbClr val="BFBFBF"/>
+                        <a:srgbClr val="E3E3E3"/>
                       </a:solidFill>
                       <a:prstDash val="solid"/>
                       <a:round/>
@@ -3443,7 +3010,7 @@
                           <a:ea typeface="Arial" pitchFamily="34" charset="-122"/>
                           <a:cs typeface="Arial" pitchFamily="34" charset="-120"/>
                         </a:rPr>
-                        <a:t>ESG sleeve: dividend income, lowest volatility</a:t>
+                        <a:t>ESG dividend anchor</a:t>
                       </a:r>
                       <a:endParaRPr lang="en-US" sz="950" dirty="0">
                         <a:latin typeface="Arial" charset="0"/>
@@ -3452,10 +3019,10 @@
                       </a:endParaRPr>
                     </a:p>
                   </a:txBody>
-                  <a:tcPr marL="76200" marR="76200" marT="25400" marB="25400" anchor="ctr">
+                  <a:tcPr marL="50800" marR="50800" marT="12700" marB="12700" anchor="ctr">
                     <a:lnL w="6350" cap="flat" cmpd="sng" algn="ctr">
                       <a:solidFill>
-                        <a:srgbClr val="BFBFBF"/>
+                        <a:srgbClr val="E3E3E3"/>
                       </a:solidFill>
                       <a:prstDash val="solid"/>
                       <a:round/>
@@ -3464,7 +3031,7 @@
                     </a:lnL>
                     <a:lnR w="6350" cap="flat" cmpd="sng" algn="ctr">
                       <a:solidFill>
-                        <a:srgbClr val="BFBFBF"/>
+                        <a:srgbClr val="E3E3E3"/>
                       </a:solidFill>
                       <a:prstDash val="solid"/>
                       <a:round/>
@@ -3473,7 +3040,7 @@
                     </a:lnR>
                     <a:lnT w="6350" cap="flat" cmpd="sng" algn="ctr">
                       <a:solidFill>
-                        <a:srgbClr val="BFBFBF"/>
+                        <a:srgbClr val="E3E3E3"/>
                       </a:solidFill>
                       <a:prstDash val="solid"/>
                       <a:round/>
@@ -3482,7 +3049,75 @@
                     </a:lnT>
                     <a:lnB w="6350" cap="flat" cmpd="sng" algn="ctr">
                       <a:solidFill>
-                        <a:srgbClr val="BFBFBF"/>
+                        <a:srgbClr val="E3E3E3"/>
+                      </a:solidFill>
+                      <a:prstDash val="solid"/>
+                      <a:round/>
+                      <a:headEnd type="none" w="med" len="med"/>
+                      <a:tailEnd type="none" w="med" len="med"/>
+                    </a:lnB>
+                    <a:solidFill>
+                      <a:srgbClr val="FFFFFF"/>
+                    </a:solidFill>
+                  </a:tcPr>
+                </a:tc>
+                <a:tc>
+                  <a:txBody>
+                    <a:bodyPr/>
+                    <a:lstStyle/>
+                    <a:p>
+                      <a:pPr algn="r" indent="0" marL="0">
+                        <a:buNone/>
+                      </a:pPr>
+                      <a:r>
+                        <a:rPr lang="en-US" sz="950" b="1" dirty="0">
+                          <a:solidFill>
+                            <a:srgbClr val="262626"/>
+                          </a:solidFill>
+                          <a:latin typeface="Arial" pitchFamily="34" charset="0"/>
+                          <a:ea typeface="Arial" pitchFamily="34" charset="-122"/>
+                          <a:cs typeface="Arial" pitchFamily="34" charset="-120"/>
+                        </a:rPr>
+                        <a:t>15%</a:t>
+                      </a:r>
+                      <a:endParaRPr lang="en-US" sz="950" dirty="0">
+                        <a:latin typeface="Arial" charset="0"/>
+                        <a:ea typeface="Arial" charset="0"/>
+                        <a:cs typeface="Arial" charset="0"/>
+                      </a:endParaRPr>
+                    </a:p>
+                  </a:txBody>
+                  <a:tcPr marL="50800" marR="50800" marT="12700" marB="12700" anchor="ctr">
+                    <a:lnL w="6350" cap="flat" cmpd="sng" algn="ctr">
+                      <a:solidFill>
+                        <a:srgbClr val="E3E3E3"/>
+                      </a:solidFill>
+                      <a:prstDash val="solid"/>
+                      <a:round/>
+                      <a:headEnd type="none" w="med" len="med"/>
+                      <a:tailEnd type="none" w="med" len="med"/>
+                    </a:lnL>
+                    <a:lnR w="6350" cap="flat" cmpd="sng" algn="ctr">
+                      <a:solidFill>
+                        <a:srgbClr val="E3E3E3"/>
+                      </a:solidFill>
+                      <a:prstDash val="solid"/>
+                      <a:round/>
+                      <a:headEnd type="none" w="med" len="med"/>
+                      <a:tailEnd type="none" w="med" len="med"/>
+                    </a:lnR>
+                    <a:lnT w="6350" cap="flat" cmpd="sng" algn="ctr">
+                      <a:solidFill>
+                        <a:srgbClr val="E3E3E3"/>
+                      </a:solidFill>
+                      <a:prstDash val="solid"/>
+                      <a:round/>
+                      <a:headEnd type="none" w="med" len="med"/>
+                      <a:tailEnd type="none" w="med" len="med"/>
+                    </a:lnT>
+                    <a:lnB w="6350" cap="flat" cmpd="sng" algn="ctr">
+                      <a:solidFill>
+                        <a:srgbClr val="E3E3E3"/>
                       </a:solidFill>
                       <a:prstDash val="solid"/>
                       <a:round/>
@@ -3501,14 +3136,152 @@
       </p:graphicFrame>
       <p:sp>
         <p:nvSpPr>
-          <p:cNvPr id="13" name="Text 9"/>
+          <p:cNvPr id="16" name="Shape 12"/>
+          <p:cNvSpPr/>
+          <p:nvPr/>
+        </p:nvSpPr>
+        <p:spPr>
+          <a:xfrm>
+            <a:off x="4069080" y="1325880"/>
+            <a:ext cx="5806440" cy="329184"/>
+          </a:xfrm>
+          <a:prstGeom prst="rect">
+            <a:avLst/>
+          </a:prstGeom>
+          <a:solidFill>
+            <a:srgbClr val="2C5F82"/>
+          </a:solidFill>
+          <a:ln w="12700">
+            <a:solidFill>
+              <a:srgbClr val="2C5F82"/>
+            </a:solidFill>
+            <a:prstDash val="solid"/>
+          </a:ln>
+        </p:spPr>
+      </p:sp>
+      <p:sp>
+        <p:nvSpPr>
+          <p:cNvPr id="17" name="Text 13"/>
           <p:cNvSpPr txBox="1"/>
           <p:nvPr/>
         </p:nvSpPr>
         <p:spPr>
           <a:xfrm>
-            <a:off x="4297680" y="4754880"/>
-            <a:ext cx="7434072" cy="640080"/>
+            <a:off x="4069080" y="1325880"/>
+            <a:ext cx="5806440" cy="329184"/>
+          </a:xfrm>
+          <a:prstGeom prst="rect">
+            <a:avLst/>
+          </a:prstGeom>
+          <a:noFill/>
+          <a:ln/>
+        </p:spPr>
+        <p:txBody>
+          <a:bodyPr wrap="square" lIns="0" tIns="0" rIns="0" bIns="0" rtlCol="0" anchor="ctr"/>
+          <a:lstStyle/>
+          <a:p>
+            <a:pPr algn="ctr" indent="0" marL="0">
+              <a:buNone/>
+            </a:pPr>
+            <a:r>
+              <a:rPr lang="en-US" sz="1150" b="1" dirty="0">
+                <a:solidFill>
+                  <a:srgbClr val="FFFFFF"/>
+                </a:solidFill>
+                <a:latin typeface="Arial" pitchFamily="34" charset="0"/>
+                <a:ea typeface="Arial" pitchFamily="34" charset="-122"/>
+                <a:cs typeface="Arial" pitchFamily="34" charset="-120"/>
+              </a:rPr>
+              <a:t>5-year Monte Carlo (value per USD 100,000)</a:t>
+            </a:r>
+            <a:endParaRPr lang="en-US" sz="1150" dirty="0"/>
+          </a:p>
+        </p:txBody>
+      </p:sp>
+      <p:pic>
+        <p:nvPicPr>
+          <p:cNvPr id="18" name="Image 0" descr="/home/user/natixis-case-comp/strategy/mc_checkpoints.png">    </p:cNvPr>
+          <p:cNvPicPr>
+            <a:picLocks noChangeAspect="1"/>
+          </p:cNvPicPr>
+          <p:nvPr/>
+        </p:nvPicPr>
+        <p:blipFill>
+          <a:blip r:embed="rId2"/>
+          <a:stretch>
+            <a:fillRect/>
+          </a:stretch>
+        </p:blipFill>
+        <p:spPr>
+          <a:xfrm>
+            <a:off x="4069080" y="1719072"/>
+            <a:ext cx="5806440" cy="3308320"/>
+          </a:xfrm>
+          <a:prstGeom prst="rect">
+            <a:avLst/>
+          </a:prstGeom>
+        </p:spPr>
+      </p:pic>
+      <p:sp>
+        <p:nvSpPr>
+          <p:cNvPr id="19" name="Shape 14"/>
+          <p:cNvSpPr/>
+          <p:nvPr/>
+        </p:nvSpPr>
+        <p:spPr>
+          <a:xfrm>
+            <a:off x="10058400" y="1325880"/>
+            <a:ext cx="1673352" cy="914400"/>
+          </a:xfrm>
+          <a:prstGeom prst="rect">
+            <a:avLst/>
+          </a:prstGeom>
+          <a:solidFill>
+            <a:srgbClr val="F2F2F2"/>
+          </a:solidFill>
+          <a:ln w="12700">
+            <a:solidFill>
+              <a:srgbClr val="F2F2F2"/>
+            </a:solidFill>
+            <a:prstDash val="solid"/>
+          </a:ln>
+        </p:spPr>
+      </p:sp>
+      <p:sp>
+        <p:nvSpPr>
+          <p:cNvPr id="20" name="Shape 15"/>
+          <p:cNvSpPr/>
+          <p:nvPr/>
+        </p:nvSpPr>
+        <p:spPr>
+          <a:xfrm>
+            <a:off x="10058400" y="1325880"/>
+            <a:ext cx="54864" cy="914400"/>
+          </a:xfrm>
+          <a:prstGeom prst="rect">
+            <a:avLst/>
+          </a:prstGeom>
+          <a:solidFill>
+            <a:srgbClr val="2C5F82"/>
+          </a:solidFill>
+          <a:ln w="12700">
+            <a:solidFill>
+              <a:srgbClr val="2C5F82"/>
+            </a:solidFill>
+            <a:prstDash val="solid"/>
+          </a:ln>
+        </p:spPr>
+      </p:sp>
+      <p:sp>
+        <p:nvSpPr>
+          <p:cNvPr id="21" name="Text 16"/>
+          <p:cNvSpPr txBox="1"/>
+          <p:nvPr/>
+        </p:nvSpPr>
+        <p:spPr>
+          <a:xfrm>
+            <a:off x="10168128" y="1371600"/>
+            <a:ext cx="1517904" cy="384048"/>
           </a:xfrm>
           <a:prstGeom prst="rect">
             <a:avLst/>
@@ -3524,7 +3297,7 @@
               <a:buNone/>
             </a:pPr>
             <a:r>
-              <a:rPr lang="en-US" sz="1000" b="1" dirty="0">
+              <a:rPr lang="en-US" sz="1700" b="1" dirty="0">
                 <a:solidFill>
                   <a:srgbClr val="2C5F82"/>
                 </a:solidFill>
@@ -3532,29 +3305,438 @@
                 <a:ea typeface="Arial" pitchFamily="34" charset="-122"/>
                 <a:cs typeface="Arial" pitchFamily="34" charset="-120"/>
               </a:rPr>
-              <a:t>Why these weights: </a:t>
+              <a:t>$279.6k</a:t>
             </a:r>
+            <a:endParaRPr lang="en-US" sz="1700" dirty="0"/>
+          </a:p>
+        </p:txBody>
+      </p:sp>
+      <p:sp>
+        <p:nvSpPr>
+          <p:cNvPr id="22" name="Text 17"/>
+          <p:cNvSpPr txBox="1"/>
+          <p:nvPr/>
+        </p:nvSpPr>
+        <p:spPr>
+          <a:xfrm>
+            <a:off x="10168128" y="1764792"/>
+            <a:ext cx="1517904" cy="457200"/>
+          </a:xfrm>
+          <a:prstGeom prst="rect">
+            <a:avLst/>
+          </a:prstGeom>
+          <a:noFill/>
+          <a:ln/>
+        </p:spPr>
+        <p:txBody>
+          <a:bodyPr wrap="square" lIns="0" tIns="0" rIns="0" bIns="0" rtlCol="0" anchor="t"/>
+          <a:lstStyle/>
+          <a:p>
             <a:pPr indent="0" marL="0">
               <a:buNone/>
             </a:pPr>
             <a:r>
-              <a:rPr lang="en-US" sz="1000" dirty="0">
+              <a:rPr lang="en-US" sz="850" dirty="0">
                 <a:solidFill>
-                  <a:srgbClr val="262626"/>
+                  <a:srgbClr val="595959"/>
                 </a:solidFill>
                 <a:latin typeface="Arial" pitchFamily="34" charset="0"/>
                 <a:ea typeface="Arial" pitchFamily="34" charset="-122"/>
                 <a:cs typeface="Arial" pitchFamily="34" charset="-120"/>
               </a:rPr>
-              <a:t>the largest slice (35%) goes to the broadest chip basket; Korea (20%) adds memory, the tightest part of the AI supply chain; Taiwan, Japan and the ESG dividend sleeve (15% each) complete the chain and steady the ride.</a:t>
+              <a:t>Median, Year 5 (2.8×, +22.8% a year)</a:t>
             </a:r>
-            <a:endParaRPr lang="en-US" sz="1000" dirty="0"/>
+            <a:endParaRPr lang="en-US" sz="850" dirty="0"/>
           </a:p>
         </p:txBody>
       </p:sp>
       <p:sp>
         <p:nvSpPr>
-          <p:cNvPr id="14" name="Shape 10"/>
+          <p:cNvPr id="23" name="Shape 18"/>
+          <p:cNvSpPr/>
+          <p:nvPr/>
+        </p:nvSpPr>
+        <p:spPr>
+          <a:xfrm>
+            <a:off x="10058400" y="2331720"/>
+            <a:ext cx="1673352" cy="914400"/>
+          </a:xfrm>
+          <a:prstGeom prst="rect">
+            <a:avLst/>
+          </a:prstGeom>
+          <a:solidFill>
+            <a:srgbClr val="F2F2F2"/>
+          </a:solidFill>
+          <a:ln w="12700">
+            <a:solidFill>
+              <a:srgbClr val="F2F2F2"/>
+            </a:solidFill>
+            <a:prstDash val="solid"/>
+          </a:ln>
+        </p:spPr>
+      </p:sp>
+      <p:sp>
+        <p:nvSpPr>
+          <p:cNvPr id="24" name="Shape 19"/>
+          <p:cNvSpPr/>
+          <p:nvPr/>
+        </p:nvSpPr>
+        <p:spPr>
+          <a:xfrm>
+            <a:off x="10058400" y="2331720"/>
+            <a:ext cx="54864" cy="914400"/>
+          </a:xfrm>
+          <a:prstGeom prst="rect">
+            <a:avLst/>
+          </a:prstGeom>
+          <a:solidFill>
+            <a:srgbClr val="C0392B"/>
+          </a:solidFill>
+          <a:ln w="12700">
+            <a:solidFill>
+              <a:srgbClr val="C0392B"/>
+            </a:solidFill>
+            <a:prstDash val="solid"/>
+          </a:ln>
+        </p:spPr>
+      </p:sp>
+      <p:sp>
+        <p:nvSpPr>
+          <p:cNvPr id="25" name="Text 20"/>
+          <p:cNvSpPr txBox="1"/>
+          <p:nvPr/>
+        </p:nvSpPr>
+        <p:spPr>
+          <a:xfrm>
+            <a:off x="10168128" y="2377440"/>
+            <a:ext cx="1517904" cy="384048"/>
+          </a:xfrm>
+          <a:prstGeom prst="rect">
+            <a:avLst/>
+          </a:prstGeom>
+          <a:noFill/>
+          <a:ln/>
+        </p:spPr>
+        <p:txBody>
+          <a:bodyPr wrap="square" lIns="0" tIns="0" rIns="0" bIns="0" rtlCol="0" anchor="t"/>
+          <a:lstStyle/>
+          <a:p>
+            <a:pPr indent="0" marL="0">
+              <a:buNone/>
+            </a:pPr>
+            <a:r>
+              <a:rPr lang="en-US" sz="1700" b="1" dirty="0">
+                <a:solidFill>
+                  <a:srgbClr val="C0392B"/>
+                </a:solidFill>
+                <a:latin typeface="Arial" pitchFamily="34" charset="0"/>
+                <a:ea typeface="Arial" pitchFamily="34" charset="-122"/>
+                <a:cs typeface="Arial" pitchFamily="34" charset="-120"/>
+              </a:rPr>
+              <a:t>$103.6k</a:t>
+            </a:r>
+            <a:endParaRPr lang="en-US" sz="1700" dirty="0"/>
+          </a:p>
+        </p:txBody>
+      </p:sp>
+      <p:sp>
+        <p:nvSpPr>
+          <p:cNvPr id="26" name="Text 21"/>
+          <p:cNvSpPr txBox="1"/>
+          <p:nvPr/>
+        </p:nvSpPr>
+        <p:spPr>
+          <a:xfrm>
+            <a:off x="10168128" y="2770632"/>
+            <a:ext cx="1517904" cy="457200"/>
+          </a:xfrm>
+          <a:prstGeom prst="rect">
+            <a:avLst/>
+          </a:prstGeom>
+          <a:noFill/>
+          <a:ln/>
+        </p:spPr>
+        <p:txBody>
+          <a:bodyPr wrap="square" lIns="0" tIns="0" rIns="0" bIns="0" rtlCol="0" anchor="t"/>
+          <a:lstStyle/>
+          <a:p>
+            <a:pPr indent="0" marL="0">
+              <a:buNone/>
+            </a:pPr>
+            <a:r>
+              <a:rPr lang="en-US" sz="850" dirty="0">
+                <a:solidFill>
+                  <a:srgbClr val="595959"/>
+                </a:solidFill>
+                <a:latin typeface="Arial" pitchFamily="34" charset="0"/>
+                <a:ea typeface="Arial" pitchFamily="34" charset="-122"/>
+                <a:cs typeface="Arial" pitchFamily="34" charset="-120"/>
+              </a:rPr>
+              <a:t>Bearish 5th percentile: above the start</a:t>
+            </a:r>
+            <a:endParaRPr lang="en-US" sz="850" dirty="0"/>
+          </a:p>
+        </p:txBody>
+      </p:sp>
+      <p:sp>
+        <p:nvSpPr>
+          <p:cNvPr id="27" name="Shape 22"/>
+          <p:cNvSpPr/>
+          <p:nvPr/>
+        </p:nvSpPr>
+        <p:spPr>
+          <a:xfrm>
+            <a:off x="10058400" y="3337560"/>
+            <a:ext cx="1673352" cy="914400"/>
+          </a:xfrm>
+          <a:prstGeom prst="rect">
+            <a:avLst/>
+          </a:prstGeom>
+          <a:solidFill>
+            <a:srgbClr val="F2F2F2"/>
+          </a:solidFill>
+          <a:ln w="12700">
+            <a:solidFill>
+              <a:srgbClr val="F2F2F2"/>
+            </a:solidFill>
+            <a:prstDash val="solid"/>
+          </a:ln>
+        </p:spPr>
+      </p:sp>
+      <p:sp>
+        <p:nvSpPr>
+          <p:cNvPr id="28" name="Shape 23"/>
+          <p:cNvSpPr/>
+          <p:nvPr/>
+        </p:nvSpPr>
+        <p:spPr>
+          <a:xfrm>
+            <a:off x="10058400" y="3337560"/>
+            <a:ext cx="54864" cy="914400"/>
+          </a:xfrm>
+          <a:prstGeom prst="rect">
+            <a:avLst/>
+          </a:prstGeom>
+          <a:solidFill>
+            <a:srgbClr val="2E9E44"/>
+          </a:solidFill>
+          <a:ln w="12700">
+            <a:solidFill>
+              <a:srgbClr val="2E9E44"/>
+            </a:solidFill>
+            <a:prstDash val="solid"/>
+          </a:ln>
+        </p:spPr>
+      </p:sp>
+      <p:sp>
+        <p:nvSpPr>
+          <p:cNvPr id="29" name="Text 24"/>
+          <p:cNvSpPr txBox="1"/>
+          <p:nvPr/>
+        </p:nvSpPr>
+        <p:spPr>
+          <a:xfrm>
+            <a:off x="10168128" y="3383280"/>
+            <a:ext cx="1517904" cy="384048"/>
+          </a:xfrm>
+          <a:prstGeom prst="rect">
+            <a:avLst/>
+          </a:prstGeom>
+          <a:noFill/>
+          <a:ln/>
+        </p:spPr>
+        <p:txBody>
+          <a:bodyPr wrap="square" lIns="0" tIns="0" rIns="0" bIns="0" rtlCol="0" anchor="t"/>
+          <a:lstStyle/>
+          <a:p>
+            <a:pPr indent="0" marL="0">
+              <a:buNone/>
+            </a:pPr>
+            <a:r>
+              <a:rPr lang="en-US" sz="1700" b="1" dirty="0">
+                <a:solidFill>
+                  <a:srgbClr val="2E9E44"/>
+                </a:solidFill>
+                <a:latin typeface="Arial" pitchFamily="34" charset="0"/>
+                <a:ea typeface="Arial" pitchFamily="34" charset="-122"/>
+                <a:cs typeface="Arial" pitchFamily="34" charset="-120"/>
+              </a:rPr>
+              <a:t>$770.5k</a:t>
+            </a:r>
+            <a:endParaRPr lang="en-US" sz="1700" dirty="0"/>
+          </a:p>
+        </p:txBody>
+      </p:sp>
+      <p:sp>
+        <p:nvSpPr>
+          <p:cNvPr id="30" name="Text 25"/>
+          <p:cNvSpPr txBox="1"/>
+          <p:nvPr/>
+        </p:nvSpPr>
+        <p:spPr>
+          <a:xfrm>
+            <a:off x="10168128" y="3776472"/>
+            <a:ext cx="1517904" cy="457200"/>
+          </a:xfrm>
+          <a:prstGeom prst="rect">
+            <a:avLst/>
+          </a:prstGeom>
+          <a:noFill/>
+          <a:ln/>
+        </p:spPr>
+        <p:txBody>
+          <a:bodyPr wrap="square" lIns="0" tIns="0" rIns="0" bIns="0" rtlCol="0" anchor="t"/>
+          <a:lstStyle/>
+          <a:p>
+            <a:pPr indent="0" marL="0">
+              <a:buNone/>
+            </a:pPr>
+            <a:r>
+              <a:rPr lang="en-US" sz="850" dirty="0">
+                <a:solidFill>
+                  <a:srgbClr val="595959"/>
+                </a:solidFill>
+                <a:latin typeface="Arial" pitchFamily="34" charset="0"/>
+                <a:ea typeface="Arial" pitchFamily="34" charset="-122"/>
+                <a:cs typeface="Arial" pitchFamily="34" charset="-120"/>
+              </a:rPr>
+              <a:t>Bullish 95th percentile (7.7×)</a:t>
+            </a:r>
+            <a:endParaRPr lang="en-US" sz="850" dirty="0"/>
+          </a:p>
+        </p:txBody>
+      </p:sp>
+      <p:sp>
+        <p:nvSpPr>
+          <p:cNvPr id="31" name="Shape 26"/>
+          <p:cNvSpPr/>
+          <p:nvPr/>
+        </p:nvSpPr>
+        <p:spPr>
+          <a:xfrm>
+            <a:off x="10058400" y="4343400"/>
+            <a:ext cx="1673352" cy="914400"/>
+          </a:xfrm>
+          <a:prstGeom prst="rect">
+            <a:avLst/>
+          </a:prstGeom>
+          <a:solidFill>
+            <a:srgbClr val="F2F2F2"/>
+          </a:solidFill>
+          <a:ln w="12700">
+            <a:solidFill>
+              <a:srgbClr val="F2F2F2"/>
+            </a:solidFill>
+            <a:prstDash val="solid"/>
+          </a:ln>
+        </p:spPr>
+      </p:sp>
+      <p:sp>
+        <p:nvSpPr>
+          <p:cNvPr id="32" name="Shape 27"/>
+          <p:cNvSpPr/>
+          <p:nvPr/>
+        </p:nvSpPr>
+        <p:spPr>
+          <a:xfrm>
+            <a:off x="10058400" y="4343400"/>
+            <a:ext cx="54864" cy="914400"/>
+          </a:xfrm>
+          <a:prstGeom prst="rect">
+            <a:avLst/>
+          </a:prstGeom>
+          <a:solidFill>
+            <a:srgbClr val="E67E22"/>
+          </a:solidFill>
+          <a:ln w="12700">
+            <a:solidFill>
+              <a:srgbClr val="E67E22"/>
+            </a:solidFill>
+            <a:prstDash val="solid"/>
+          </a:ln>
+        </p:spPr>
+      </p:sp>
+      <p:sp>
+        <p:nvSpPr>
+          <p:cNvPr id="33" name="Text 28"/>
+          <p:cNvSpPr txBox="1"/>
+          <p:nvPr/>
+        </p:nvSpPr>
+        <p:spPr>
+          <a:xfrm>
+            <a:off x="10168128" y="4389120"/>
+            <a:ext cx="1517904" cy="384048"/>
+          </a:xfrm>
+          <a:prstGeom prst="rect">
+            <a:avLst/>
+          </a:prstGeom>
+          <a:noFill/>
+          <a:ln/>
+        </p:spPr>
+        <p:txBody>
+          <a:bodyPr wrap="square" lIns="0" tIns="0" rIns="0" bIns="0" rtlCol="0" anchor="t"/>
+          <a:lstStyle/>
+          <a:p>
+            <a:pPr indent="0" marL="0">
+              <a:buNone/>
+            </a:pPr>
+            <a:r>
+              <a:rPr lang="en-US" sz="1700" b="1" dirty="0">
+                <a:solidFill>
+                  <a:srgbClr val="E67E22"/>
+                </a:solidFill>
+                <a:latin typeface="Arial" pitchFamily="34" charset="0"/>
+                <a:ea typeface="Arial" pitchFamily="34" charset="-122"/>
+                <a:cs typeface="Arial" pitchFamily="34" charset="-120"/>
+              </a:rPr>
+              <a:t>99.0%</a:t>
+            </a:r>
+            <a:endParaRPr lang="en-US" sz="1700" dirty="0"/>
+          </a:p>
+        </p:txBody>
+      </p:sp>
+      <p:sp>
+        <p:nvSpPr>
+          <p:cNvPr id="34" name="Text 29"/>
+          <p:cNvSpPr txBox="1"/>
+          <p:nvPr/>
+        </p:nvSpPr>
+        <p:spPr>
+          <a:xfrm>
+            <a:off x="10168128" y="4782312"/>
+            <a:ext cx="1517904" cy="457200"/>
+          </a:xfrm>
+          <a:prstGeom prst="rect">
+            <a:avLst/>
+          </a:prstGeom>
+          <a:noFill/>
+          <a:ln/>
+        </p:spPr>
+        <p:txBody>
+          <a:bodyPr wrap="square" lIns="0" tIns="0" rIns="0" bIns="0" rtlCol="0" anchor="t"/>
+          <a:lstStyle/>
+          <a:p>
+            <a:pPr indent="0" marL="0">
+              <a:buNone/>
+            </a:pPr>
+            <a:r>
+              <a:rPr lang="en-US" sz="850" dirty="0">
+                <a:solidFill>
+                  <a:srgbClr val="595959"/>
+                </a:solidFill>
+                <a:latin typeface="Arial" pitchFamily="34" charset="0"/>
+                <a:ea typeface="Arial" pitchFamily="34" charset="-122"/>
+                <a:cs typeface="Arial" pitchFamily="34" charset="-120"/>
+              </a:rPr>
+              <a:t>Chance of ending ≥ USD 70,000</a:t>
+            </a:r>
+            <a:endParaRPr lang="en-US" sz="850" dirty="0"/>
+          </a:p>
+        </p:txBody>
+      </p:sp>
+      <p:sp>
+        <p:nvSpPr>
+          <p:cNvPr id="35" name="Shape 30"/>
           <p:cNvSpPr/>
           <p:nvPr/>
         </p:nvSpPr>
@@ -3579,7 +3761,7 @@
       </p:sp>
       <p:sp>
         <p:nvSpPr>
-          <p:cNvPr id="15" name="Text 11"/>
+          <p:cNvPr id="36" name="Text 31"/>
           <p:cNvSpPr txBox="1"/>
           <p:nvPr/>
         </p:nvSpPr>
@@ -3610,7 +3792,7 @@
                 <a:ea typeface="Arial" pitchFamily="34" charset="-122"/>
                 <a:cs typeface="Arial" pitchFamily="34" charset="-120"/>
               </a:rPr>
-              <a:t>One theme, five bottlenecks: chips, memory, foundry, tools, plus an ESG income anchor</a:t>
+              <a:t>One theme, five bottlenecks: the median grows 2.8× in five years, and even the bearish path ends above the start ($103.6k)</a:t>
             </a:r>
             <a:endParaRPr lang="en-US" sz="1200" dirty="0"/>
           </a:p>
@@ -3618,7 +3800,7 @@
       </p:sp>
       <p:sp>
         <p:nvSpPr>
-          <p:cNvPr id="16" name="Text 12"/>
+          <p:cNvPr id="37" name="Text 32"/>
           <p:cNvSpPr txBox="1"/>
           <p:nvPr/>
         </p:nvSpPr>
@@ -3649,7 +3831,7 @@
                 <a:ea typeface="Arial" pitchFamily="34" charset="-122"/>
                 <a:cs typeface="Arial" pitchFamily="34" charset="-120"/>
               </a:rPr>
-              <a:t>Weights from the team's allocation. Liquidity rule (USD 5M/day, 6-month average): EWY, EWT, 2644 and 00878 pass; 3119 HK is borderline, verify on Bloomberg.</a:t>
+              <a:t>Source: team Monte Carlo app (annual checkpoints; lines connect the yearly values; target USD 70,000 = 1st percentile). Liquidity: 3119 HK is borderline against the USD 5M/day rule, verify on Bloomberg.</a:t>
             </a:r>
             <a:endParaRPr lang="en-US" sz="800" dirty="0"/>
           </a:p>
@@ -3666,943 +3848,6 @@
 <file path=ppt/slides/slide2.xml><?xml version="1.0" encoding="utf-8"?>
 <p:sld xmlns:a="http://schemas.openxmlformats.org/drawingml/2006/main" xmlns:r="http://schemas.openxmlformats.org/officeDocument/2006/relationships" xmlns:p="http://schemas.openxmlformats.org/presentationml/2006/main">
   <p:cSld name="Slide 2">
-    <p:bg>
-      <p:bgPr>
-        <a:solidFill>
-          <a:srgbClr val="FFFFFF"/>
-        </a:solidFill>
-      </p:bgPr>
-    </p:bg>
-    <p:spTree>
-      <p:nvGrpSpPr>
-        <p:cNvPr id="1" name=""/>
-        <p:cNvGrpSpPr/>
-        <p:nvPr/>
-      </p:nvGrpSpPr>
-      <p:grpSpPr>
-        <a:xfrm>
-          <a:off x="0" y="0"/>
-          <a:ext cx="0" cy="0"/>
-          <a:chOff x="0" y="0"/>
-          <a:chExt cx="0" cy="0"/>
-        </a:xfrm>
-      </p:grpSpPr>
-      <p:sp>
-        <p:nvSpPr>
-          <p:cNvPr id="2" name="Text 0"/>
-          <p:cNvSpPr txBox="1"/>
-          <p:nvPr/>
-        </p:nvSpPr>
-        <p:spPr>
-          <a:xfrm>
-            <a:off x="457200" y="274320"/>
-            <a:ext cx="11247120" cy="548640"/>
-          </a:xfrm>
-          <a:prstGeom prst="rect">
-            <a:avLst/>
-          </a:prstGeom>
-          <a:noFill/>
-          <a:ln/>
-        </p:spPr>
-        <p:txBody>
-          <a:bodyPr wrap="square" lIns="0" tIns="0" rIns="0" bIns="0" rtlCol="0" anchor="ctr"/>
-          <a:lstStyle/>
-          <a:p>
-            <a:pPr indent="0" marL="0">
-              <a:buNone/>
-            </a:pPr>
-            <a:r>
-              <a:rPr lang="en-US" sz="2200" dirty="0">
-                <a:solidFill>
-                  <a:srgbClr val="262626"/>
-                </a:solidFill>
-                <a:latin typeface="Arial" pitchFamily="34" charset="0"/>
-                <a:ea typeface="Arial" pitchFamily="34" charset="-122"/>
-                <a:cs typeface="Arial" pitchFamily="34" charset="-120"/>
-              </a:rPr>
-              <a:t>Monte Carlo: the median portfolio grows 2.8× in five years</a:t>
-            </a:r>
-            <a:endParaRPr lang="en-US" sz="2200" dirty="0"/>
-          </a:p>
-        </p:txBody>
-      </p:sp>
-      <p:sp>
-        <p:nvSpPr>
-          <p:cNvPr id="3" name="Shape 1"/>
-          <p:cNvSpPr/>
-          <p:nvPr/>
-        </p:nvSpPr>
-        <p:spPr>
-          <a:xfrm>
-            <a:off x="457200" y="896112"/>
-            <a:ext cx="11274552" cy="0"/>
-          </a:xfrm>
-          <a:prstGeom prst="line">
-            <a:avLst/>
-          </a:prstGeom>
-          <a:noFill/>
-          <a:ln w="12700">
-            <a:solidFill>
-              <a:srgbClr val="2C5F82"/>
-            </a:solidFill>
-            <a:prstDash val="solid"/>
-          </a:ln>
-        </p:spPr>
-      </p:sp>
-      <p:sp>
-        <p:nvSpPr>
-          <p:cNvPr id="4" name="Shape 2"/>
-          <p:cNvSpPr/>
-          <p:nvPr/>
-        </p:nvSpPr>
-        <p:spPr>
-          <a:xfrm>
-            <a:off x="457200" y="6382512"/>
-            <a:ext cx="11274552" cy="0"/>
-          </a:xfrm>
-          <a:prstGeom prst="line">
-            <a:avLst/>
-          </a:prstGeom>
-          <a:noFill/>
-          <a:ln w="9525">
-            <a:solidFill>
-              <a:srgbClr val="BFBFBF"/>
-            </a:solidFill>
-            <a:prstDash val="solid"/>
-          </a:ln>
-        </p:spPr>
-      </p:sp>
-      <p:sp>
-        <p:nvSpPr>
-          <p:cNvPr id="5" name="Text 3"/>
-          <p:cNvSpPr txBox="1"/>
-          <p:nvPr/>
-        </p:nvSpPr>
-        <p:spPr>
-          <a:xfrm>
-            <a:off x="457200" y="6446520"/>
-            <a:ext cx="3611880" cy="274320"/>
-          </a:xfrm>
-          <a:prstGeom prst="rect">
-            <a:avLst/>
-          </a:prstGeom>
-          <a:noFill/>
-          <a:ln/>
-        </p:spPr>
-        <p:txBody>
-          <a:bodyPr wrap="square" lIns="0" tIns="0" rIns="0" bIns="0" rtlCol="0" anchor="t"/>
-          <a:lstStyle/>
-          <a:p>
-            <a:pPr algn="ctr" indent="0" marL="0">
-              <a:buNone/>
-            </a:pPr>
-            <a:r>
-              <a:rPr lang="en-US" sz="1200" spc="100" kern="0" dirty="0">
-                <a:solidFill>
-                  <a:srgbClr val="595959"/>
-                </a:solidFill>
-                <a:latin typeface="Arial" pitchFamily="34" charset="0"/>
-                <a:ea typeface="Arial" pitchFamily="34" charset="-122"/>
-                <a:cs typeface="Arial" pitchFamily="34" charset="-120"/>
-              </a:rPr>
-              <a:t>ANALYSIS</a:t>
-            </a:r>
-            <a:endParaRPr lang="en-US" sz="1200" dirty="0"/>
-          </a:p>
-        </p:txBody>
-      </p:sp>
-      <p:sp>
-        <p:nvSpPr>
-          <p:cNvPr id="6" name="Shape 4"/>
-          <p:cNvSpPr/>
-          <p:nvPr/>
-        </p:nvSpPr>
-        <p:spPr>
-          <a:xfrm>
-            <a:off x="4837176" y="6364224"/>
-            <a:ext cx="2514600" cy="45720"/>
-          </a:xfrm>
-          <a:prstGeom prst="rect">
-            <a:avLst/>
-          </a:prstGeom>
-          <a:solidFill>
-            <a:srgbClr val="2C5F82"/>
-          </a:solidFill>
-          <a:ln w="12700">
-            <a:solidFill>
-              <a:srgbClr val="2C5F82"/>
-            </a:solidFill>
-            <a:prstDash val="solid"/>
-          </a:ln>
-        </p:spPr>
-      </p:sp>
-      <p:sp>
-        <p:nvSpPr>
-          <p:cNvPr id="7" name="Text 5"/>
-          <p:cNvSpPr txBox="1"/>
-          <p:nvPr/>
-        </p:nvSpPr>
-        <p:spPr>
-          <a:xfrm>
-            <a:off x="4288536" y="6446520"/>
-            <a:ext cx="3611880" cy="274320"/>
-          </a:xfrm>
-          <a:prstGeom prst="rect">
-            <a:avLst/>
-          </a:prstGeom>
-          <a:noFill/>
-          <a:ln/>
-        </p:spPr>
-        <p:txBody>
-          <a:bodyPr wrap="square" lIns="0" tIns="0" rIns="0" bIns="0" rtlCol="0" anchor="t"/>
-          <a:lstStyle/>
-          <a:p>
-            <a:pPr algn="ctr" indent="0" marL="0">
-              <a:buNone/>
-            </a:pPr>
-            <a:r>
-              <a:rPr lang="en-US" sz="1200" b="1" spc="100" kern="0" dirty="0">
-                <a:solidFill>
-                  <a:srgbClr val="2C5F82"/>
-                </a:solidFill>
-                <a:latin typeface="Arial" pitchFamily="34" charset="0"/>
-                <a:ea typeface="Arial" pitchFamily="34" charset="-122"/>
-                <a:cs typeface="Arial" pitchFamily="34" charset="-120"/>
-              </a:rPr>
-              <a:t>STRATEGY</a:t>
-            </a:r>
-            <a:endParaRPr lang="en-US" sz="1200" dirty="0"/>
-          </a:p>
-        </p:txBody>
-      </p:sp>
-      <p:sp>
-        <p:nvSpPr>
-          <p:cNvPr id="8" name="Text 6"/>
-          <p:cNvSpPr txBox="1"/>
-          <p:nvPr/>
-        </p:nvSpPr>
-        <p:spPr>
-          <a:xfrm>
-            <a:off x="8129016" y="6446520"/>
-            <a:ext cx="3611880" cy="274320"/>
-          </a:xfrm>
-          <a:prstGeom prst="rect">
-            <a:avLst/>
-          </a:prstGeom>
-          <a:noFill/>
-          <a:ln/>
-        </p:spPr>
-        <p:txBody>
-          <a:bodyPr wrap="square" lIns="0" tIns="0" rIns="0" bIns="0" rtlCol="0" anchor="t"/>
-          <a:lstStyle/>
-          <a:p>
-            <a:pPr algn="ctr" indent="0" marL="0">
-              <a:buNone/>
-            </a:pPr>
-            <a:r>
-              <a:rPr lang="en-US" sz="1200" spc="100" kern="0" dirty="0">
-                <a:solidFill>
-                  <a:srgbClr val="595959"/>
-                </a:solidFill>
-                <a:latin typeface="Arial" pitchFamily="34" charset="0"/>
-                <a:ea typeface="Arial" pitchFamily="34" charset="-122"/>
-                <a:cs typeface="Arial" pitchFamily="34" charset="-120"/>
-              </a:rPr>
-              <a:t>APPENDIX</a:t>
-            </a:r>
-            <a:endParaRPr lang="en-US" sz="1200" dirty="0"/>
-          </a:p>
-        </p:txBody>
-      </p:sp>
-      <p:sp>
-        <p:nvSpPr>
-          <p:cNvPr id="9" name="Text 7"/>
-          <p:cNvSpPr txBox="1"/>
-          <p:nvPr/>
-        </p:nvSpPr>
-        <p:spPr>
-          <a:xfrm>
-            <a:off x="457200" y="969264"/>
-            <a:ext cx="11274552" cy="274320"/>
-          </a:xfrm>
-          <a:prstGeom prst="rect">
-            <a:avLst/>
-          </a:prstGeom>
-          <a:noFill/>
-          <a:ln/>
-        </p:spPr>
-        <p:txBody>
-          <a:bodyPr wrap="square" lIns="0" tIns="0" rIns="0" bIns="0" rtlCol="0" anchor="t"/>
-          <a:lstStyle/>
-          <a:p>
-            <a:pPr indent="0" marL="0">
-              <a:buNone/>
-            </a:pPr>
-            <a:r>
-              <a:rPr lang="en-US" sz="1100" i="1" dirty="0">
-                <a:solidFill>
-                  <a:srgbClr val="595959"/>
-                </a:solidFill>
-                <a:latin typeface="Arial" pitchFamily="34" charset="0"/>
-                <a:ea typeface="Arial" pitchFamily="34" charset="-122"/>
-                <a:cs typeface="Arial" pitchFamily="34" charset="-120"/>
-              </a:rPr>
-              <a:t>5-year simulation of the five-ETF portfolio, per USD 100,000 invested (×1,000 for the USD 100mn mandate)</a:t>
-            </a:r>
-            <a:endParaRPr lang="en-US" sz="1100" dirty="0"/>
-          </a:p>
-        </p:txBody>
-      </p:sp>
-      <p:pic>
-        <p:nvPicPr>
-          <p:cNvPr id="10" name="Image 0" descr="/home/user/natixis-case-comp/strategy/mc_checkpoints.png">    </p:cNvPr>
-          <p:cNvPicPr>
-            <a:picLocks noChangeAspect="1"/>
-          </p:cNvPicPr>
-          <p:nvPr/>
-        </p:nvPicPr>
-        <p:blipFill>
-          <a:blip r:embed="rId1"/>
-          <a:stretch>
-            <a:fillRect/>
-          </a:stretch>
-        </p:blipFill>
-        <p:spPr>
-          <a:xfrm>
-            <a:off x="457200" y="1298448"/>
-            <a:ext cx="7498080" cy="4272162"/>
-          </a:xfrm>
-          <a:prstGeom prst="rect">
-            <a:avLst/>
-          </a:prstGeom>
-        </p:spPr>
-      </p:pic>
-      <p:sp>
-        <p:nvSpPr>
-          <p:cNvPr id="11" name="Shape 8"/>
-          <p:cNvSpPr/>
-          <p:nvPr/>
-        </p:nvSpPr>
-        <p:spPr>
-          <a:xfrm>
-            <a:off x="8183880" y="1325880"/>
-            <a:ext cx="3547872" cy="914400"/>
-          </a:xfrm>
-          <a:prstGeom prst="rect">
-            <a:avLst/>
-          </a:prstGeom>
-          <a:solidFill>
-            <a:srgbClr val="F2F2F2"/>
-          </a:solidFill>
-          <a:ln w="12700">
-            <a:solidFill>
-              <a:srgbClr val="F2F2F2"/>
-            </a:solidFill>
-            <a:prstDash val="solid"/>
-          </a:ln>
-        </p:spPr>
-      </p:sp>
-      <p:sp>
-        <p:nvSpPr>
-          <p:cNvPr id="12" name="Shape 9"/>
-          <p:cNvSpPr/>
-          <p:nvPr/>
-        </p:nvSpPr>
-        <p:spPr>
-          <a:xfrm>
-            <a:off x="8183880" y="1325880"/>
-            <a:ext cx="64008" cy="914400"/>
-          </a:xfrm>
-          <a:prstGeom prst="rect">
-            <a:avLst/>
-          </a:prstGeom>
-          <a:solidFill>
-            <a:srgbClr val="2C5F82"/>
-          </a:solidFill>
-          <a:ln w="12700">
-            <a:solidFill>
-              <a:srgbClr val="2C5F82"/>
-            </a:solidFill>
-            <a:prstDash val="solid"/>
-          </a:ln>
-        </p:spPr>
-      </p:sp>
-      <p:sp>
-        <p:nvSpPr>
-          <p:cNvPr id="13" name="Text 10"/>
-          <p:cNvSpPr txBox="1"/>
-          <p:nvPr/>
-        </p:nvSpPr>
-        <p:spPr>
-          <a:xfrm>
-            <a:off x="8366760" y="1380744"/>
-            <a:ext cx="3291840" cy="457200"/>
-          </a:xfrm>
-          <a:prstGeom prst="rect">
-            <a:avLst/>
-          </a:prstGeom>
-          <a:noFill/>
-          <a:ln/>
-        </p:spPr>
-        <p:txBody>
-          <a:bodyPr wrap="square" lIns="0" tIns="0" rIns="0" bIns="0" rtlCol="0" anchor="t"/>
-          <a:lstStyle/>
-          <a:p>
-            <a:pPr indent="0" marL="0">
-              <a:buNone/>
-            </a:pPr>
-            <a:r>
-              <a:rPr lang="en-US" sz="2200" b="1" dirty="0">
-                <a:solidFill>
-                  <a:srgbClr val="2C5F82"/>
-                </a:solidFill>
-                <a:latin typeface="Arial" pitchFamily="34" charset="0"/>
-                <a:ea typeface="Arial" pitchFamily="34" charset="-122"/>
-                <a:cs typeface="Arial" pitchFamily="34" charset="-120"/>
-              </a:rPr>
-              <a:t>$279.6k</a:t>
-            </a:r>
-            <a:endParaRPr lang="en-US" sz="2200" dirty="0"/>
-          </a:p>
-        </p:txBody>
-      </p:sp>
-      <p:sp>
-        <p:nvSpPr>
-          <p:cNvPr id="14" name="Text 11"/>
-          <p:cNvSpPr txBox="1"/>
-          <p:nvPr/>
-        </p:nvSpPr>
-        <p:spPr>
-          <a:xfrm>
-            <a:off x="8366760" y="1837944"/>
-            <a:ext cx="3291840" cy="365760"/>
-          </a:xfrm>
-          <a:prstGeom prst="rect">
-            <a:avLst/>
-          </a:prstGeom>
-          <a:noFill/>
-          <a:ln/>
-        </p:spPr>
-        <p:txBody>
-          <a:bodyPr wrap="square" lIns="0" tIns="0" rIns="0" bIns="0" rtlCol="0" anchor="t"/>
-          <a:lstStyle/>
-          <a:p>
-            <a:pPr indent="0" marL="0">
-              <a:buNone/>
-            </a:pPr>
-            <a:r>
-              <a:rPr lang="en-US" sz="950" dirty="0">
-                <a:solidFill>
-                  <a:srgbClr val="595959"/>
-                </a:solidFill>
-                <a:latin typeface="Arial" pitchFamily="34" charset="0"/>
-                <a:ea typeface="Arial" pitchFamily="34" charset="-122"/>
-                <a:cs typeface="Arial" pitchFamily="34" charset="-120"/>
-              </a:rPr>
-              <a:t>Median at Year 5: 2.8× the start, +22.8% a year</a:t>
-            </a:r>
-            <a:endParaRPr lang="en-US" sz="950" dirty="0"/>
-          </a:p>
-        </p:txBody>
-      </p:sp>
-      <p:sp>
-        <p:nvSpPr>
-          <p:cNvPr id="15" name="Shape 12"/>
-          <p:cNvSpPr/>
-          <p:nvPr/>
-        </p:nvSpPr>
-        <p:spPr>
-          <a:xfrm>
-            <a:off x="8183880" y="2350008"/>
-            <a:ext cx="3547872" cy="914400"/>
-          </a:xfrm>
-          <a:prstGeom prst="rect">
-            <a:avLst/>
-          </a:prstGeom>
-          <a:solidFill>
-            <a:srgbClr val="F2F2F2"/>
-          </a:solidFill>
-          <a:ln w="12700">
-            <a:solidFill>
-              <a:srgbClr val="F2F2F2"/>
-            </a:solidFill>
-            <a:prstDash val="solid"/>
-          </a:ln>
-        </p:spPr>
-      </p:sp>
-      <p:sp>
-        <p:nvSpPr>
-          <p:cNvPr id="16" name="Shape 13"/>
-          <p:cNvSpPr/>
-          <p:nvPr/>
-        </p:nvSpPr>
-        <p:spPr>
-          <a:xfrm>
-            <a:off x="8183880" y="2350008"/>
-            <a:ext cx="64008" cy="914400"/>
-          </a:xfrm>
-          <a:prstGeom prst="rect">
-            <a:avLst/>
-          </a:prstGeom>
-          <a:solidFill>
-            <a:srgbClr val="C0392B"/>
-          </a:solidFill>
-          <a:ln w="12700">
-            <a:solidFill>
-              <a:srgbClr val="C0392B"/>
-            </a:solidFill>
-            <a:prstDash val="solid"/>
-          </a:ln>
-        </p:spPr>
-      </p:sp>
-      <p:sp>
-        <p:nvSpPr>
-          <p:cNvPr id="17" name="Text 14"/>
-          <p:cNvSpPr txBox="1"/>
-          <p:nvPr/>
-        </p:nvSpPr>
-        <p:spPr>
-          <a:xfrm>
-            <a:off x="8366760" y="2404872"/>
-            <a:ext cx="3291840" cy="457200"/>
-          </a:xfrm>
-          <a:prstGeom prst="rect">
-            <a:avLst/>
-          </a:prstGeom>
-          <a:noFill/>
-          <a:ln/>
-        </p:spPr>
-        <p:txBody>
-          <a:bodyPr wrap="square" lIns="0" tIns="0" rIns="0" bIns="0" rtlCol="0" anchor="t"/>
-          <a:lstStyle/>
-          <a:p>
-            <a:pPr indent="0" marL="0">
-              <a:buNone/>
-            </a:pPr>
-            <a:r>
-              <a:rPr lang="en-US" sz="2200" b="1" dirty="0">
-                <a:solidFill>
-                  <a:srgbClr val="C0392B"/>
-                </a:solidFill>
-                <a:latin typeface="Arial" pitchFamily="34" charset="0"/>
-                <a:ea typeface="Arial" pitchFamily="34" charset="-122"/>
-                <a:cs typeface="Arial" pitchFamily="34" charset="-120"/>
-              </a:rPr>
-              <a:t>$103.6k</a:t>
-            </a:r>
-            <a:endParaRPr lang="en-US" sz="2200" dirty="0"/>
-          </a:p>
-        </p:txBody>
-      </p:sp>
-      <p:sp>
-        <p:nvSpPr>
-          <p:cNvPr id="18" name="Text 15"/>
-          <p:cNvSpPr txBox="1"/>
-          <p:nvPr/>
-        </p:nvSpPr>
-        <p:spPr>
-          <a:xfrm>
-            <a:off x="8366760" y="2862072"/>
-            <a:ext cx="3291840" cy="365760"/>
-          </a:xfrm>
-          <a:prstGeom prst="rect">
-            <a:avLst/>
-          </a:prstGeom>
-          <a:noFill/>
-          <a:ln/>
-        </p:spPr>
-        <p:txBody>
-          <a:bodyPr wrap="square" lIns="0" tIns="0" rIns="0" bIns="0" rtlCol="0" anchor="t"/>
-          <a:lstStyle/>
-          <a:p>
-            <a:pPr indent="0" marL="0">
-              <a:buNone/>
-            </a:pPr>
-            <a:r>
-              <a:rPr lang="en-US" sz="950" dirty="0">
-                <a:solidFill>
-                  <a:srgbClr val="595959"/>
-                </a:solidFill>
-                <a:latin typeface="Arial" pitchFamily="34" charset="0"/>
-                <a:ea typeface="Arial" pitchFamily="34" charset="-122"/>
-                <a:cs typeface="Arial" pitchFamily="34" charset="-120"/>
-              </a:rPr>
-              <a:t>Bearish (5th percentile): still above the start, +0.7% a year</a:t>
-            </a:r>
-            <a:endParaRPr lang="en-US" sz="950" dirty="0"/>
-          </a:p>
-        </p:txBody>
-      </p:sp>
-      <p:sp>
-        <p:nvSpPr>
-          <p:cNvPr id="19" name="Shape 16"/>
-          <p:cNvSpPr/>
-          <p:nvPr/>
-        </p:nvSpPr>
-        <p:spPr>
-          <a:xfrm>
-            <a:off x="8183880" y="3374136"/>
-            <a:ext cx="3547872" cy="914400"/>
-          </a:xfrm>
-          <a:prstGeom prst="rect">
-            <a:avLst/>
-          </a:prstGeom>
-          <a:solidFill>
-            <a:srgbClr val="F2F2F2"/>
-          </a:solidFill>
-          <a:ln w="12700">
-            <a:solidFill>
-              <a:srgbClr val="F2F2F2"/>
-            </a:solidFill>
-            <a:prstDash val="solid"/>
-          </a:ln>
-        </p:spPr>
-      </p:sp>
-      <p:sp>
-        <p:nvSpPr>
-          <p:cNvPr id="20" name="Shape 17"/>
-          <p:cNvSpPr/>
-          <p:nvPr/>
-        </p:nvSpPr>
-        <p:spPr>
-          <a:xfrm>
-            <a:off x="8183880" y="3374136"/>
-            <a:ext cx="64008" cy="914400"/>
-          </a:xfrm>
-          <a:prstGeom prst="rect">
-            <a:avLst/>
-          </a:prstGeom>
-          <a:solidFill>
-            <a:srgbClr val="2E9E44"/>
-          </a:solidFill>
-          <a:ln w="12700">
-            <a:solidFill>
-              <a:srgbClr val="2E9E44"/>
-            </a:solidFill>
-            <a:prstDash val="solid"/>
-          </a:ln>
-        </p:spPr>
-      </p:sp>
-      <p:sp>
-        <p:nvSpPr>
-          <p:cNvPr id="21" name="Text 18"/>
-          <p:cNvSpPr txBox="1"/>
-          <p:nvPr/>
-        </p:nvSpPr>
-        <p:spPr>
-          <a:xfrm>
-            <a:off x="8366760" y="3429000"/>
-            <a:ext cx="3291840" cy="457200"/>
-          </a:xfrm>
-          <a:prstGeom prst="rect">
-            <a:avLst/>
-          </a:prstGeom>
-          <a:noFill/>
-          <a:ln/>
-        </p:spPr>
-        <p:txBody>
-          <a:bodyPr wrap="square" lIns="0" tIns="0" rIns="0" bIns="0" rtlCol="0" anchor="t"/>
-          <a:lstStyle/>
-          <a:p>
-            <a:pPr indent="0" marL="0">
-              <a:buNone/>
-            </a:pPr>
-            <a:r>
-              <a:rPr lang="en-US" sz="2200" b="1" dirty="0">
-                <a:solidFill>
-                  <a:srgbClr val="2E9E44"/>
-                </a:solidFill>
-                <a:latin typeface="Arial" pitchFamily="34" charset="0"/>
-                <a:ea typeface="Arial" pitchFamily="34" charset="-122"/>
-                <a:cs typeface="Arial" pitchFamily="34" charset="-120"/>
-              </a:rPr>
-              <a:t>$770.5k</a:t>
-            </a:r>
-            <a:endParaRPr lang="en-US" sz="2200" dirty="0"/>
-          </a:p>
-        </p:txBody>
-      </p:sp>
-      <p:sp>
-        <p:nvSpPr>
-          <p:cNvPr id="22" name="Text 19"/>
-          <p:cNvSpPr txBox="1"/>
-          <p:nvPr/>
-        </p:nvSpPr>
-        <p:spPr>
-          <a:xfrm>
-            <a:off x="8366760" y="3886200"/>
-            <a:ext cx="3291840" cy="365760"/>
-          </a:xfrm>
-          <a:prstGeom prst="rect">
-            <a:avLst/>
-          </a:prstGeom>
-          <a:noFill/>
-          <a:ln/>
-        </p:spPr>
-        <p:txBody>
-          <a:bodyPr wrap="square" lIns="0" tIns="0" rIns="0" bIns="0" rtlCol="0" anchor="t"/>
-          <a:lstStyle/>
-          <a:p>
-            <a:pPr indent="0" marL="0">
-              <a:buNone/>
-            </a:pPr>
-            <a:r>
-              <a:rPr lang="en-US" sz="950" dirty="0">
-                <a:solidFill>
-                  <a:srgbClr val="595959"/>
-                </a:solidFill>
-                <a:latin typeface="Arial" pitchFamily="34" charset="0"/>
-                <a:ea typeface="Arial" pitchFamily="34" charset="-122"/>
-                <a:cs typeface="Arial" pitchFamily="34" charset="-120"/>
-              </a:rPr>
-              <a:t>Bullish (95th percentile): 7.7× the start</a:t>
-            </a:r>
-            <a:endParaRPr lang="en-US" sz="950" dirty="0"/>
-          </a:p>
-        </p:txBody>
-      </p:sp>
-      <p:sp>
-        <p:nvSpPr>
-          <p:cNvPr id="23" name="Shape 20"/>
-          <p:cNvSpPr/>
-          <p:nvPr/>
-        </p:nvSpPr>
-        <p:spPr>
-          <a:xfrm>
-            <a:off x="8183880" y="4398264"/>
-            <a:ext cx="3547872" cy="914400"/>
-          </a:xfrm>
-          <a:prstGeom prst="rect">
-            <a:avLst/>
-          </a:prstGeom>
-          <a:solidFill>
-            <a:srgbClr val="F2F2F2"/>
-          </a:solidFill>
-          <a:ln w="12700">
-            <a:solidFill>
-              <a:srgbClr val="F2F2F2"/>
-            </a:solidFill>
-            <a:prstDash val="solid"/>
-          </a:ln>
-        </p:spPr>
-      </p:sp>
-      <p:sp>
-        <p:nvSpPr>
-          <p:cNvPr id="24" name="Shape 21"/>
-          <p:cNvSpPr/>
-          <p:nvPr/>
-        </p:nvSpPr>
-        <p:spPr>
-          <a:xfrm>
-            <a:off x="8183880" y="4398264"/>
-            <a:ext cx="64008" cy="914400"/>
-          </a:xfrm>
-          <a:prstGeom prst="rect">
-            <a:avLst/>
-          </a:prstGeom>
-          <a:solidFill>
-            <a:srgbClr val="E67E22"/>
-          </a:solidFill>
-          <a:ln w="12700">
-            <a:solidFill>
-              <a:srgbClr val="E67E22"/>
-            </a:solidFill>
-            <a:prstDash val="solid"/>
-          </a:ln>
-        </p:spPr>
-      </p:sp>
-      <p:sp>
-        <p:nvSpPr>
-          <p:cNvPr id="25" name="Text 22"/>
-          <p:cNvSpPr txBox="1"/>
-          <p:nvPr/>
-        </p:nvSpPr>
-        <p:spPr>
-          <a:xfrm>
-            <a:off x="8366760" y="4453128"/>
-            <a:ext cx="3291840" cy="457200"/>
-          </a:xfrm>
-          <a:prstGeom prst="rect">
-            <a:avLst/>
-          </a:prstGeom>
-          <a:noFill/>
-          <a:ln/>
-        </p:spPr>
-        <p:txBody>
-          <a:bodyPr wrap="square" lIns="0" tIns="0" rIns="0" bIns="0" rtlCol="0" anchor="t"/>
-          <a:lstStyle/>
-          <a:p>
-            <a:pPr indent="0" marL="0">
-              <a:buNone/>
-            </a:pPr>
-            <a:r>
-              <a:rPr lang="en-US" sz="2200" b="1" dirty="0">
-                <a:solidFill>
-                  <a:srgbClr val="E67E22"/>
-                </a:solidFill>
-                <a:latin typeface="Arial" pitchFamily="34" charset="0"/>
-                <a:ea typeface="Arial" pitchFamily="34" charset="-122"/>
-                <a:cs typeface="Arial" pitchFamily="34" charset="-120"/>
-              </a:rPr>
-              <a:t>99.0%</a:t>
-            </a:r>
-            <a:endParaRPr lang="en-US" sz="2200" dirty="0"/>
-          </a:p>
-        </p:txBody>
-      </p:sp>
-      <p:sp>
-        <p:nvSpPr>
-          <p:cNvPr id="26" name="Text 23"/>
-          <p:cNvSpPr txBox="1"/>
-          <p:nvPr/>
-        </p:nvSpPr>
-        <p:spPr>
-          <a:xfrm>
-            <a:off x="8366760" y="4910328"/>
-            <a:ext cx="3291840" cy="365760"/>
-          </a:xfrm>
-          <a:prstGeom prst="rect">
-            <a:avLst/>
-          </a:prstGeom>
-          <a:noFill/>
-          <a:ln/>
-        </p:spPr>
-        <p:txBody>
-          <a:bodyPr wrap="square" lIns="0" tIns="0" rIns="0" bIns="0" rtlCol="0" anchor="t"/>
-          <a:lstStyle/>
-          <a:p>
-            <a:pPr indent="0" marL="0">
-              <a:buNone/>
-            </a:pPr>
-            <a:r>
-              <a:rPr lang="en-US" sz="950" dirty="0">
-                <a:solidFill>
-                  <a:srgbClr val="595959"/>
-                </a:solidFill>
-                <a:latin typeface="Arial" pitchFamily="34" charset="0"/>
-                <a:ea typeface="Arial" pitchFamily="34" charset="-122"/>
-                <a:cs typeface="Arial" pitchFamily="34" charset="-120"/>
-              </a:rPr>
-              <a:t>Chance of ending at or above the USD 70,000 target</a:t>
-            </a:r>
-            <a:endParaRPr lang="en-US" sz="950" dirty="0"/>
-          </a:p>
-        </p:txBody>
-      </p:sp>
-      <p:sp>
-        <p:nvSpPr>
-          <p:cNvPr id="27" name="Shape 24"/>
-          <p:cNvSpPr/>
-          <p:nvPr/>
-        </p:nvSpPr>
-        <p:spPr>
-          <a:xfrm>
-            <a:off x="457200" y="5577840"/>
-            <a:ext cx="11274552" cy="457200"/>
-          </a:xfrm>
-          <a:prstGeom prst="rect">
-            <a:avLst/>
-          </a:prstGeom>
-          <a:solidFill>
-            <a:srgbClr val="2C5F82"/>
-          </a:solidFill>
-          <a:ln w="12700">
-            <a:solidFill>
-              <a:srgbClr val="2C5F82"/>
-            </a:solidFill>
-            <a:prstDash val="solid"/>
-          </a:ln>
-        </p:spPr>
-      </p:sp>
-      <p:sp>
-        <p:nvSpPr>
-          <p:cNvPr id="28" name="Text 25"/>
-          <p:cNvSpPr txBox="1"/>
-          <p:nvPr/>
-        </p:nvSpPr>
-        <p:spPr>
-          <a:xfrm>
-            <a:off x="594360" y="5577840"/>
-            <a:ext cx="11000232" cy="457200"/>
-          </a:xfrm>
-          <a:prstGeom prst="rect">
-            <a:avLst/>
-          </a:prstGeom>
-          <a:noFill/>
-          <a:ln/>
-        </p:spPr>
-        <p:txBody>
-          <a:bodyPr wrap="square" lIns="0" tIns="0" rIns="0" bIns="0" rtlCol="0" anchor="ctr"/>
-          <a:lstStyle/>
-          <a:p>
-            <a:pPr algn="ctr" indent="0" marL="0">
-              <a:buNone/>
-            </a:pPr>
-            <a:r>
-              <a:rPr lang="en-US" sz="1200" b="1" dirty="0">
-                <a:solidFill>
-                  <a:srgbClr val="FFFFFF"/>
-                </a:solidFill>
-                <a:latin typeface="Arial" pitchFamily="34" charset="0"/>
-                <a:ea typeface="Arial" pitchFamily="34" charset="-122"/>
-                <a:cs typeface="Arial" pitchFamily="34" charset="-120"/>
-              </a:rPr>
-              <a:t>Even the bearish path ends above the start ($103.6k); the USD 70,000 target is the 1st percentile</a:t>
-            </a:r>
-            <a:endParaRPr lang="en-US" sz="1200" dirty="0"/>
-          </a:p>
-        </p:txBody>
-      </p:sp>
-      <p:sp>
-        <p:nvSpPr>
-          <p:cNvPr id="29" name="Text 26"/>
-          <p:cNvSpPr txBox="1"/>
-          <p:nvPr/>
-        </p:nvSpPr>
-        <p:spPr>
-          <a:xfrm>
-            <a:off x="457200" y="6089904"/>
-            <a:ext cx="11274552" cy="256032"/>
-          </a:xfrm>
-          <a:prstGeom prst="rect">
-            <a:avLst/>
-          </a:prstGeom>
-          <a:noFill/>
-          <a:ln/>
-        </p:spPr>
-        <p:txBody>
-          <a:bodyPr wrap="square" lIns="0" tIns="0" rIns="0" bIns="0" rtlCol="0" anchor="t"/>
-          <a:lstStyle/>
-          <a:p>
-            <a:pPr indent="0" marL="0">
-              <a:buNone/>
-            </a:pPr>
-            <a:r>
-              <a:rPr lang="en-US" sz="800" i="1" dirty="0">
-                <a:solidFill>
-                  <a:srgbClr val="595959"/>
-                </a:solidFill>
-                <a:latin typeface="Arial" pitchFamily="34" charset="0"/>
-                <a:ea typeface="Arial" pitchFamily="34" charset="-122"/>
-                <a:cs typeface="Arial" pitchFamily="34" charset="-120"/>
-              </a:rPr>
-              <a:t>Source: team Monte Carlo app (annual checkpoints of the simulated paths). Lines connect the yearly values. Results depend on the app's return and volatility inputs; refresh with Bloomberg data at the 17 Sep 2026 trade date.</a:t>
-            </a:r>
-            <a:endParaRPr lang="en-US" sz="800" dirty="0"/>
-          </a:p>
-        </p:txBody>
-      </p:sp>
-    </p:spTree>
-  </p:cSld>
-  <p:clrMapOvr>
-    <a:masterClrMapping/>
-  </p:clrMapOvr>
-</p:sld>
-</file>
-
-<file path=ppt/slides/slide3.xml><?xml version="1.0" encoding="utf-8"?>
-<p:sld xmlns:a="http://schemas.openxmlformats.org/drawingml/2006/main" xmlns:r="http://schemas.openxmlformats.org/officeDocument/2006/relationships" xmlns:p="http://schemas.openxmlformats.org/presentationml/2006/main">
-  <p:cSld name="Slide 3">
     <p:bg>
       <p:bgPr>
         <a:solidFill>
@@ -4892,7 +4137,7 @@
       </p:sp>
       <p:graphicFrame>
         <p:nvGraphicFramePr>
-          <p:cNvPr id="4" name="Table 0"/>
+          <p:cNvPr id="3" name="Table 0"/>
           <p:cNvGraphicFramePr>
             <a:graphicFrameLocks noGrp="1"/>
           </p:cNvGraphicFramePr>

</xml_diff>

<commit_message>
Strategy slides: add the risk/return chart beside the allocation; Monte Carlo moves to slide 2
Co-Authored-By: Claude Opus 5.5 <noreply@anthropic.com>
Claude-Session: https://claude.ai/code/session_01Rwoh8cFDQqLD8JWT3mee6y
</commit_message>
<xml_diff>
--- a/strategy/Strategy-Slides.pptx
+++ b/strategy/Strategy-Slides.pptx
@@ -7,9 +7,10 @@
   <p:sldIdLst>
     <p:sldId id="256" r:id="rId2"/>
     <p:sldId id="257" r:id="rId3"/>
+    <p:sldId id="258" r:id="rId4"/>
   </p:sldIdLst>
   <p:notesMasterIdLst>
-    <p:notesMasterId r:id="rId4"/>
+    <p:notesMasterId r:id="rId5"/>
   </p:notesMasterIdLst>
   <p:sldSz cx="12192000" cy="6858000"/>
   <p:notesSz cx="6858000" cy="12192000"/>
@@ -925,6 +926,94 @@
             <a:fld id="{F7021451-1387-4CA6-816F-3879F97B5CBC}" type="slidenum">
               <a:rPr lang="en-US"/>
               <a:t>2</a:t>
+            </a:fld>
+            <a:endParaRPr lang="en-US"/>
+          </a:p>
+        </p:txBody>
+      </p:sp>
+    </p:spTree>
+    <p:extLst>
+      <p:ext uri="{BB962C8B-B14F-4D97-AF65-F5344CB8AC3E}">
+        <p14:creationId xmlns:p14="http://schemas.microsoft.com/office/powerpoint/2010/main" val="1024086991"/>
+      </p:ext>
+    </p:extLst>
+  </p:cSld>
+  <p:clrMapOvr>
+    <a:masterClrMapping/>
+  </p:clrMapOvr>
+</p:notes>
+</file>
+
+<file path=ppt/notesSlides/notesSlide3.xml><?xml version="1.0" encoding="utf-8"?>
+<p:notes xmlns:a="http://schemas.openxmlformats.org/drawingml/2006/main" xmlns:r="http://schemas.openxmlformats.org/officeDocument/2006/relationships" xmlns:p="http://schemas.openxmlformats.org/presentationml/2006/main">
+  <p:cSld>
+    <p:spTree>
+      <p:nvGrpSpPr>
+        <p:cNvPr id="1" name=""/>
+        <p:cNvGrpSpPr/>
+        <p:nvPr/>
+      </p:nvGrpSpPr>
+      <p:grpSpPr>
+        <a:xfrm>
+          <a:off x="0" y="0"/>
+          <a:ext cx="0" cy="0"/>
+          <a:chOff x="0" y="0"/>
+          <a:chExt cx="0" cy="0"/>
+        </a:xfrm>
+      </p:grpSpPr>
+      <p:sp>
+        <p:nvSpPr>
+          <p:cNvPr id="2" name="Slide Image Placeholder 1"/>
+          <p:cNvSpPr>
+            <a:spLocks noGrp="1" noRot="1" noChangeAspect="1"/>
+          </p:cNvSpPr>
+          <p:nvPr>
+            <p:ph type="sldImg"/>
+          </p:nvPr>
+        </p:nvSpPr>
+        <p:spPr/>
+      </p:sp>
+      <p:sp>
+        <p:nvSpPr>
+          <p:cNvPr id="3" name="Notes Placeholder 2"/>
+          <p:cNvSpPr>
+            <a:spLocks noGrp="1"/>
+          </p:cNvSpPr>
+          <p:nvPr>
+            <p:ph type="body" idx="1"/>
+          </p:nvPr>
+        </p:nvSpPr>
+        <p:spPr/>
+        <p:txBody>
+          <a:bodyPr/>
+          <a:lstStyle/>
+          <a:p>
+            <a:r>
+              <a:rPr lang="en-US" dirty="0"/>
+              <a:t/>
+            </a:r>
+            <a:endParaRPr lang="en-US" dirty="0"/>
+          </a:p>
+        </p:txBody>
+      </p:sp>
+      <p:sp>
+        <p:nvSpPr>
+          <p:cNvPr id="4" name="Slide Number Placeholder 3"/>
+          <p:cNvSpPr>
+            <a:spLocks noGrp="1"/>
+          </p:cNvSpPr>
+          <p:nvPr>
+            <p:ph type="sldNum" sz="quarter" idx="10"/>
+          </p:nvPr>
+        </p:nvSpPr>
+        <p:spPr/>
+        <p:txBody>
+          <a:bodyPr/>
+          <a:lstStyle/>
+          <a:p>
+            <a:fld id="{F7021451-1387-4CA6-816F-3879F97B5CBC}" type="slidenum">
+              <a:rPr lang="en-US"/>
+              <a:t>3</a:t>
             </a:fld>
             <a:endParaRPr lang="en-US"/>
           </a:p>
@@ -1307,7 +1396,7 @@
                 <a:ea typeface="Arial" pitchFamily="34" charset="-122"/>
                 <a:cs typeface="Arial" pitchFamily="34" charset="-120"/>
               </a:rPr>
-              <a:t>Strategy: five Asian AI-hardware ETFs, simulated over five years</a:t>
+              <a:t>Strategy: five Asian AI-hardware ETFs, combined to cut risk</a:t>
             </a:r>
             <a:endParaRPr lang="en-US" sz="2200" dirty="0"/>
           </a:p>
@@ -1534,7 +1623,7 @@
                 <a:ea typeface="Arial" pitchFamily="34" charset="-122"/>
                 <a:cs typeface="Arial" pitchFamily="34" charset="-120"/>
               </a:rPr>
-              <a:t>USD 100mn across five Bloomberg-listed ETFs; Monte Carlo per USD 100,000 invested (×1,000 for the mandate)</a:t>
+              <a:t>USD 100mn across five Bloomberg-listed ETFs; mixing them gives most of the return with less volatility than the riskiest funds</a:t>
             </a:r>
             <a:endParaRPr lang="en-US" sz="1100" dirty="0"/>
           </a:p>
@@ -3143,7 +3232,7 @@
         <p:spPr>
           <a:xfrm>
             <a:off x="4069080" y="1325880"/>
-            <a:ext cx="5806440" cy="329184"/>
+            <a:ext cx="4572000" cy="329184"/>
           </a:xfrm>
           <a:prstGeom prst="rect">
             <a:avLst/>
@@ -3168,7 +3257,7 @@
         <p:spPr>
           <a:xfrm>
             <a:off x="4069080" y="1325880"/>
-            <a:ext cx="5806440" cy="329184"/>
+            <a:ext cx="4572000" cy="329184"/>
           </a:xfrm>
           <a:prstGeom prst="rect">
             <a:avLst/>
@@ -3192,7 +3281,7 @@
                 <a:ea typeface="Arial" pitchFamily="34" charset="-122"/>
                 <a:cs typeface="Arial" pitchFamily="34" charset="-120"/>
               </a:rPr>
-              <a:t>5-year Monte Carlo (value per USD 100,000)</a:t>
+              <a:t>Risk vs return: single ETFs and random mixes</a:t>
             </a:r>
             <a:endParaRPr lang="en-US" sz="1150" dirty="0"/>
           </a:p>
@@ -3200,7 +3289,7 @@
       </p:sp>
       <p:pic>
         <p:nvPicPr>
-          <p:cNvPr id="18" name="Image 0" descr="/home/user/natixis-case-comp/strategy/mc_checkpoints.png">    </p:cNvPr>
+          <p:cNvPr id="18" name="Image 0" descr="/home/user/natixis-case-comp/strategy/risk_return_cloud.jpg">    </p:cNvPr>
           <p:cNvPicPr>
             <a:picLocks noChangeAspect="1"/>
           </p:cNvPicPr>
@@ -3214,8 +3303,8 @@
         </p:blipFill>
         <p:spPr>
           <a:xfrm>
-            <a:off x="4069080" y="1719072"/>
-            <a:ext cx="5806440" cy="3308320"/>
+            <a:off x="4114800" y="1719072"/>
+            <a:ext cx="4480560" cy="3520835"/>
           </a:xfrm>
           <a:prstGeom prst="rect">
             <a:avLst/>
@@ -3230,33 +3319,8 @@
         </p:nvSpPr>
         <p:spPr>
           <a:xfrm>
-            <a:off x="10058400" y="1325880"/>
-            <a:ext cx="1673352" cy="914400"/>
-          </a:xfrm>
-          <a:prstGeom prst="rect">
-            <a:avLst/>
-          </a:prstGeom>
-          <a:solidFill>
-            <a:srgbClr val="F2F2F2"/>
-          </a:solidFill>
-          <a:ln w="12700">
-            <a:solidFill>
-              <a:srgbClr val="F2F2F2"/>
-            </a:solidFill>
-            <a:prstDash val="solid"/>
-          </a:ln>
-        </p:spPr>
-      </p:sp>
-      <p:sp>
-        <p:nvSpPr>
-          <p:cNvPr id="20" name="Shape 15"/>
-          <p:cNvSpPr/>
-          <p:nvPr/>
-        </p:nvSpPr>
-        <p:spPr>
-          <a:xfrm>
-            <a:off x="10058400" y="1325880"/>
-            <a:ext cx="54864" cy="914400"/>
+            <a:off x="8823960" y="1325880"/>
+            <a:ext cx="2907792" cy="329184"/>
           </a:xfrm>
           <a:prstGeom prst="rect">
             <a:avLst/>
@@ -3274,14 +3338,53 @@
       </p:sp>
       <p:sp>
         <p:nvSpPr>
+          <p:cNvPr id="20" name="Text 15"/>
+          <p:cNvSpPr txBox="1"/>
+          <p:nvPr/>
+        </p:nvSpPr>
+        <p:spPr>
+          <a:xfrm>
+            <a:off x="8823960" y="1325880"/>
+            <a:ext cx="2907792" cy="329184"/>
+          </a:xfrm>
+          <a:prstGeom prst="rect">
+            <a:avLst/>
+          </a:prstGeom>
+          <a:noFill/>
+          <a:ln/>
+        </p:spPr>
+        <p:txBody>
+          <a:bodyPr wrap="square" lIns="0" tIns="0" rIns="0" bIns="0" rtlCol="0" anchor="ctr"/>
+          <a:lstStyle/>
+          <a:p>
+            <a:pPr algn="ctr" indent="0" marL="0">
+              <a:buNone/>
+            </a:pPr>
+            <a:r>
+              <a:rPr lang="en-US" sz="1150" b="1" dirty="0">
+                <a:solidFill>
+                  <a:srgbClr val="FFFFFF"/>
+                </a:solidFill>
+                <a:latin typeface="Arial" pitchFamily="34" charset="0"/>
+                <a:ea typeface="Arial" pitchFamily="34" charset="-122"/>
+                <a:cs typeface="Arial" pitchFamily="34" charset="-120"/>
+              </a:rPr>
+              <a:t>How to read it</a:t>
+            </a:r>
+            <a:endParaRPr lang="en-US" sz="1150" dirty="0"/>
+          </a:p>
+        </p:txBody>
+      </p:sp>
+      <p:sp>
+        <p:nvSpPr>
           <p:cNvPr id="21" name="Text 16"/>
           <p:cNvSpPr txBox="1"/>
           <p:nvPr/>
         </p:nvSpPr>
         <p:spPr>
           <a:xfrm>
-            <a:off x="10168128" y="1371600"/>
-            <a:ext cx="1517904" cy="384048"/>
+            <a:off x="8869680" y="1719072"/>
+            <a:ext cx="2834640" cy="1325880"/>
           </a:xfrm>
           <a:prstGeom prst="rect">
             <a:avLst/>
@@ -3294,10 +3397,50 @@
           <a:lstStyle/>
           <a:p>
             <a:pPr indent="0" marL="0">
+              <a:spcAft>
+                <a:spcPts val="300"/>
+              </a:spcAft>
               <a:buNone/>
             </a:pPr>
             <a:r>
-              <a:rPr lang="en-US" sz="1700" b="1" dirty="0">
+              <a:rPr lang="en-US" sz="900" b="1" dirty="0">
+                <a:solidFill>
+                  <a:srgbClr val="E67E22"/>
+                </a:solidFill>
+                <a:latin typeface="Arial" pitchFamily="34" charset="0"/>
+                <a:ea typeface="Arial" pitchFamily="34" charset="-122"/>
+                <a:cs typeface="Arial" pitchFamily="34" charset="-120"/>
+              </a:rPr>
+              <a:t>Orange dots: </a:t>
+            </a:r>
+            <a:pPr indent="0" marL="0">
+              <a:spcAft>
+                <a:spcPts val="300"/>
+              </a:spcAft>
+              <a:buNone/>
+            </a:pPr>
+            <a:r>
+              <a:rPr lang="en-US" sz="900" dirty="0">
+                <a:solidFill>
+                  <a:srgbClr val="262626"/>
+                </a:solidFill>
+                <a:latin typeface="Arial" pitchFamily="34" charset="0"/>
+                <a:ea typeface="Arial" pitchFamily="34" charset="-122"/>
+                <a:cs typeface="Arial" pitchFamily="34" charset="-120"/>
+              </a:rPr>
+              <a:t>each ETF on its own (2644 is the dot near 0.26, 0.25).</a:t>
+            </a:r>
+            <a:endParaRPr lang="en-US" sz="900" dirty="0"/>
+          </a:p>
+          <a:p>
+            <a:pPr indent="0" marL="0">
+              <a:spcAft>
+                <a:spcPts val="300"/>
+              </a:spcAft>
+              <a:buNone/>
+            </a:pPr>
+            <a:r>
+              <a:rPr lang="en-US" sz="900" b="1" dirty="0">
                 <a:solidFill>
                   <a:srgbClr val="2C5F82"/>
                 </a:solidFill>
@@ -3305,22 +3448,101 @@
                 <a:ea typeface="Arial" pitchFamily="34" charset="-122"/>
                 <a:cs typeface="Arial" pitchFamily="34" charset="-120"/>
               </a:rPr>
-              <a:t>$279.6k</a:t>
+              <a:t>Small dots: </a:t>
             </a:r>
-            <a:endParaRPr lang="en-US" sz="1700" dirty="0"/>
+            <a:pPr indent="0" marL="0">
+              <a:spcAft>
+                <a:spcPts val="300"/>
+              </a:spcAft>
+              <a:buNone/>
+            </a:pPr>
+            <a:r>
+              <a:rPr lang="en-US" sz="900" dirty="0">
+                <a:solidFill>
+                  <a:srgbClr val="262626"/>
+                </a:solidFill>
+                <a:latin typeface="Arial" pitchFamily="34" charset="0"/>
+                <a:ea typeface="Arial" pitchFamily="34" charset="-122"/>
+                <a:cs typeface="Arial" pitchFamily="34" charset="-120"/>
+              </a:rPr>
+              <a:t>thousands of random weightings of the five ETFs; lighter = more return per unit of risk.</a:t>
+            </a:r>
+            <a:endParaRPr lang="en-US" sz="900" dirty="0"/>
+          </a:p>
+          <a:p>
+            <a:pPr indent="0" marL="0">
+              <a:spcAft>
+                <a:spcPts val="300"/>
+              </a:spcAft>
+              <a:buNone/>
+            </a:pPr>
+            <a:r>
+              <a:rPr lang="en-US" sz="900" b="1" dirty="0">
+                <a:solidFill>
+                  <a:srgbClr val="262626"/>
+                </a:solidFill>
+                <a:latin typeface="Arial" pitchFamily="34" charset="0"/>
+                <a:ea typeface="Arial" pitchFamily="34" charset="-122"/>
+                <a:cs typeface="Arial" pitchFamily="34" charset="-120"/>
+              </a:rPr>
+              <a:t>Axes: </a:t>
+            </a:r>
+            <a:pPr indent="0" marL="0">
+              <a:spcAft>
+                <a:spcPts val="300"/>
+              </a:spcAft>
+              <a:buNone/>
+            </a:pPr>
+            <a:r>
+              <a:rPr lang="en-US" sz="900" dirty="0">
+                <a:solidFill>
+                  <a:srgbClr val="262626"/>
+                </a:solidFill>
+                <a:latin typeface="Arial" pitchFamily="34" charset="0"/>
+                <a:ea typeface="Arial" pitchFamily="34" charset="-122"/>
+                <a:cs typeface="Arial" pitchFamily="34" charset="-120"/>
+              </a:rPr>
+              <a:t>annualised volatility (risk) and expected return.</a:t>
+            </a:r>
+            <a:endParaRPr lang="en-US" sz="900" dirty="0"/>
           </a:p>
         </p:txBody>
       </p:sp>
       <p:sp>
         <p:nvSpPr>
-          <p:cNvPr id="22" name="Text 17"/>
+          <p:cNvPr id="22" name="Shape 17"/>
+          <p:cNvSpPr/>
+          <p:nvPr/>
+        </p:nvSpPr>
+        <p:spPr>
+          <a:xfrm>
+            <a:off x="8823960" y="3108960"/>
+            <a:ext cx="2907792" cy="2331720"/>
+          </a:xfrm>
+          <a:prstGeom prst="rect">
+            <a:avLst/>
+          </a:prstGeom>
+          <a:solidFill>
+            <a:srgbClr val="E8EFF5"/>
+          </a:solidFill>
+          <a:ln w="12700">
+            <a:solidFill>
+              <a:srgbClr val="E8EFF5"/>
+            </a:solidFill>
+            <a:prstDash val="solid"/>
+          </a:ln>
+        </p:spPr>
+      </p:sp>
+      <p:sp>
+        <p:nvSpPr>
+          <p:cNvPr id="23" name="Text 18"/>
           <p:cNvSpPr txBox="1"/>
           <p:nvPr/>
         </p:nvSpPr>
         <p:spPr>
           <a:xfrm>
-            <a:off x="10168128" y="1764792"/>
-            <a:ext cx="1517904" cy="457200"/>
+            <a:off x="8915400" y="3182112"/>
+            <a:ext cx="2743200" cy="2212848"/>
           </a:xfrm>
           <a:prstGeom prst="rect">
             <a:avLst/>
@@ -3333,410 +3555,113 @@
           <a:lstStyle/>
           <a:p>
             <a:pPr indent="0" marL="0">
+              <a:spcAft>
+                <a:spcPts val="400"/>
+              </a:spcAft>
               <a:buNone/>
             </a:pPr>
             <a:r>
-              <a:rPr lang="en-US" sz="850" dirty="0">
+              <a:rPr lang="en-US" sz="1100" b="1" dirty="0">
                 <a:solidFill>
-                  <a:srgbClr val="595959"/>
+                  <a:srgbClr val="2C5F82"/>
                 </a:solidFill>
                 <a:latin typeface="Arial" pitchFamily="34" charset="0"/>
                 <a:ea typeface="Arial" pitchFamily="34" charset="-122"/>
                 <a:cs typeface="Arial" pitchFamily="34" charset="-120"/>
               </a:rPr>
-              <a:t>Median, Year 5 (2.8×, +22.8% a year)</a:t>
+              <a:t>Takeaways</a:t>
             </a:r>
-            <a:endParaRPr lang="en-US" sz="850" dirty="0"/>
+            <a:endParaRPr lang="en-US" sz="950" dirty="0"/>
           </a:p>
-        </p:txBody>
-      </p:sp>
-      <p:sp>
-        <p:nvSpPr>
-          <p:cNvPr id="23" name="Shape 18"/>
-          <p:cNvSpPr/>
-          <p:nvPr/>
-        </p:nvSpPr>
-        <p:spPr>
-          <a:xfrm>
-            <a:off x="10058400" y="2331720"/>
-            <a:ext cx="1673352" cy="914400"/>
-          </a:xfrm>
-          <a:prstGeom prst="rect">
-            <a:avLst/>
-          </a:prstGeom>
-          <a:solidFill>
-            <a:srgbClr val="F2F2F2"/>
-          </a:solidFill>
-          <a:ln w="12700">
-            <a:solidFill>
-              <a:srgbClr val="F2F2F2"/>
-            </a:solidFill>
-            <a:prstDash val="solid"/>
-          </a:ln>
-        </p:spPr>
-      </p:sp>
-      <p:sp>
-        <p:nvSpPr>
-          <p:cNvPr id="24" name="Shape 19"/>
-          <p:cNvSpPr/>
-          <p:nvPr/>
-        </p:nvSpPr>
-        <p:spPr>
-          <a:xfrm>
-            <a:off x="10058400" y="2331720"/>
-            <a:ext cx="54864" cy="914400"/>
-          </a:xfrm>
-          <a:prstGeom prst="rect">
-            <a:avLst/>
-          </a:prstGeom>
-          <a:solidFill>
-            <a:srgbClr val="C0392B"/>
-          </a:solidFill>
-          <a:ln w="12700">
-            <a:solidFill>
-              <a:srgbClr val="C0392B"/>
-            </a:solidFill>
-            <a:prstDash val="solid"/>
-          </a:ln>
-        </p:spPr>
-      </p:sp>
-      <p:sp>
-        <p:nvSpPr>
-          <p:cNvPr id="25" name="Text 20"/>
-          <p:cNvSpPr txBox="1"/>
-          <p:nvPr/>
-        </p:nvSpPr>
-        <p:spPr>
-          <a:xfrm>
-            <a:off x="10168128" y="2377440"/>
-            <a:ext cx="1517904" cy="384048"/>
-          </a:xfrm>
-          <a:prstGeom prst="rect">
-            <a:avLst/>
-          </a:prstGeom>
-          <a:noFill/>
-          <a:ln/>
-        </p:spPr>
-        <p:txBody>
-          <a:bodyPr wrap="square" lIns="0" tIns="0" rIns="0" bIns="0" rtlCol="0" anchor="t"/>
-          <a:lstStyle/>
           <a:p>
-            <a:pPr indent="0" marL="0">
-              <a:buNone/>
+            <a:pPr marL="342900" indent="-342900">
+              <a:spcAft>
+                <a:spcPts val="400"/>
+              </a:spcAft>
+              <a:buSzPct val="100000"/>
+              <a:buChar char="•"/>
             </a:pPr>
             <a:r>
-              <a:rPr lang="en-US" sz="1700" b="1" dirty="0">
+              <a:rPr lang="en-US" sz="950" dirty="0">
                 <a:solidFill>
-                  <a:srgbClr val="C0392B"/>
+                  <a:srgbClr val="262626"/>
                 </a:solidFill>
                 <a:latin typeface="Arial" pitchFamily="34" charset="0"/>
                 <a:ea typeface="Arial" pitchFamily="34" charset="-122"/>
                 <a:cs typeface="Arial" pitchFamily="34" charset="-120"/>
               </a:rPr>
-              <a:t>$103.6k</a:t>
+              <a:t>Mixing cuts risk: most mixes sit at 22–32% volatility, far below EWY (~49%), while still returning 25–28%.</a:t>
             </a:r>
-            <a:endParaRPr lang="en-US" sz="1700" dirty="0"/>
+            <a:endParaRPr lang="en-US" sz="950" dirty="0"/>
           </a:p>
-        </p:txBody>
-      </p:sp>
-      <p:sp>
-        <p:nvSpPr>
-          <p:cNvPr id="26" name="Text 21"/>
-          <p:cNvSpPr txBox="1"/>
-          <p:nvPr/>
-        </p:nvSpPr>
-        <p:spPr>
-          <a:xfrm>
-            <a:off x="10168128" y="2770632"/>
-            <a:ext cx="1517904" cy="457200"/>
-          </a:xfrm>
-          <a:prstGeom prst="rect">
-            <a:avLst/>
-          </a:prstGeom>
-          <a:noFill/>
-          <a:ln/>
-        </p:spPr>
-        <p:txBody>
-          <a:bodyPr wrap="square" lIns="0" tIns="0" rIns="0" bIns="0" rtlCol="0" anchor="t"/>
-          <a:lstStyle/>
           <a:p>
-            <a:pPr indent="0" marL="0">
-              <a:buNone/>
+            <a:pPr marL="342900" indent="-342900">
+              <a:spcAft>
+                <a:spcPts val="400"/>
+              </a:spcAft>
+              <a:buSzPct val="100000"/>
+              <a:buChar char="•"/>
             </a:pPr>
             <a:r>
-              <a:rPr lang="en-US" sz="850" dirty="0">
+              <a:rPr lang="en-US" sz="950" dirty="0">
                 <a:solidFill>
-                  <a:srgbClr val="595959"/>
+                  <a:srgbClr val="262626"/>
                 </a:solidFill>
                 <a:latin typeface="Arial" pitchFamily="34" charset="0"/>
                 <a:ea typeface="Arial" pitchFamily="34" charset="-122"/>
                 <a:cs typeface="Arial" pitchFamily="34" charset="-120"/>
               </a:rPr>
-              <a:t>Bearish 5th percentile: above the start</a:t>
+              <a:t>3119 HK has the best risk/return on its own, so it gets the largest weight (35%).</a:t>
             </a:r>
-            <a:endParaRPr lang="en-US" sz="850" dirty="0"/>
+            <a:endParaRPr lang="en-US" sz="950" dirty="0"/>
           </a:p>
-        </p:txBody>
-      </p:sp>
-      <p:sp>
-        <p:nvSpPr>
-          <p:cNvPr id="27" name="Shape 22"/>
-          <p:cNvSpPr/>
-          <p:nvPr/>
-        </p:nvSpPr>
-        <p:spPr>
-          <a:xfrm>
-            <a:off x="10058400" y="3337560"/>
-            <a:ext cx="1673352" cy="914400"/>
-          </a:xfrm>
-          <a:prstGeom prst="rect">
-            <a:avLst/>
-          </a:prstGeom>
-          <a:solidFill>
-            <a:srgbClr val="F2F2F2"/>
-          </a:solidFill>
-          <a:ln w="12700">
-            <a:solidFill>
-              <a:srgbClr val="F2F2F2"/>
-            </a:solidFill>
-            <a:prstDash val="solid"/>
-          </a:ln>
-        </p:spPr>
-      </p:sp>
-      <p:sp>
-        <p:nvSpPr>
-          <p:cNvPr id="28" name="Shape 23"/>
-          <p:cNvSpPr/>
-          <p:nvPr/>
-        </p:nvSpPr>
-        <p:spPr>
-          <a:xfrm>
-            <a:off x="10058400" y="3337560"/>
-            <a:ext cx="54864" cy="914400"/>
-          </a:xfrm>
-          <a:prstGeom prst="rect">
-            <a:avLst/>
-          </a:prstGeom>
-          <a:solidFill>
-            <a:srgbClr val="2E9E44"/>
-          </a:solidFill>
-          <a:ln w="12700">
-            <a:solidFill>
-              <a:srgbClr val="2E9E44"/>
-            </a:solidFill>
-            <a:prstDash val="solid"/>
-          </a:ln>
-        </p:spPr>
-      </p:sp>
-      <p:sp>
-        <p:nvSpPr>
-          <p:cNvPr id="29" name="Text 24"/>
-          <p:cNvSpPr txBox="1"/>
-          <p:nvPr/>
-        </p:nvSpPr>
-        <p:spPr>
-          <a:xfrm>
-            <a:off x="10168128" y="3383280"/>
-            <a:ext cx="1517904" cy="384048"/>
-          </a:xfrm>
-          <a:prstGeom prst="rect">
-            <a:avLst/>
-          </a:prstGeom>
-          <a:noFill/>
-          <a:ln/>
-        </p:spPr>
-        <p:txBody>
-          <a:bodyPr wrap="square" lIns="0" tIns="0" rIns="0" bIns="0" rtlCol="0" anchor="t"/>
-          <a:lstStyle/>
           <a:p>
-            <a:pPr indent="0" marL="0">
-              <a:buNone/>
+            <a:pPr marL="342900" indent="-342900">
+              <a:spcAft>
+                <a:spcPts val="400"/>
+              </a:spcAft>
+              <a:buSzPct val="100000"/>
+              <a:buChar char="•"/>
             </a:pPr>
             <a:r>
-              <a:rPr lang="en-US" sz="1700" b="1" dirty="0">
+              <a:rPr lang="en-US" sz="950" dirty="0">
                 <a:solidFill>
-                  <a:srgbClr val="2E9E44"/>
+                  <a:srgbClr val="262626"/>
                 </a:solidFill>
                 <a:latin typeface="Arial" pitchFamily="34" charset="0"/>
                 <a:ea typeface="Arial" pitchFamily="34" charset="-122"/>
                 <a:cs typeface="Arial" pitchFamily="34" charset="-120"/>
               </a:rPr>
-              <a:t>$770.5k</a:t>
+              <a:t>EWY is the riskiest for its return, so it is held for memory exposure at 20%, not more.</a:t>
             </a:r>
-            <a:endParaRPr lang="en-US" sz="1700" dirty="0"/>
+            <a:endParaRPr lang="en-US" sz="950" dirty="0"/>
           </a:p>
-        </p:txBody>
-      </p:sp>
-      <p:sp>
-        <p:nvSpPr>
-          <p:cNvPr id="30" name="Text 25"/>
-          <p:cNvSpPr txBox="1"/>
-          <p:nvPr/>
-        </p:nvSpPr>
-        <p:spPr>
-          <a:xfrm>
-            <a:off x="10168128" y="3776472"/>
-            <a:ext cx="1517904" cy="457200"/>
-          </a:xfrm>
-          <a:prstGeom prst="rect">
-            <a:avLst/>
-          </a:prstGeom>
-          <a:noFill/>
-          <a:ln/>
-        </p:spPr>
-        <p:txBody>
-          <a:bodyPr wrap="square" lIns="0" tIns="0" rIns="0" bIns="0" rtlCol="0" anchor="t"/>
-          <a:lstStyle/>
           <a:p>
-            <a:pPr indent="0" marL="0">
-              <a:buNone/>
+            <a:pPr marL="342900" indent="-342900">
+              <a:spcAft>
+                <a:spcPts val="400"/>
+              </a:spcAft>
+              <a:buSzPct val="100000"/>
+              <a:buChar char="•"/>
             </a:pPr>
             <a:r>
-              <a:rPr lang="en-US" sz="850" dirty="0">
+              <a:rPr lang="en-US" sz="950" dirty="0">
                 <a:solidFill>
-                  <a:srgbClr val="595959"/>
+                  <a:srgbClr val="262626"/>
                 </a:solidFill>
                 <a:latin typeface="Arial" pitchFamily="34" charset="0"/>
                 <a:ea typeface="Arial" pitchFamily="34" charset="-122"/>
                 <a:cs typeface="Arial" pitchFamily="34" charset="-120"/>
               </a:rPr>
-              <a:t>Bullish 95th percentile (7.7×)</a:t>
+              <a:t>EWT has the highest return (~31%) and 2644 one of the lowest volatilities (~26%): 15% each rounds out the chain.</a:t>
             </a:r>
-            <a:endParaRPr lang="en-US" sz="850" dirty="0"/>
+            <a:endParaRPr lang="en-US" sz="950" dirty="0"/>
           </a:p>
         </p:txBody>
       </p:sp>
       <p:sp>
         <p:nvSpPr>
-          <p:cNvPr id="31" name="Shape 26"/>
-          <p:cNvSpPr/>
-          <p:nvPr/>
-        </p:nvSpPr>
-        <p:spPr>
-          <a:xfrm>
-            <a:off x="10058400" y="4343400"/>
-            <a:ext cx="1673352" cy="914400"/>
-          </a:xfrm>
-          <a:prstGeom prst="rect">
-            <a:avLst/>
-          </a:prstGeom>
-          <a:solidFill>
-            <a:srgbClr val="F2F2F2"/>
-          </a:solidFill>
-          <a:ln w="12700">
-            <a:solidFill>
-              <a:srgbClr val="F2F2F2"/>
-            </a:solidFill>
-            <a:prstDash val="solid"/>
-          </a:ln>
-        </p:spPr>
-      </p:sp>
-      <p:sp>
-        <p:nvSpPr>
-          <p:cNvPr id="32" name="Shape 27"/>
-          <p:cNvSpPr/>
-          <p:nvPr/>
-        </p:nvSpPr>
-        <p:spPr>
-          <a:xfrm>
-            <a:off x="10058400" y="4343400"/>
-            <a:ext cx="54864" cy="914400"/>
-          </a:xfrm>
-          <a:prstGeom prst="rect">
-            <a:avLst/>
-          </a:prstGeom>
-          <a:solidFill>
-            <a:srgbClr val="E67E22"/>
-          </a:solidFill>
-          <a:ln w="12700">
-            <a:solidFill>
-              <a:srgbClr val="E67E22"/>
-            </a:solidFill>
-            <a:prstDash val="solid"/>
-          </a:ln>
-        </p:spPr>
-      </p:sp>
-      <p:sp>
-        <p:nvSpPr>
-          <p:cNvPr id="33" name="Text 28"/>
-          <p:cNvSpPr txBox="1"/>
-          <p:nvPr/>
-        </p:nvSpPr>
-        <p:spPr>
-          <a:xfrm>
-            <a:off x="10168128" y="4389120"/>
-            <a:ext cx="1517904" cy="384048"/>
-          </a:xfrm>
-          <a:prstGeom prst="rect">
-            <a:avLst/>
-          </a:prstGeom>
-          <a:noFill/>
-          <a:ln/>
-        </p:spPr>
-        <p:txBody>
-          <a:bodyPr wrap="square" lIns="0" tIns="0" rIns="0" bIns="0" rtlCol="0" anchor="t"/>
-          <a:lstStyle/>
-          <a:p>
-            <a:pPr indent="0" marL="0">
-              <a:buNone/>
-            </a:pPr>
-            <a:r>
-              <a:rPr lang="en-US" sz="1700" b="1" dirty="0">
-                <a:solidFill>
-                  <a:srgbClr val="E67E22"/>
-                </a:solidFill>
-                <a:latin typeface="Arial" pitchFamily="34" charset="0"/>
-                <a:ea typeface="Arial" pitchFamily="34" charset="-122"/>
-                <a:cs typeface="Arial" pitchFamily="34" charset="-120"/>
-              </a:rPr>
-              <a:t>99.0%</a:t>
-            </a:r>
-            <a:endParaRPr lang="en-US" sz="1700" dirty="0"/>
-          </a:p>
-        </p:txBody>
-      </p:sp>
-      <p:sp>
-        <p:nvSpPr>
-          <p:cNvPr id="34" name="Text 29"/>
-          <p:cNvSpPr txBox="1"/>
-          <p:nvPr/>
-        </p:nvSpPr>
-        <p:spPr>
-          <a:xfrm>
-            <a:off x="10168128" y="4782312"/>
-            <a:ext cx="1517904" cy="457200"/>
-          </a:xfrm>
-          <a:prstGeom prst="rect">
-            <a:avLst/>
-          </a:prstGeom>
-          <a:noFill/>
-          <a:ln/>
-        </p:spPr>
-        <p:txBody>
-          <a:bodyPr wrap="square" lIns="0" tIns="0" rIns="0" bIns="0" rtlCol="0" anchor="t"/>
-          <a:lstStyle/>
-          <a:p>
-            <a:pPr indent="0" marL="0">
-              <a:buNone/>
-            </a:pPr>
-            <a:r>
-              <a:rPr lang="en-US" sz="850" dirty="0">
-                <a:solidFill>
-                  <a:srgbClr val="595959"/>
-                </a:solidFill>
-                <a:latin typeface="Arial" pitchFamily="34" charset="0"/>
-                <a:ea typeface="Arial" pitchFamily="34" charset="-122"/>
-                <a:cs typeface="Arial" pitchFamily="34" charset="-120"/>
-              </a:rPr>
-              <a:t>Chance of ending ≥ USD 70,000</a:t>
-            </a:r>
-            <a:endParaRPr lang="en-US" sz="850" dirty="0"/>
-          </a:p>
-        </p:txBody>
-      </p:sp>
-      <p:sp>
-        <p:nvSpPr>
-          <p:cNvPr id="35" name="Shape 30"/>
+          <p:cNvPr id="24" name="Shape 19"/>
           <p:cNvSpPr/>
           <p:nvPr/>
         </p:nvSpPr>
@@ -3761,7 +3686,7 @@
       </p:sp>
       <p:sp>
         <p:nvSpPr>
-          <p:cNvPr id="36" name="Text 31"/>
+          <p:cNvPr id="25" name="Text 20"/>
           <p:cNvSpPr txBox="1"/>
           <p:nvPr/>
         </p:nvSpPr>
@@ -3792,7 +3717,7 @@
                 <a:ea typeface="Arial" pitchFamily="34" charset="-122"/>
                 <a:cs typeface="Arial" pitchFamily="34" charset="-120"/>
               </a:rPr>
-              <a:t>One theme, five bottlenecks: the median grows 2.8× in five years, and even the bearish path ends above the start ($103.6k)</a:t>
+              <a:t>One theme, five bottlenecks: weighted towards the best risk/return (3119 HK), diversified to keep volatility down</a:t>
             </a:r>
             <a:endParaRPr lang="en-US" sz="1200" dirty="0"/>
           </a:p>
@@ -3800,7 +3725,7 @@
       </p:sp>
       <p:sp>
         <p:nvSpPr>
-          <p:cNvPr id="37" name="Text 32"/>
+          <p:cNvPr id="26" name="Text 21"/>
           <p:cNvSpPr txBox="1"/>
           <p:nvPr/>
         </p:nvSpPr>
@@ -3831,7 +3756,7 @@
                 <a:ea typeface="Arial" pitchFamily="34" charset="-122"/>
                 <a:cs typeface="Arial" pitchFamily="34" charset="-120"/>
               </a:rPr>
-              <a:t>Source: team Monte Carlo app (annual checkpoints; lines connect the yearly values; target USD 70,000 = 1st percentile). Liquidity: 3119 HK is borderline against the USD 5M/day rule, verify on Bloomberg.</a:t>
+              <a:t>Risk/return chart: team analysis app (annualised from historical data; red star as marked in the app). Liquidity: 3119 HK is borderline against the USD 5M/day rule, verify on Bloomberg.</a:t>
             </a:r>
             <a:endParaRPr lang="en-US" sz="800" dirty="0"/>
           </a:p>
@@ -3902,7 +3827,7 @@
                 <a:ea typeface="Arial" pitchFamily="34" charset="-122"/>
                 <a:cs typeface="Arial" pitchFamily="34" charset="-120"/>
               </a:rPr>
-              <a:t>Annual checkpoints: the downside stays above the USD 70,000 target</a:t>
+              <a:t>Monte Carlo: the median portfolio grows 2.8× in five years</a:t>
             </a:r>
             <a:endParaRPr lang="en-US" sz="2200" dirty="0"/>
           </a:p>
@@ -4129,6 +4054,943 @@
                 <a:ea typeface="Arial" pitchFamily="34" charset="-122"/>
                 <a:cs typeface="Arial" pitchFamily="34" charset="-120"/>
               </a:rPr>
+              <a:t>5-year simulation of the five-ETF portfolio, per USD 100,000 invested (×1,000 for the USD 100mn mandate)</a:t>
+            </a:r>
+            <a:endParaRPr lang="en-US" sz="1100" dirty="0"/>
+          </a:p>
+        </p:txBody>
+      </p:sp>
+      <p:pic>
+        <p:nvPicPr>
+          <p:cNvPr id="10" name="Image 0" descr="/home/user/natixis-case-comp/strategy/mc_checkpoints.png">    </p:cNvPr>
+          <p:cNvPicPr>
+            <a:picLocks noChangeAspect="1"/>
+          </p:cNvPicPr>
+          <p:nvPr/>
+        </p:nvPicPr>
+        <p:blipFill>
+          <a:blip r:embed="rId1"/>
+          <a:stretch>
+            <a:fillRect/>
+          </a:stretch>
+        </p:blipFill>
+        <p:spPr>
+          <a:xfrm>
+            <a:off x="457200" y="1298448"/>
+            <a:ext cx="7498080" cy="4272162"/>
+          </a:xfrm>
+          <a:prstGeom prst="rect">
+            <a:avLst/>
+          </a:prstGeom>
+        </p:spPr>
+      </p:pic>
+      <p:sp>
+        <p:nvSpPr>
+          <p:cNvPr id="11" name="Shape 8"/>
+          <p:cNvSpPr/>
+          <p:nvPr/>
+        </p:nvSpPr>
+        <p:spPr>
+          <a:xfrm>
+            <a:off x="8183880" y="1325880"/>
+            <a:ext cx="3547872" cy="914400"/>
+          </a:xfrm>
+          <a:prstGeom prst="rect">
+            <a:avLst/>
+          </a:prstGeom>
+          <a:solidFill>
+            <a:srgbClr val="F2F2F2"/>
+          </a:solidFill>
+          <a:ln w="12700">
+            <a:solidFill>
+              <a:srgbClr val="F2F2F2"/>
+            </a:solidFill>
+            <a:prstDash val="solid"/>
+          </a:ln>
+        </p:spPr>
+      </p:sp>
+      <p:sp>
+        <p:nvSpPr>
+          <p:cNvPr id="12" name="Shape 9"/>
+          <p:cNvSpPr/>
+          <p:nvPr/>
+        </p:nvSpPr>
+        <p:spPr>
+          <a:xfrm>
+            <a:off x="8183880" y="1325880"/>
+            <a:ext cx="64008" cy="914400"/>
+          </a:xfrm>
+          <a:prstGeom prst="rect">
+            <a:avLst/>
+          </a:prstGeom>
+          <a:solidFill>
+            <a:srgbClr val="2C5F82"/>
+          </a:solidFill>
+          <a:ln w="12700">
+            <a:solidFill>
+              <a:srgbClr val="2C5F82"/>
+            </a:solidFill>
+            <a:prstDash val="solid"/>
+          </a:ln>
+        </p:spPr>
+      </p:sp>
+      <p:sp>
+        <p:nvSpPr>
+          <p:cNvPr id="13" name="Text 10"/>
+          <p:cNvSpPr txBox="1"/>
+          <p:nvPr/>
+        </p:nvSpPr>
+        <p:spPr>
+          <a:xfrm>
+            <a:off x="8366760" y="1380744"/>
+            <a:ext cx="3291840" cy="457200"/>
+          </a:xfrm>
+          <a:prstGeom prst="rect">
+            <a:avLst/>
+          </a:prstGeom>
+          <a:noFill/>
+          <a:ln/>
+        </p:spPr>
+        <p:txBody>
+          <a:bodyPr wrap="square" lIns="0" tIns="0" rIns="0" bIns="0" rtlCol="0" anchor="t"/>
+          <a:lstStyle/>
+          <a:p>
+            <a:pPr indent="0" marL="0">
+              <a:buNone/>
+            </a:pPr>
+            <a:r>
+              <a:rPr lang="en-US" sz="2200" b="1" dirty="0">
+                <a:solidFill>
+                  <a:srgbClr val="2C5F82"/>
+                </a:solidFill>
+                <a:latin typeface="Arial" pitchFamily="34" charset="0"/>
+                <a:ea typeface="Arial" pitchFamily="34" charset="-122"/>
+                <a:cs typeface="Arial" pitchFamily="34" charset="-120"/>
+              </a:rPr>
+              <a:t>$279.6k</a:t>
+            </a:r>
+            <a:endParaRPr lang="en-US" sz="2200" dirty="0"/>
+          </a:p>
+        </p:txBody>
+      </p:sp>
+      <p:sp>
+        <p:nvSpPr>
+          <p:cNvPr id="14" name="Text 11"/>
+          <p:cNvSpPr txBox="1"/>
+          <p:nvPr/>
+        </p:nvSpPr>
+        <p:spPr>
+          <a:xfrm>
+            <a:off x="8366760" y="1837944"/>
+            <a:ext cx="3291840" cy="365760"/>
+          </a:xfrm>
+          <a:prstGeom prst="rect">
+            <a:avLst/>
+          </a:prstGeom>
+          <a:noFill/>
+          <a:ln/>
+        </p:spPr>
+        <p:txBody>
+          <a:bodyPr wrap="square" lIns="0" tIns="0" rIns="0" bIns="0" rtlCol="0" anchor="t"/>
+          <a:lstStyle/>
+          <a:p>
+            <a:pPr indent="0" marL="0">
+              <a:buNone/>
+            </a:pPr>
+            <a:r>
+              <a:rPr lang="en-US" sz="950" dirty="0">
+                <a:solidFill>
+                  <a:srgbClr val="595959"/>
+                </a:solidFill>
+                <a:latin typeface="Arial" pitchFamily="34" charset="0"/>
+                <a:ea typeface="Arial" pitchFamily="34" charset="-122"/>
+                <a:cs typeface="Arial" pitchFamily="34" charset="-120"/>
+              </a:rPr>
+              <a:t>Median at Year 5: 2.8× the start, +22.8% a year</a:t>
+            </a:r>
+            <a:endParaRPr lang="en-US" sz="950" dirty="0"/>
+          </a:p>
+        </p:txBody>
+      </p:sp>
+      <p:sp>
+        <p:nvSpPr>
+          <p:cNvPr id="15" name="Shape 12"/>
+          <p:cNvSpPr/>
+          <p:nvPr/>
+        </p:nvSpPr>
+        <p:spPr>
+          <a:xfrm>
+            <a:off x="8183880" y="2350008"/>
+            <a:ext cx="3547872" cy="914400"/>
+          </a:xfrm>
+          <a:prstGeom prst="rect">
+            <a:avLst/>
+          </a:prstGeom>
+          <a:solidFill>
+            <a:srgbClr val="F2F2F2"/>
+          </a:solidFill>
+          <a:ln w="12700">
+            <a:solidFill>
+              <a:srgbClr val="F2F2F2"/>
+            </a:solidFill>
+            <a:prstDash val="solid"/>
+          </a:ln>
+        </p:spPr>
+      </p:sp>
+      <p:sp>
+        <p:nvSpPr>
+          <p:cNvPr id="16" name="Shape 13"/>
+          <p:cNvSpPr/>
+          <p:nvPr/>
+        </p:nvSpPr>
+        <p:spPr>
+          <a:xfrm>
+            <a:off x="8183880" y="2350008"/>
+            <a:ext cx="64008" cy="914400"/>
+          </a:xfrm>
+          <a:prstGeom prst="rect">
+            <a:avLst/>
+          </a:prstGeom>
+          <a:solidFill>
+            <a:srgbClr val="C0392B"/>
+          </a:solidFill>
+          <a:ln w="12700">
+            <a:solidFill>
+              <a:srgbClr val="C0392B"/>
+            </a:solidFill>
+            <a:prstDash val="solid"/>
+          </a:ln>
+        </p:spPr>
+      </p:sp>
+      <p:sp>
+        <p:nvSpPr>
+          <p:cNvPr id="17" name="Text 14"/>
+          <p:cNvSpPr txBox="1"/>
+          <p:nvPr/>
+        </p:nvSpPr>
+        <p:spPr>
+          <a:xfrm>
+            <a:off x="8366760" y="2404872"/>
+            <a:ext cx="3291840" cy="457200"/>
+          </a:xfrm>
+          <a:prstGeom prst="rect">
+            <a:avLst/>
+          </a:prstGeom>
+          <a:noFill/>
+          <a:ln/>
+        </p:spPr>
+        <p:txBody>
+          <a:bodyPr wrap="square" lIns="0" tIns="0" rIns="0" bIns="0" rtlCol="0" anchor="t"/>
+          <a:lstStyle/>
+          <a:p>
+            <a:pPr indent="0" marL="0">
+              <a:buNone/>
+            </a:pPr>
+            <a:r>
+              <a:rPr lang="en-US" sz="2200" b="1" dirty="0">
+                <a:solidFill>
+                  <a:srgbClr val="C0392B"/>
+                </a:solidFill>
+                <a:latin typeface="Arial" pitchFamily="34" charset="0"/>
+                <a:ea typeface="Arial" pitchFamily="34" charset="-122"/>
+                <a:cs typeface="Arial" pitchFamily="34" charset="-120"/>
+              </a:rPr>
+              <a:t>$103.6k</a:t>
+            </a:r>
+            <a:endParaRPr lang="en-US" sz="2200" dirty="0"/>
+          </a:p>
+        </p:txBody>
+      </p:sp>
+      <p:sp>
+        <p:nvSpPr>
+          <p:cNvPr id="18" name="Text 15"/>
+          <p:cNvSpPr txBox="1"/>
+          <p:nvPr/>
+        </p:nvSpPr>
+        <p:spPr>
+          <a:xfrm>
+            <a:off x="8366760" y="2862072"/>
+            <a:ext cx="3291840" cy="365760"/>
+          </a:xfrm>
+          <a:prstGeom prst="rect">
+            <a:avLst/>
+          </a:prstGeom>
+          <a:noFill/>
+          <a:ln/>
+        </p:spPr>
+        <p:txBody>
+          <a:bodyPr wrap="square" lIns="0" tIns="0" rIns="0" bIns="0" rtlCol="0" anchor="t"/>
+          <a:lstStyle/>
+          <a:p>
+            <a:pPr indent="0" marL="0">
+              <a:buNone/>
+            </a:pPr>
+            <a:r>
+              <a:rPr lang="en-US" sz="950" dirty="0">
+                <a:solidFill>
+                  <a:srgbClr val="595959"/>
+                </a:solidFill>
+                <a:latin typeface="Arial" pitchFamily="34" charset="0"/>
+                <a:ea typeface="Arial" pitchFamily="34" charset="-122"/>
+                <a:cs typeface="Arial" pitchFamily="34" charset="-120"/>
+              </a:rPr>
+              <a:t>Bearish (5th percentile): still above the start, +0.7% a year</a:t>
+            </a:r>
+            <a:endParaRPr lang="en-US" sz="950" dirty="0"/>
+          </a:p>
+        </p:txBody>
+      </p:sp>
+      <p:sp>
+        <p:nvSpPr>
+          <p:cNvPr id="19" name="Shape 16"/>
+          <p:cNvSpPr/>
+          <p:nvPr/>
+        </p:nvSpPr>
+        <p:spPr>
+          <a:xfrm>
+            <a:off x="8183880" y="3374136"/>
+            <a:ext cx="3547872" cy="914400"/>
+          </a:xfrm>
+          <a:prstGeom prst="rect">
+            <a:avLst/>
+          </a:prstGeom>
+          <a:solidFill>
+            <a:srgbClr val="F2F2F2"/>
+          </a:solidFill>
+          <a:ln w="12700">
+            <a:solidFill>
+              <a:srgbClr val="F2F2F2"/>
+            </a:solidFill>
+            <a:prstDash val="solid"/>
+          </a:ln>
+        </p:spPr>
+      </p:sp>
+      <p:sp>
+        <p:nvSpPr>
+          <p:cNvPr id="20" name="Shape 17"/>
+          <p:cNvSpPr/>
+          <p:nvPr/>
+        </p:nvSpPr>
+        <p:spPr>
+          <a:xfrm>
+            <a:off x="8183880" y="3374136"/>
+            <a:ext cx="64008" cy="914400"/>
+          </a:xfrm>
+          <a:prstGeom prst="rect">
+            <a:avLst/>
+          </a:prstGeom>
+          <a:solidFill>
+            <a:srgbClr val="2E9E44"/>
+          </a:solidFill>
+          <a:ln w="12700">
+            <a:solidFill>
+              <a:srgbClr val="2E9E44"/>
+            </a:solidFill>
+            <a:prstDash val="solid"/>
+          </a:ln>
+        </p:spPr>
+      </p:sp>
+      <p:sp>
+        <p:nvSpPr>
+          <p:cNvPr id="21" name="Text 18"/>
+          <p:cNvSpPr txBox="1"/>
+          <p:nvPr/>
+        </p:nvSpPr>
+        <p:spPr>
+          <a:xfrm>
+            <a:off x="8366760" y="3429000"/>
+            <a:ext cx="3291840" cy="457200"/>
+          </a:xfrm>
+          <a:prstGeom prst="rect">
+            <a:avLst/>
+          </a:prstGeom>
+          <a:noFill/>
+          <a:ln/>
+        </p:spPr>
+        <p:txBody>
+          <a:bodyPr wrap="square" lIns="0" tIns="0" rIns="0" bIns="0" rtlCol="0" anchor="t"/>
+          <a:lstStyle/>
+          <a:p>
+            <a:pPr indent="0" marL="0">
+              <a:buNone/>
+            </a:pPr>
+            <a:r>
+              <a:rPr lang="en-US" sz="2200" b="1" dirty="0">
+                <a:solidFill>
+                  <a:srgbClr val="2E9E44"/>
+                </a:solidFill>
+                <a:latin typeface="Arial" pitchFamily="34" charset="0"/>
+                <a:ea typeface="Arial" pitchFamily="34" charset="-122"/>
+                <a:cs typeface="Arial" pitchFamily="34" charset="-120"/>
+              </a:rPr>
+              <a:t>$770.5k</a:t>
+            </a:r>
+            <a:endParaRPr lang="en-US" sz="2200" dirty="0"/>
+          </a:p>
+        </p:txBody>
+      </p:sp>
+      <p:sp>
+        <p:nvSpPr>
+          <p:cNvPr id="22" name="Text 19"/>
+          <p:cNvSpPr txBox="1"/>
+          <p:nvPr/>
+        </p:nvSpPr>
+        <p:spPr>
+          <a:xfrm>
+            <a:off x="8366760" y="3886200"/>
+            <a:ext cx="3291840" cy="365760"/>
+          </a:xfrm>
+          <a:prstGeom prst="rect">
+            <a:avLst/>
+          </a:prstGeom>
+          <a:noFill/>
+          <a:ln/>
+        </p:spPr>
+        <p:txBody>
+          <a:bodyPr wrap="square" lIns="0" tIns="0" rIns="0" bIns="0" rtlCol="0" anchor="t"/>
+          <a:lstStyle/>
+          <a:p>
+            <a:pPr indent="0" marL="0">
+              <a:buNone/>
+            </a:pPr>
+            <a:r>
+              <a:rPr lang="en-US" sz="950" dirty="0">
+                <a:solidFill>
+                  <a:srgbClr val="595959"/>
+                </a:solidFill>
+                <a:latin typeface="Arial" pitchFamily="34" charset="0"/>
+                <a:ea typeface="Arial" pitchFamily="34" charset="-122"/>
+                <a:cs typeface="Arial" pitchFamily="34" charset="-120"/>
+              </a:rPr>
+              <a:t>Bullish (95th percentile): 7.7× the start</a:t>
+            </a:r>
+            <a:endParaRPr lang="en-US" sz="950" dirty="0"/>
+          </a:p>
+        </p:txBody>
+      </p:sp>
+      <p:sp>
+        <p:nvSpPr>
+          <p:cNvPr id="23" name="Shape 20"/>
+          <p:cNvSpPr/>
+          <p:nvPr/>
+        </p:nvSpPr>
+        <p:spPr>
+          <a:xfrm>
+            <a:off x="8183880" y="4398264"/>
+            <a:ext cx="3547872" cy="914400"/>
+          </a:xfrm>
+          <a:prstGeom prst="rect">
+            <a:avLst/>
+          </a:prstGeom>
+          <a:solidFill>
+            <a:srgbClr val="F2F2F2"/>
+          </a:solidFill>
+          <a:ln w="12700">
+            <a:solidFill>
+              <a:srgbClr val="F2F2F2"/>
+            </a:solidFill>
+            <a:prstDash val="solid"/>
+          </a:ln>
+        </p:spPr>
+      </p:sp>
+      <p:sp>
+        <p:nvSpPr>
+          <p:cNvPr id="24" name="Shape 21"/>
+          <p:cNvSpPr/>
+          <p:nvPr/>
+        </p:nvSpPr>
+        <p:spPr>
+          <a:xfrm>
+            <a:off x="8183880" y="4398264"/>
+            <a:ext cx="64008" cy="914400"/>
+          </a:xfrm>
+          <a:prstGeom prst="rect">
+            <a:avLst/>
+          </a:prstGeom>
+          <a:solidFill>
+            <a:srgbClr val="E67E22"/>
+          </a:solidFill>
+          <a:ln w="12700">
+            <a:solidFill>
+              <a:srgbClr val="E67E22"/>
+            </a:solidFill>
+            <a:prstDash val="solid"/>
+          </a:ln>
+        </p:spPr>
+      </p:sp>
+      <p:sp>
+        <p:nvSpPr>
+          <p:cNvPr id="25" name="Text 22"/>
+          <p:cNvSpPr txBox="1"/>
+          <p:nvPr/>
+        </p:nvSpPr>
+        <p:spPr>
+          <a:xfrm>
+            <a:off x="8366760" y="4453128"/>
+            <a:ext cx="3291840" cy="457200"/>
+          </a:xfrm>
+          <a:prstGeom prst="rect">
+            <a:avLst/>
+          </a:prstGeom>
+          <a:noFill/>
+          <a:ln/>
+        </p:spPr>
+        <p:txBody>
+          <a:bodyPr wrap="square" lIns="0" tIns="0" rIns="0" bIns="0" rtlCol="0" anchor="t"/>
+          <a:lstStyle/>
+          <a:p>
+            <a:pPr indent="0" marL="0">
+              <a:buNone/>
+            </a:pPr>
+            <a:r>
+              <a:rPr lang="en-US" sz="2200" b="1" dirty="0">
+                <a:solidFill>
+                  <a:srgbClr val="E67E22"/>
+                </a:solidFill>
+                <a:latin typeface="Arial" pitchFamily="34" charset="0"/>
+                <a:ea typeface="Arial" pitchFamily="34" charset="-122"/>
+                <a:cs typeface="Arial" pitchFamily="34" charset="-120"/>
+              </a:rPr>
+              <a:t>99.0%</a:t>
+            </a:r>
+            <a:endParaRPr lang="en-US" sz="2200" dirty="0"/>
+          </a:p>
+        </p:txBody>
+      </p:sp>
+      <p:sp>
+        <p:nvSpPr>
+          <p:cNvPr id="26" name="Text 23"/>
+          <p:cNvSpPr txBox="1"/>
+          <p:nvPr/>
+        </p:nvSpPr>
+        <p:spPr>
+          <a:xfrm>
+            <a:off x="8366760" y="4910328"/>
+            <a:ext cx="3291840" cy="365760"/>
+          </a:xfrm>
+          <a:prstGeom prst="rect">
+            <a:avLst/>
+          </a:prstGeom>
+          <a:noFill/>
+          <a:ln/>
+        </p:spPr>
+        <p:txBody>
+          <a:bodyPr wrap="square" lIns="0" tIns="0" rIns="0" bIns="0" rtlCol="0" anchor="t"/>
+          <a:lstStyle/>
+          <a:p>
+            <a:pPr indent="0" marL="0">
+              <a:buNone/>
+            </a:pPr>
+            <a:r>
+              <a:rPr lang="en-US" sz="950" dirty="0">
+                <a:solidFill>
+                  <a:srgbClr val="595959"/>
+                </a:solidFill>
+                <a:latin typeface="Arial" pitchFamily="34" charset="0"/>
+                <a:ea typeface="Arial" pitchFamily="34" charset="-122"/>
+                <a:cs typeface="Arial" pitchFamily="34" charset="-120"/>
+              </a:rPr>
+              <a:t>Chance of ending at or above the USD 70,000 target</a:t>
+            </a:r>
+            <a:endParaRPr lang="en-US" sz="950" dirty="0"/>
+          </a:p>
+        </p:txBody>
+      </p:sp>
+      <p:sp>
+        <p:nvSpPr>
+          <p:cNvPr id="27" name="Shape 24"/>
+          <p:cNvSpPr/>
+          <p:nvPr/>
+        </p:nvSpPr>
+        <p:spPr>
+          <a:xfrm>
+            <a:off x="457200" y="5577840"/>
+            <a:ext cx="11274552" cy="457200"/>
+          </a:xfrm>
+          <a:prstGeom prst="rect">
+            <a:avLst/>
+          </a:prstGeom>
+          <a:solidFill>
+            <a:srgbClr val="2C5F82"/>
+          </a:solidFill>
+          <a:ln w="12700">
+            <a:solidFill>
+              <a:srgbClr val="2C5F82"/>
+            </a:solidFill>
+            <a:prstDash val="solid"/>
+          </a:ln>
+        </p:spPr>
+      </p:sp>
+      <p:sp>
+        <p:nvSpPr>
+          <p:cNvPr id="28" name="Text 25"/>
+          <p:cNvSpPr txBox="1"/>
+          <p:nvPr/>
+        </p:nvSpPr>
+        <p:spPr>
+          <a:xfrm>
+            <a:off x="594360" y="5577840"/>
+            <a:ext cx="11000232" cy="457200"/>
+          </a:xfrm>
+          <a:prstGeom prst="rect">
+            <a:avLst/>
+          </a:prstGeom>
+          <a:noFill/>
+          <a:ln/>
+        </p:spPr>
+        <p:txBody>
+          <a:bodyPr wrap="square" lIns="0" tIns="0" rIns="0" bIns="0" rtlCol="0" anchor="ctr"/>
+          <a:lstStyle/>
+          <a:p>
+            <a:pPr algn="ctr" indent="0" marL="0">
+              <a:buNone/>
+            </a:pPr>
+            <a:r>
+              <a:rPr lang="en-US" sz="1200" b="1" dirty="0">
+                <a:solidFill>
+                  <a:srgbClr val="FFFFFF"/>
+                </a:solidFill>
+                <a:latin typeface="Arial" pitchFamily="34" charset="0"/>
+                <a:ea typeface="Arial" pitchFamily="34" charset="-122"/>
+                <a:cs typeface="Arial" pitchFamily="34" charset="-120"/>
+              </a:rPr>
+              <a:t>Even the bearish path ends above the start ($103.6k); the USD 70,000 target is the 1st percentile</a:t>
+            </a:r>
+            <a:endParaRPr lang="en-US" sz="1200" dirty="0"/>
+          </a:p>
+        </p:txBody>
+      </p:sp>
+      <p:sp>
+        <p:nvSpPr>
+          <p:cNvPr id="29" name="Text 26"/>
+          <p:cNvSpPr txBox="1"/>
+          <p:nvPr/>
+        </p:nvSpPr>
+        <p:spPr>
+          <a:xfrm>
+            <a:off x="457200" y="6089904"/>
+            <a:ext cx="11274552" cy="256032"/>
+          </a:xfrm>
+          <a:prstGeom prst="rect">
+            <a:avLst/>
+          </a:prstGeom>
+          <a:noFill/>
+          <a:ln/>
+        </p:spPr>
+        <p:txBody>
+          <a:bodyPr wrap="square" lIns="0" tIns="0" rIns="0" bIns="0" rtlCol="0" anchor="t"/>
+          <a:lstStyle/>
+          <a:p>
+            <a:pPr indent="0" marL="0">
+              <a:buNone/>
+            </a:pPr>
+            <a:r>
+              <a:rPr lang="en-US" sz="800" i="1" dirty="0">
+                <a:solidFill>
+                  <a:srgbClr val="595959"/>
+                </a:solidFill>
+                <a:latin typeface="Arial" pitchFamily="34" charset="0"/>
+                <a:ea typeface="Arial" pitchFamily="34" charset="-122"/>
+                <a:cs typeface="Arial" pitchFamily="34" charset="-120"/>
+              </a:rPr>
+              <a:t>Source: team Monte Carlo app (annual checkpoints of the simulated paths). Lines connect the yearly values. Results depend on the app's return and volatility inputs; refresh with Bloomberg data at the 17 Sep 2026 trade date.</a:t>
+            </a:r>
+            <a:endParaRPr lang="en-US" sz="800" dirty="0"/>
+          </a:p>
+        </p:txBody>
+      </p:sp>
+    </p:spTree>
+  </p:cSld>
+  <p:clrMapOvr>
+    <a:masterClrMapping/>
+  </p:clrMapOvr>
+</p:sld>
+</file>
+
+<file path=ppt/slides/slide3.xml><?xml version="1.0" encoding="utf-8"?>
+<p:sld xmlns:a="http://schemas.openxmlformats.org/drawingml/2006/main" xmlns:r="http://schemas.openxmlformats.org/officeDocument/2006/relationships" xmlns:p="http://schemas.openxmlformats.org/presentationml/2006/main">
+  <p:cSld name="Slide 3">
+    <p:bg>
+      <p:bgPr>
+        <a:solidFill>
+          <a:srgbClr val="FFFFFF"/>
+        </a:solidFill>
+      </p:bgPr>
+    </p:bg>
+    <p:spTree>
+      <p:nvGrpSpPr>
+        <p:cNvPr id="1" name=""/>
+        <p:cNvGrpSpPr/>
+        <p:nvPr/>
+      </p:nvGrpSpPr>
+      <p:grpSpPr>
+        <a:xfrm>
+          <a:off x="0" y="0"/>
+          <a:ext cx="0" cy="0"/>
+          <a:chOff x="0" y="0"/>
+          <a:chExt cx="0" cy="0"/>
+        </a:xfrm>
+      </p:grpSpPr>
+      <p:sp>
+        <p:nvSpPr>
+          <p:cNvPr id="2" name="Text 0"/>
+          <p:cNvSpPr txBox="1"/>
+          <p:nvPr/>
+        </p:nvSpPr>
+        <p:spPr>
+          <a:xfrm>
+            <a:off x="457200" y="274320"/>
+            <a:ext cx="11247120" cy="548640"/>
+          </a:xfrm>
+          <a:prstGeom prst="rect">
+            <a:avLst/>
+          </a:prstGeom>
+          <a:noFill/>
+          <a:ln/>
+        </p:spPr>
+        <p:txBody>
+          <a:bodyPr wrap="square" lIns="0" tIns="0" rIns="0" bIns="0" rtlCol="0" anchor="ctr"/>
+          <a:lstStyle/>
+          <a:p>
+            <a:pPr indent="0" marL="0">
+              <a:buNone/>
+            </a:pPr>
+            <a:r>
+              <a:rPr lang="en-US" sz="2200" dirty="0">
+                <a:solidFill>
+                  <a:srgbClr val="262626"/>
+                </a:solidFill>
+                <a:latin typeface="Arial" pitchFamily="34" charset="0"/>
+                <a:ea typeface="Arial" pitchFamily="34" charset="-122"/>
+                <a:cs typeface="Arial" pitchFamily="34" charset="-120"/>
+              </a:rPr>
+              <a:t>Annual checkpoints: the downside stays above the USD 70,000 target</a:t>
+            </a:r>
+            <a:endParaRPr lang="en-US" sz="2200" dirty="0"/>
+          </a:p>
+        </p:txBody>
+      </p:sp>
+      <p:sp>
+        <p:nvSpPr>
+          <p:cNvPr id="3" name="Shape 1"/>
+          <p:cNvSpPr/>
+          <p:nvPr/>
+        </p:nvSpPr>
+        <p:spPr>
+          <a:xfrm>
+            <a:off x="457200" y="896112"/>
+            <a:ext cx="11274552" cy="0"/>
+          </a:xfrm>
+          <a:prstGeom prst="line">
+            <a:avLst/>
+          </a:prstGeom>
+          <a:noFill/>
+          <a:ln w="12700">
+            <a:solidFill>
+              <a:srgbClr val="2C5F82"/>
+            </a:solidFill>
+            <a:prstDash val="solid"/>
+          </a:ln>
+        </p:spPr>
+      </p:sp>
+      <p:sp>
+        <p:nvSpPr>
+          <p:cNvPr id="4" name="Shape 2"/>
+          <p:cNvSpPr/>
+          <p:nvPr/>
+        </p:nvSpPr>
+        <p:spPr>
+          <a:xfrm>
+            <a:off x="457200" y="6382512"/>
+            <a:ext cx="11274552" cy="0"/>
+          </a:xfrm>
+          <a:prstGeom prst="line">
+            <a:avLst/>
+          </a:prstGeom>
+          <a:noFill/>
+          <a:ln w="9525">
+            <a:solidFill>
+              <a:srgbClr val="BFBFBF"/>
+            </a:solidFill>
+            <a:prstDash val="solid"/>
+          </a:ln>
+        </p:spPr>
+      </p:sp>
+      <p:sp>
+        <p:nvSpPr>
+          <p:cNvPr id="5" name="Text 3"/>
+          <p:cNvSpPr txBox="1"/>
+          <p:nvPr/>
+        </p:nvSpPr>
+        <p:spPr>
+          <a:xfrm>
+            <a:off x="457200" y="6446520"/>
+            <a:ext cx="3611880" cy="274320"/>
+          </a:xfrm>
+          <a:prstGeom prst="rect">
+            <a:avLst/>
+          </a:prstGeom>
+          <a:noFill/>
+          <a:ln/>
+        </p:spPr>
+        <p:txBody>
+          <a:bodyPr wrap="square" lIns="0" tIns="0" rIns="0" bIns="0" rtlCol="0" anchor="t"/>
+          <a:lstStyle/>
+          <a:p>
+            <a:pPr algn="ctr" indent="0" marL="0">
+              <a:buNone/>
+            </a:pPr>
+            <a:r>
+              <a:rPr lang="en-US" sz="1200" spc="100" kern="0" dirty="0">
+                <a:solidFill>
+                  <a:srgbClr val="595959"/>
+                </a:solidFill>
+                <a:latin typeface="Arial" pitchFamily="34" charset="0"/>
+                <a:ea typeface="Arial" pitchFamily="34" charset="-122"/>
+                <a:cs typeface="Arial" pitchFamily="34" charset="-120"/>
+              </a:rPr>
+              <a:t>ANALYSIS</a:t>
+            </a:r>
+            <a:endParaRPr lang="en-US" sz="1200" dirty="0"/>
+          </a:p>
+        </p:txBody>
+      </p:sp>
+      <p:sp>
+        <p:nvSpPr>
+          <p:cNvPr id="6" name="Shape 4"/>
+          <p:cNvSpPr/>
+          <p:nvPr/>
+        </p:nvSpPr>
+        <p:spPr>
+          <a:xfrm>
+            <a:off x="4837176" y="6364224"/>
+            <a:ext cx="2514600" cy="45720"/>
+          </a:xfrm>
+          <a:prstGeom prst="rect">
+            <a:avLst/>
+          </a:prstGeom>
+          <a:solidFill>
+            <a:srgbClr val="2C5F82"/>
+          </a:solidFill>
+          <a:ln w="12700">
+            <a:solidFill>
+              <a:srgbClr val="2C5F82"/>
+            </a:solidFill>
+            <a:prstDash val="solid"/>
+          </a:ln>
+        </p:spPr>
+      </p:sp>
+      <p:sp>
+        <p:nvSpPr>
+          <p:cNvPr id="7" name="Text 5"/>
+          <p:cNvSpPr txBox="1"/>
+          <p:nvPr/>
+        </p:nvSpPr>
+        <p:spPr>
+          <a:xfrm>
+            <a:off x="4288536" y="6446520"/>
+            <a:ext cx="3611880" cy="274320"/>
+          </a:xfrm>
+          <a:prstGeom prst="rect">
+            <a:avLst/>
+          </a:prstGeom>
+          <a:noFill/>
+          <a:ln/>
+        </p:spPr>
+        <p:txBody>
+          <a:bodyPr wrap="square" lIns="0" tIns="0" rIns="0" bIns="0" rtlCol="0" anchor="t"/>
+          <a:lstStyle/>
+          <a:p>
+            <a:pPr algn="ctr" indent="0" marL="0">
+              <a:buNone/>
+            </a:pPr>
+            <a:r>
+              <a:rPr lang="en-US" sz="1200" b="1" spc="100" kern="0" dirty="0">
+                <a:solidFill>
+                  <a:srgbClr val="2C5F82"/>
+                </a:solidFill>
+                <a:latin typeface="Arial" pitchFamily="34" charset="0"/>
+                <a:ea typeface="Arial" pitchFamily="34" charset="-122"/>
+                <a:cs typeface="Arial" pitchFamily="34" charset="-120"/>
+              </a:rPr>
+              <a:t>STRATEGY</a:t>
+            </a:r>
+            <a:endParaRPr lang="en-US" sz="1200" dirty="0"/>
+          </a:p>
+        </p:txBody>
+      </p:sp>
+      <p:sp>
+        <p:nvSpPr>
+          <p:cNvPr id="8" name="Text 6"/>
+          <p:cNvSpPr txBox="1"/>
+          <p:nvPr/>
+        </p:nvSpPr>
+        <p:spPr>
+          <a:xfrm>
+            <a:off x="8129016" y="6446520"/>
+            <a:ext cx="3611880" cy="274320"/>
+          </a:xfrm>
+          <a:prstGeom prst="rect">
+            <a:avLst/>
+          </a:prstGeom>
+          <a:noFill/>
+          <a:ln/>
+        </p:spPr>
+        <p:txBody>
+          <a:bodyPr wrap="square" lIns="0" tIns="0" rIns="0" bIns="0" rtlCol="0" anchor="t"/>
+          <a:lstStyle/>
+          <a:p>
+            <a:pPr algn="ctr" indent="0" marL="0">
+              <a:buNone/>
+            </a:pPr>
+            <a:r>
+              <a:rPr lang="en-US" sz="1200" spc="100" kern="0" dirty="0">
+                <a:solidFill>
+                  <a:srgbClr val="595959"/>
+                </a:solidFill>
+                <a:latin typeface="Arial" pitchFamily="34" charset="0"/>
+                <a:ea typeface="Arial" pitchFamily="34" charset="-122"/>
+                <a:cs typeface="Arial" pitchFamily="34" charset="-120"/>
+              </a:rPr>
+              <a:t>APPENDIX</a:t>
+            </a:r>
+            <a:endParaRPr lang="en-US" sz="1200" dirty="0"/>
+          </a:p>
+        </p:txBody>
+      </p:sp>
+      <p:sp>
+        <p:nvSpPr>
+          <p:cNvPr id="9" name="Text 7"/>
+          <p:cNvSpPr txBox="1"/>
+          <p:nvPr/>
+        </p:nvSpPr>
+        <p:spPr>
+          <a:xfrm>
+            <a:off x="457200" y="969264"/>
+            <a:ext cx="11274552" cy="274320"/>
+          </a:xfrm>
+          <a:prstGeom prst="rect">
+            <a:avLst/>
+          </a:prstGeom>
+          <a:noFill/>
+          <a:ln/>
+        </p:spPr>
+        <p:txBody>
+          <a:bodyPr wrap="square" lIns="0" tIns="0" rIns="0" bIns="0" rtlCol="0" anchor="t"/>
+          <a:lstStyle/>
+          <a:p>
+            <a:pPr indent="0" marL="0">
+              <a:buNone/>
+            </a:pPr>
+            <a:r>
+              <a:rPr lang="en-US" sz="1100" i="1" dirty="0">
+                <a:solidFill>
+                  <a:srgbClr val="595959"/>
+                </a:solidFill>
+                <a:latin typeface="Arial" pitchFamily="34" charset="0"/>
+                <a:ea typeface="Arial" pitchFamily="34" charset="-122"/>
+                <a:cs typeface="Arial" pitchFamily="34" charset="-120"/>
+              </a:rPr>
               <a:t>Simulated portfolio value at each year-end, per USD 100,000 invested</a:t>
             </a:r>
             <a:endParaRPr lang="en-US" sz="1100" dirty="0"/>
@@ -4137,7 +4999,7 @@
       </p:sp>
       <p:graphicFrame>
         <p:nvGraphicFramePr>
-          <p:cNvPr id="3" name="Table 0"/>
+          <p:cNvPr id="4" name="Table 0"/>
           <p:cNvGraphicFramePr>
             <a:graphicFrameLocks noGrp="1"/>
           </p:cNvGraphicFramePr>

</xml_diff>

<commit_message>
Strategy slide 1: explain the basket with the red star on the risk/return chart
Co-Authored-By: Claude Opus 5.5 <noreply@anthropic.com>
Claude-Session: https://claude.ai/code/session_01Rwoh8cFDQqLD8JWT3mee6y
</commit_message>
<xml_diff>
--- a/strategy/Strategy-Slides.pptx
+++ b/strategy/Strategy-Slides.pptx
@@ -1396,7 +1396,7 @@
                 <a:ea typeface="Arial" pitchFamily="34" charset="-122"/>
                 <a:cs typeface="Arial" pitchFamily="34" charset="-120"/>
               </a:rPr>
-              <a:t>Strategy: five Asian AI-hardware ETFs, combined to cut risk</a:t>
+              <a:t>Strategy: our five-ETF basket sits at the low-risk edge of every possible mix</a:t>
             </a:r>
             <a:endParaRPr lang="en-US" sz="2200" dirty="0"/>
           </a:p>
@@ -1623,7 +1623,7 @@
                 <a:ea typeface="Arial" pitchFamily="34" charset="-122"/>
                 <a:cs typeface="Arial" pitchFamily="34" charset="-120"/>
               </a:rPr>
-              <a:t>USD 100mn across five Bloomberg-listed ETFs; mixing them gives most of the return with less volatility than the riskiest funds</a:t>
+              <a:t>USD 100mn across five Bloomberg-listed ETFs; our weights (red star) deliver ~26% expected return for only ~17% volatility</a:t>
             </a:r>
             <a:endParaRPr lang="en-US" sz="1100" dirty="0"/>
           </a:p>
@@ -3429,6 +3429,43 @@
                 <a:cs typeface="Arial" pitchFamily="34" charset="-120"/>
               </a:rPr>
               <a:t>each ETF on its own (2644 is the dot near 0.26, 0.25).</a:t>
+            </a:r>
+            <a:endParaRPr lang="en-US" sz="900" dirty="0"/>
+          </a:p>
+          <a:p>
+            <a:pPr indent="0" marL="0">
+              <a:spcAft>
+                <a:spcPts val="300"/>
+              </a:spcAft>
+              <a:buNone/>
+            </a:pPr>
+            <a:r>
+              <a:rPr lang="en-US" sz="900" b="1" dirty="0">
+                <a:solidFill>
+                  <a:srgbClr val="C0392B"/>
+                </a:solidFill>
+                <a:latin typeface="Arial" pitchFamily="34" charset="0"/>
+                <a:ea typeface="Arial" pitchFamily="34" charset="-122"/>
+                <a:cs typeface="Arial" pitchFamily="34" charset="-120"/>
+              </a:rPr>
+              <a:t>Red star: </a:t>
+            </a:r>
+            <a:pPr indent="0" marL="0">
+              <a:spcAft>
+                <a:spcPts val="300"/>
+              </a:spcAft>
+              <a:buNone/>
+            </a:pPr>
+            <a:r>
+              <a:rPr lang="en-US" sz="900" dirty="0">
+                <a:solidFill>
+                  <a:srgbClr val="262626"/>
+                </a:solidFill>
+                <a:latin typeface="Arial" pitchFamily="34" charset="0"/>
+                <a:ea typeface="Arial" pitchFamily="34" charset="-122"/>
+                <a:cs typeface="Arial" pitchFamily="34" charset="-120"/>
+              </a:rPr>
+              <a:t>our basket (35 / 20 / 15 / 15 / 15).</a:t>
             </a:r>
             <a:endParaRPr lang="en-US" sz="900" dirty="0"/>
           </a:p>
@@ -3590,7 +3627,7 @@
                 <a:ea typeface="Arial" pitchFamily="34" charset="-122"/>
                 <a:cs typeface="Arial" pitchFamily="34" charset="-120"/>
               </a:rPr>
-              <a:t>Mixing cuts risk: most mixes sit at 22–32% volatility, far below EWY (~49%), while still returning 25–28%.</a:t>
+              <a:t>Our basket (red star): ~26% return at ~17% volatility, the lowest risk of all the mixes shown.</a:t>
             </a:r>
             <a:endParaRPr lang="en-US" sz="950" dirty="0"/>
           </a:p>
@@ -3611,7 +3648,7 @@
                 <a:ea typeface="Arial" pitchFamily="34" charset="-122"/>
                 <a:cs typeface="Arial" pitchFamily="34" charset="-120"/>
               </a:rPr>
-              <a:t>3119 HK has the best risk/return on its own, so it gets the largest weight (35%).</a:t>
+              <a:t>Most random mixes need 22–32% volatility for the same 25–28% return: our weights get it with less risk.</a:t>
             </a:r>
             <a:endParaRPr lang="en-US" sz="950" dirty="0"/>
           </a:p>
@@ -3632,7 +3669,7 @@
                 <a:ea typeface="Arial" pitchFamily="34" charset="-122"/>
                 <a:cs typeface="Arial" pitchFamily="34" charset="-120"/>
               </a:rPr>
-              <a:t>EWY is the riskiest for its return, so it is held for memory exposure at 20%, not more.</a:t>
+              <a:t>Less risk than any single ETF, about a third of EWY's (~49%), while giving up only a few points versus EWT's ~31%.</a:t>
             </a:r>
             <a:endParaRPr lang="en-US" sz="950" dirty="0"/>
           </a:p>
@@ -3653,7 +3690,7 @@
                 <a:ea typeface="Arial" pitchFamily="34" charset="-122"/>
                 <a:cs typeface="Arial" pitchFamily="34" charset="-120"/>
               </a:rPr>
-              <a:t>EWT has the highest return (~31%) and 2644 one of the lowest volatilities (~26%): 15% each rounds out the chain.</a:t>
+              <a:t>Why: 3119 HK (35%) anchors the basket; the other four move differently enough to pull risk down.</a:t>
             </a:r>
             <a:endParaRPr lang="en-US" sz="950" dirty="0"/>
           </a:p>
@@ -3717,7 +3754,7 @@
                 <a:ea typeface="Arial" pitchFamily="34" charset="-122"/>
                 <a:cs typeface="Arial" pitchFamily="34" charset="-120"/>
               </a:rPr>
-              <a:t>One theme, five bottlenecks: weighted towards the best risk/return (3119 HK), diversified to keep volatility down</a:t>
+              <a:t>Our basket (red star): ~26% return for ~17% volatility, less risk than any single ETF or random mix</a:t>
             </a:r>
             <a:endParaRPr lang="en-US" sz="1200" dirty="0"/>
           </a:p>
@@ -3756,7 +3793,7 @@
                 <a:ea typeface="Arial" pitchFamily="34" charset="-122"/>
                 <a:cs typeface="Arial" pitchFamily="34" charset="-120"/>
               </a:rPr>
-              <a:t>Risk/return chart: team analysis app (annualised from historical data; red star as marked in the app). Liquidity: 3119 HK is borderline against the USD 5M/day rule, verify on Bloomberg.</a:t>
+              <a:t>Risk/return chart: team analysis app (annualised from historical data; red star = our basket at 35/20/15/15/15; values read from the chart). Liquidity: 3119 HK is borderline against the USD 5M/day rule, verify on Bloomberg.</a:t>
             </a:r>
             <a:endParaRPr lang="en-US" sz="800" dirty="0"/>
           </a:p>

</xml_diff>